<commit_message>
Complete AKKA final submission package
</commit_message>
<xml_diff>
--- a/docs/hackathon/Try-This-Hackathon-Deck.pptx
+++ b/docs/hackathon/Try-This-Hackathon-Deck.pptx
@@ -2,17 +2,21 @@
 <file path=ppt/presentation.xml><?xml version="1.0" encoding="utf-8"?>
 <p:presentation xmlns:p="http://schemas.openxmlformats.org/presentationml/2006/main">
   <p:sldMasterIdLst>
-    <p:sldMasterId xmlns:r="http://schemas.openxmlformats.org/officeDocument/2006/relationships" id="2147483648" r:id="Rb63a0b36c1054a0b"/>
+    <p:sldMasterId xmlns:r="http://schemas.openxmlformats.org/officeDocument/2006/relationships" id="2147483648" r:id="Rcca4ab179ab54665"/>
   </p:sldMasterIdLst>
   <p:notesMasterIdLst>
-    <p:notesMasterId xmlns:r="http://schemas.openxmlformats.org/officeDocument/2006/relationships" r:id="R29862a70759d474e"/>
+    <p:notesMasterId xmlns:r="http://schemas.openxmlformats.org/officeDocument/2006/relationships" r:id="Ra831c50ef89245a3"/>
   </p:notesMasterIdLst>
   <p:sldIdLst>
-    <p:sldId xmlns:r="http://schemas.openxmlformats.org/officeDocument/2006/relationships" id="256" r:id="Rf944065839034fcf"/>
-    <p:sldId xmlns:r="http://schemas.openxmlformats.org/officeDocument/2006/relationships" id="257" r:id="Rb4aa86a987f64e5b"/>
-    <p:sldId xmlns:r="http://schemas.openxmlformats.org/officeDocument/2006/relationships" id="258" r:id="Re437d3974e414dc9"/>
-    <p:sldId xmlns:r="http://schemas.openxmlformats.org/officeDocument/2006/relationships" id="259" r:id="R25cb15c01fc4431c"/>
-    <p:sldId xmlns:r="http://schemas.openxmlformats.org/officeDocument/2006/relationships" id="260" r:id="Rf166b2d600d94838"/>
+    <p:sldId xmlns:r="http://schemas.openxmlformats.org/officeDocument/2006/relationships" id="256" r:id="R646cf0972e0e4099"/>
+    <p:sldId xmlns:r="http://schemas.openxmlformats.org/officeDocument/2006/relationships" id="257" r:id="Rb69aaae1490e4b5e"/>
+    <p:sldId xmlns:r="http://schemas.openxmlformats.org/officeDocument/2006/relationships" id="258" r:id="R55931a51dbb04859"/>
+    <p:sldId xmlns:r="http://schemas.openxmlformats.org/officeDocument/2006/relationships" id="259" r:id="R1d57906e104340d7"/>
+    <p:sldId xmlns:r="http://schemas.openxmlformats.org/officeDocument/2006/relationships" id="260" r:id="Re7cec37891a244f9"/>
+    <p:sldId xmlns:r="http://schemas.openxmlformats.org/officeDocument/2006/relationships" id="261" r:id="Rd98b8a2078ff4e87"/>
+    <p:sldId xmlns:r="http://schemas.openxmlformats.org/officeDocument/2006/relationships" id="262" r:id="R813cc10205034706"/>
+    <p:sldId xmlns:r="http://schemas.openxmlformats.org/officeDocument/2006/relationships" id="263" r:id="R1bfdefec1cb04380"/>
+    <p:sldId xmlns:r="http://schemas.openxmlformats.org/officeDocument/2006/relationships" id="264" r:id="R18a92405822d4d4c"/>
   </p:sldIdLst>
   <p:sldSz cx="12192000" cy="6858000"/>
   <p:notesSz cx="6858000" cy="9144000"/>
@@ -446,7 +450,7 @@
           <a:lstStyle xmlns:a="http://schemas.openxmlformats.org/drawingml/2006/main"/>
           <a:p xmlns:a="http://schemas.openxmlformats.org/drawingml/2006/main">
             <a:r>
-              <a:t>Open with the product promise: Try This helps a family move from ‘what should we do?’ to doing one genuinely playable thing together.</a:t>
+              <a:t>Open with the promise and the founders’ family context.</a:t>
             </a:r>
           </a:p>
           <a:p xmlns:a="http://schemas.openxmlformats.org/drawingml/2006/main">
@@ -461,7 +465,7 @@
           </a:p>
           <a:p xmlns:a="http://schemas.openxmlformats.org/drawingml/2006/main">
             <a:r>
-              <a:t>- Founder and family context supplied by Kumar Sridharamurthy and Lavanya Shirur Sudhakar.</a:t>
+              <a:t>- Founder context supplied by Kumar Sridharamurthy and Lavanya Shirur Sudhakar.</a:t>
             </a:r>
           </a:p>
           <a:p xmlns:a="http://schemas.openxmlformats.org/drawingml/2006/main">
@@ -536,7 +540,7 @@
           <a:lstStyle xmlns:a="http://schemas.openxmlformats.org/drawingml/2006/main"/>
           <a:p xmlns:a="http://schemas.openxmlformats.org/drawingml/2006/main">
             <a:r>
-              <a:t>Tell the family story briefly. The product starts from lived friction: plenty of possible activities, but no energy for browsing and adapting them in the moment.</a:t>
+              <a:t>Tell the personal problem in thirty seconds: the family had ideas, but not the energy to search and adapt one in the moment.</a:t>
             </a:r>
           </a:p>
           <a:p xmlns:a="http://schemas.openxmlformats.org/drawingml/2006/main">
@@ -551,7 +555,7 @@
           </a:p>
           <a:p xmlns:a="http://schemas.openxmlformats.org/drawingml/2006/main">
             <a:r>
-              <a:t>- Founder and family context supplied by Kumar Sridharamurthy and Lavanya Shirur Sudhakar.</a:t>
+              <a:t>- Founder context supplied by Kumar Sridharamurthy and Lavanya Shirur Sudhakar.</a:t>
             </a:r>
           </a:p>
           <a:p xmlns:a="http://schemas.openxmlformats.org/drawingml/2006/main">
@@ -626,7 +630,7 @@
           <a:lstStyle xmlns:a="http://schemas.openxmlformats.org/drawingml/2006/main"/>
           <a:p xmlns:a="http://schemas.openxmlformats.org/drawingml/2006/main">
             <a:r>
-              <a:t>Walk through the screen from top to bottom. The home flow deliberately avoids a catalogue-first experience and gives the parent one clear next action.</a:t>
+              <a:t>Show the working homepage: choose the moment, receive one matched activity, and start with complete instructions.</a:t>
             </a:r>
           </a:p>
           <a:p xmlns:a="http://schemas.openxmlformats.org/drawingml/2006/main">
@@ -641,7 +645,12 @@
           </a:p>
           <a:p xmlns:a="http://schemas.openxmlformats.org/drawingml/2006/main">
             <a:r>
-              <a:t>- User-provided product screenshot: /Users/lavanya/Desktop/screenshots/homepage.png</a:t>
+              <a:t>- Product screenshot: /Users/lavanya/Desktop/screenshots/homepage.png</a:t>
+            </a:r>
+          </a:p>
+          <a:p xmlns:a="http://schemas.openxmlformats.org/drawingml/2006/main">
+            <a:r>
+              <a:t>- Working prototype: https://trythis.fun</a:t>
             </a:r>
           </a:p>
           <a:p xmlns:a="http://schemas.openxmlformats.org/drawingml/2006/main">
@@ -716,7 +725,7 @@
           <a:lstStyle xmlns:a="http://schemas.openxmlformats.org/drawingml/2006/main"/>
           <a:p xmlns:a="http://schemas.openxmlformats.org/drawingml/2006/main">
             <a:r>
-              <a:t>Use Family Guess Who as the proof point. The product is not just a database of titles; each page gives a parent the first line, the rules, and ways to adapt the activity.</a:t>
+              <a:t>Use Oota Yaarige as proof that heritage preservation must include the words, motions, rhythm, and demonstration—not merely a title.</a:t>
             </a:r>
           </a:p>
           <a:p xmlns:a="http://schemas.openxmlformats.org/drawingml/2006/main">
@@ -731,7 +740,12 @@
           </a:p>
           <a:p xmlns:a="http://schemas.openxmlformats.org/drawingml/2006/main">
             <a:r>
-              <a:t>- User-provided product screenshot: /Users/lavanya/Desktop/screenshots/familyGuess.png</a:t>
+              <a:t>- Current Try This Fun product screenshot captured from https://trythis.fun</a:t>
+            </a:r>
+          </a:p>
+          <a:p xmlns:a="http://schemas.openxmlformats.org/drawingml/2006/main">
+            <a:r>
+              <a:t>- Heritage content supplied and demonstrated by the founders’ family.</a:t>
             </a:r>
           </a:p>
           <a:p xmlns:a="http://schemas.openxmlformats.org/drawingml/2006/main">
@@ -806,7 +820,7 @@
           <a:lstStyle xmlns:a="http://schemas.openxmlformats.org/drawingml/2006/main"/>
           <a:p xmlns:a="http://schemas.openxmlformats.org/drawingml/2006/main">
             <a:r>
-              <a:t>Close on the emotional outcome. Invite the audience to try the product at trythis.fun and ask for feedback from families who also struggle with the ‘what should we do?’ moment.</a:t>
+              <a:t>Explain the actual MVP architecture. No runtime LLM or login is required: reviewed content becomes a typed catalog, deterministic constraints create a compatible deck, and the same source feeds web and native apps.</a:t>
             </a:r>
           </a:p>
           <a:p xmlns:a="http://schemas.openxmlformats.org/drawingml/2006/main">
@@ -821,12 +835,377 @@
           </a:p>
           <a:p xmlns:a="http://schemas.openxmlformats.org/drawingml/2006/main">
             <a:r>
-              <a:t>- Product URL supplied by the founders: https://trythis.fun</a:t>
-            </a:r>
-          </a:p>
-          <a:p xmlns:a="http://schemas.openxmlformats.org/drawingml/2006/main">
-            <a:r>
-              <a:t>- Founder names supplied by Kumar Sridharamurthy and Lavanya Shirur Sudhakar.</a:t>
+              <a:t>- Repository architecture: /Users/lavanya/github/Bonding/README.md</a:t>
+            </a:r>
+          </a:p>
+          <a:p xmlns:a="http://schemas.openxmlformats.org/drawingml/2006/main">
+            <a:r>
+              <a:t>- Implementation: /Users/lavanya/github/Bonding/web/components/play-deck.tsx</a:t>
+            </a:r>
+          </a:p>
+          <a:p xmlns:a="http://schemas.openxmlformats.org/drawingml/2006/main">
+            <a:r>
+              <a:t>[/Sources]</a:t>
+            </a:r>
+          </a:p>
+        </p:txBody>
+      </p:sp>
+      <p:sp>
+        <p:nvSpPr>
+          <p:cNvPr id="4" name="Slide Number Placeholder 3"/>
+          <p:cNvSpPr>
+            <a:spLocks xmlns:a="http://schemas.openxmlformats.org/drawingml/2006/main" noGrp="1"/>
+          </p:cNvSpPr>
+          <p:nvPr>
+            <p:ph type="sldNum" idx="5"/>
+          </p:nvPr>
+        </p:nvSpPr>
+        <p:spPr/>
+        <p:txBody>
+          <a:bodyPr xmlns:a="http://schemas.openxmlformats.org/drawingml/2006/main"/>
+          <a:lstStyle xmlns:a="http://schemas.openxmlformats.org/drawingml/2006/main"/>
+          <a:p xmlns:a="http://schemas.openxmlformats.org/drawingml/2006/main"/>
+        </p:txBody>
+      </p:sp>
+    </p:spTree>
+  </p:cSld>
+  <p:clrMapOvr>
+    <a:masterClrMapping xmlns:a="http://schemas.openxmlformats.org/drawingml/2006/main"/>
+  </p:clrMapOvr>
+</p:notes>
+</file>
+
+<file path=ppt/notesSlides/notesSlide6.xml><?xml version="1.0" encoding="utf-8"?>
+<p:notes xmlns:p="http://schemas.openxmlformats.org/presentationml/2006/main">
+  <p:cSld>
+    <p:spTree>
+      <p:nvGrpSpPr>
+        <p:cNvPr id="1" name=""/>
+        <p:cNvGrpSpPr/>
+        <p:nvPr/>
+      </p:nvGrpSpPr>
+      <p:grpSpPr>
+        <a:xfrm xmlns:a="http://schemas.openxmlformats.org/drawingml/2006/main"/>
+      </p:grpSpPr>
+      <p:sp>
+        <p:nvSpPr>
+          <p:cNvPr id="2" name="Slide Image Placeholder 1"/>
+          <p:cNvSpPr>
+            <a:spLocks xmlns:a="http://schemas.openxmlformats.org/drawingml/2006/main" noGrp="1"/>
+          </p:cNvSpPr>
+          <p:nvPr>
+            <p:ph type="sldImg" idx="0"/>
+          </p:nvPr>
+        </p:nvSpPr>
+        <p:spPr/>
+      </p:sp>
+      <p:sp>
+        <p:nvSpPr>
+          <p:cNvPr id="3" name="Notes Placeholder 2"/>
+          <p:cNvSpPr>
+            <a:spLocks xmlns:a="http://schemas.openxmlformats.org/drawingml/2006/main" noGrp="1"/>
+          </p:cNvSpPr>
+          <p:nvPr>
+            <p:ph type="body" idx="1"/>
+          </p:nvPr>
+        </p:nvSpPr>
+        <p:spPr/>
+        <p:txBody>
+          <a:bodyPr xmlns:a="http://schemas.openxmlformats.org/drawingml/2006/main"/>
+          <a:lstStyle xmlns:a="http://schemas.openxmlformats.org/drawingml/2006/main"/>
+          <a:p xmlns:a="http://schemas.openxmlformats.org/drawingml/2006/main">
+            <a:r>
+              <a:t>Technical depth is concentrated in content engineering, schema normalization, shared adapters, fallback logic, randomization, media optimization, and source provenance.</a:t>
+            </a:r>
+          </a:p>
+          <a:p xmlns:a="http://schemas.openxmlformats.org/drawingml/2006/main">
+            <a:r>
+              <a:t/>
+            </a:r>
+          </a:p>
+          <a:p xmlns:a="http://schemas.openxmlformats.org/drawingml/2006/main">
+            <a:r>
+              <a:t>[Sources]</a:t>
+            </a:r>
+          </a:p>
+          <a:p xmlns:a="http://schemas.openxmlformats.org/drawingml/2006/main">
+            <a:r>
+              <a:t>- Shared catalog implementation: /Users/lavanya/github/Bonding/web/lib/catalog.ts</a:t>
+            </a:r>
+          </a:p>
+          <a:p xmlns:a="http://schemas.openxmlformats.org/drawingml/2006/main">
+            <a:r>
+              <a:t>- Source playbooks: /Users/lavanya/github/Bonding/src/data/source-ideas.ts</a:t>
+            </a:r>
+          </a:p>
+          <a:p xmlns:a="http://schemas.openxmlformats.org/drawingml/2006/main">
+            <a:r>
+              <a:t>[/Sources]</a:t>
+            </a:r>
+          </a:p>
+        </p:txBody>
+      </p:sp>
+      <p:sp>
+        <p:nvSpPr>
+          <p:cNvPr id="4" name="Slide Number Placeholder 3"/>
+          <p:cNvSpPr>
+            <a:spLocks xmlns:a="http://schemas.openxmlformats.org/drawingml/2006/main" noGrp="1"/>
+          </p:cNvSpPr>
+          <p:nvPr>
+            <p:ph type="sldNum" idx="5"/>
+          </p:nvPr>
+        </p:nvSpPr>
+        <p:spPr/>
+        <p:txBody>
+          <a:bodyPr xmlns:a="http://schemas.openxmlformats.org/drawingml/2006/main"/>
+          <a:lstStyle xmlns:a="http://schemas.openxmlformats.org/drawingml/2006/main"/>
+          <a:p xmlns:a="http://schemas.openxmlformats.org/drawingml/2006/main"/>
+        </p:txBody>
+      </p:sp>
+    </p:spTree>
+  </p:cSld>
+  <p:clrMapOvr>
+    <a:masterClrMapping xmlns:a="http://schemas.openxmlformats.org/drawingml/2006/main"/>
+  </p:clrMapOvr>
+</p:notes>
+</file>
+
+<file path=ppt/notesSlides/notesSlide7.xml><?xml version="1.0" encoding="utf-8"?>
+<p:notes xmlns:p="http://schemas.openxmlformats.org/presentationml/2006/main">
+  <p:cSld>
+    <p:spTree>
+      <p:nvGrpSpPr>
+        <p:cNvPr id="1" name=""/>
+        <p:cNvGrpSpPr/>
+        <p:nvPr/>
+      </p:nvGrpSpPr>
+      <p:grpSpPr>
+        <a:xfrm xmlns:a="http://schemas.openxmlformats.org/drawingml/2006/main"/>
+      </p:grpSpPr>
+      <p:sp>
+        <p:nvSpPr>
+          <p:cNvPr id="2" name="Slide Image Placeholder 1"/>
+          <p:cNvSpPr>
+            <a:spLocks xmlns:a="http://schemas.openxmlformats.org/drawingml/2006/main" noGrp="1"/>
+          </p:cNvSpPr>
+          <p:nvPr>
+            <p:ph type="sldImg" idx="0"/>
+          </p:nvPr>
+        </p:nvSpPr>
+        <p:spPr/>
+      </p:sp>
+      <p:sp>
+        <p:nvSpPr>
+          <p:cNvPr id="3" name="Notes Placeholder 2"/>
+          <p:cNvSpPr>
+            <a:spLocks xmlns:a="http://schemas.openxmlformats.org/drawingml/2006/main" noGrp="1"/>
+          </p:cNvSpPr>
+          <p:nvPr>
+            <p:ph type="body" idx="1"/>
+          </p:nvPr>
+        </p:nvSpPr>
+        <p:spPr/>
+        <p:txBody>
+          <a:bodyPr xmlns:a="http://schemas.openxmlformats.org/drawingml/2006/main"/>
+          <a:lstStyle xmlns:a="http://schemas.openxmlformats.org/drawingml/2006/main"/>
+          <a:p xmlns:a="http://schemas.openxmlformats.org/drawingml/2006/main">
+            <a:r>
+              <a:t>Present the commercial model as a hypothesis to validate: a free starter product followed by a single family unlock and institutional collection partnerships.</a:t>
+            </a:r>
+          </a:p>
+          <a:p xmlns:a="http://schemas.openxmlformats.org/drawingml/2006/main">
+            <a:r>
+              <a:t/>
+            </a:r>
+          </a:p>
+          <a:p xmlns:a="http://schemas.openxmlformats.org/drawingml/2006/main">
+            <a:r>
+              <a:t>[Sources]</a:t>
+            </a:r>
+          </a:p>
+          <a:p xmlns:a="http://schemas.openxmlformats.org/drawingml/2006/main">
+            <a:r>
+              <a:t>- Product strategy: /Users/lavanya/github/Bonding/docs/DEVFOLIO_SUBMISSION.md</a:t>
+            </a:r>
+          </a:p>
+          <a:p xmlns:a="http://schemas.openxmlformats.org/drawingml/2006/main">
+            <a:r>
+              <a:t>[/Sources]</a:t>
+            </a:r>
+          </a:p>
+        </p:txBody>
+      </p:sp>
+      <p:sp>
+        <p:nvSpPr>
+          <p:cNvPr id="4" name="Slide Number Placeholder 3"/>
+          <p:cNvSpPr>
+            <a:spLocks xmlns:a="http://schemas.openxmlformats.org/drawingml/2006/main" noGrp="1"/>
+          </p:cNvSpPr>
+          <p:nvPr>
+            <p:ph type="sldNum" idx="5"/>
+          </p:nvPr>
+        </p:nvSpPr>
+        <p:spPr/>
+        <p:txBody>
+          <a:bodyPr xmlns:a="http://schemas.openxmlformats.org/drawingml/2006/main"/>
+          <a:lstStyle xmlns:a="http://schemas.openxmlformats.org/drawingml/2006/main"/>
+          <a:p xmlns:a="http://schemas.openxmlformats.org/drawingml/2006/main"/>
+        </p:txBody>
+      </p:sp>
+    </p:spTree>
+  </p:cSld>
+  <p:clrMapOvr>
+    <a:masterClrMapping xmlns:a="http://schemas.openxmlformats.org/drawingml/2006/main"/>
+  </p:clrMapOvr>
+</p:notes>
+</file>
+
+<file path=ppt/notesSlides/notesSlide8.xml><?xml version="1.0" encoding="utf-8"?>
+<p:notes xmlns:p="http://schemas.openxmlformats.org/presentationml/2006/main">
+  <p:cSld>
+    <p:spTree>
+      <p:nvGrpSpPr>
+        <p:cNvPr id="1" name=""/>
+        <p:cNvGrpSpPr/>
+        <p:nvPr/>
+      </p:nvGrpSpPr>
+      <p:grpSpPr>
+        <a:xfrm xmlns:a="http://schemas.openxmlformats.org/drawingml/2006/main"/>
+      </p:grpSpPr>
+      <p:sp>
+        <p:nvSpPr>
+          <p:cNvPr id="2" name="Slide Image Placeholder 1"/>
+          <p:cNvSpPr>
+            <a:spLocks xmlns:a="http://schemas.openxmlformats.org/drawingml/2006/main" noGrp="1"/>
+          </p:cNvSpPr>
+          <p:nvPr>
+            <p:ph type="sldImg" idx="0"/>
+          </p:nvPr>
+        </p:nvSpPr>
+        <p:spPr/>
+      </p:sp>
+      <p:sp>
+        <p:nvSpPr>
+          <p:cNvPr id="3" name="Notes Placeholder 2"/>
+          <p:cNvSpPr>
+            <a:spLocks xmlns:a="http://schemas.openxmlformats.org/drawingml/2006/main" noGrp="1"/>
+          </p:cNvSpPr>
+          <p:nvPr>
+            <p:ph type="body" idx="1"/>
+          </p:nvPr>
+        </p:nvSpPr>
+        <p:spPr/>
+        <p:txBody>
+          <a:bodyPr xmlns:a="http://schemas.openxmlformats.org/drawingml/2006/main"/>
+          <a:lstStyle xmlns:a="http://schemas.openxmlformats.org/drawingml/2006/main"/>
+          <a:p xmlns:a="http://schemas.openxmlformats.org/drawingml/2006/main">
+            <a:r>
+              <a:t>The six-month roadmap includes opt-in outcome learning, reviewed heritage expansion, and production launches on both the iOS App Store and Android Play Store with a one-time unlock.</a:t>
+            </a:r>
+          </a:p>
+          <a:p xmlns:a="http://schemas.openxmlformats.org/drawingml/2006/main">
+            <a:r>
+              <a:t/>
+            </a:r>
+          </a:p>
+          <a:p xmlns:a="http://schemas.openxmlformats.org/drawingml/2006/main">
+            <a:r>
+              <a:t>[Sources]</a:t>
+            </a:r>
+          </a:p>
+          <a:p xmlns:a="http://schemas.openxmlformats.org/drawingml/2006/main">
+            <a:r>
+              <a:t>- Product roadmap: /Users/lavanya/github/Bonding/README.md</a:t>
+            </a:r>
+          </a:p>
+          <a:p xmlns:a="http://schemas.openxmlformats.org/drawingml/2006/main">
+            <a:r>
+              <a:t>[/Sources]</a:t>
+            </a:r>
+          </a:p>
+        </p:txBody>
+      </p:sp>
+      <p:sp>
+        <p:nvSpPr>
+          <p:cNvPr id="4" name="Slide Number Placeholder 3"/>
+          <p:cNvSpPr>
+            <a:spLocks xmlns:a="http://schemas.openxmlformats.org/drawingml/2006/main" noGrp="1"/>
+          </p:cNvSpPr>
+          <p:nvPr>
+            <p:ph type="sldNum" idx="5"/>
+          </p:nvPr>
+        </p:nvSpPr>
+        <p:spPr/>
+        <p:txBody>
+          <a:bodyPr xmlns:a="http://schemas.openxmlformats.org/drawingml/2006/main"/>
+          <a:lstStyle xmlns:a="http://schemas.openxmlformats.org/drawingml/2006/main"/>
+          <a:p xmlns:a="http://schemas.openxmlformats.org/drawingml/2006/main"/>
+        </p:txBody>
+      </p:sp>
+    </p:spTree>
+  </p:cSld>
+  <p:clrMapOvr>
+    <a:masterClrMapping xmlns:a="http://schemas.openxmlformats.org/drawingml/2006/main"/>
+  </p:clrMapOvr>
+</p:notes>
+</file>
+
+<file path=ppt/notesSlides/notesSlide9.xml><?xml version="1.0" encoding="utf-8"?>
+<p:notes xmlns:p="http://schemas.openxmlformats.org/presentationml/2006/main">
+  <p:cSld>
+    <p:spTree>
+      <p:nvGrpSpPr>
+        <p:cNvPr id="1" name=""/>
+        <p:cNvGrpSpPr/>
+        <p:nvPr/>
+      </p:nvGrpSpPr>
+      <p:grpSpPr>
+        <a:xfrm xmlns:a="http://schemas.openxmlformats.org/drawingml/2006/main"/>
+      </p:grpSpPr>
+      <p:sp>
+        <p:nvSpPr>
+          <p:cNvPr id="2" name="Slide Image Placeholder 1"/>
+          <p:cNvSpPr>
+            <a:spLocks xmlns:a="http://schemas.openxmlformats.org/drawingml/2006/main" noGrp="1"/>
+          </p:cNvSpPr>
+          <p:nvPr>
+            <p:ph type="sldImg" idx="0"/>
+          </p:nvPr>
+        </p:nvSpPr>
+        <p:spPr/>
+      </p:sp>
+      <p:sp>
+        <p:nvSpPr>
+          <p:cNvPr id="3" name="Notes Placeholder 2"/>
+          <p:cNvSpPr>
+            <a:spLocks xmlns:a="http://schemas.openxmlformats.org/drawingml/2006/main" noGrp="1"/>
+          </p:cNvSpPr>
+          <p:nvPr>
+            <p:ph type="body" idx="1"/>
+          </p:nvPr>
+        </p:nvSpPr>
+        <p:spPr/>
+        <p:txBody>
+          <a:bodyPr xmlns:a="http://schemas.openxmlformats.org/drawingml/2006/main"/>
+          <a:lstStyle xmlns:a="http://schemas.openxmlformats.org/drawingml/2006/main"/>
+          <a:p xmlns:a="http://schemas.openxmlformats.org/drawingml/2006/main">
+            <a:r>
+              <a:t>Close by returning to the opening tension: a few spare minutes should become play, not another search. Invite judges to use the account-free live product.</a:t>
+            </a:r>
+          </a:p>
+          <a:p xmlns:a="http://schemas.openxmlformats.org/drawingml/2006/main">
+            <a:r>
+              <a:t/>
+            </a:r>
+          </a:p>
+          <a:p xmlns:a="http://schemas.openxmlformats.org/drawingml/2006/main">
+            <a:r>
+              <a:t>[Sources]</a:t>
+            </a:r>
+          </a:p>
+          <a:p xmlns:a="http://schemas.openxmlformats.org/drawingml/2006/main">
+            <a:r>
+              <a:t>- Working prototype: https://trythis.fun</a:t>
             </a:r>
           </a:p>
           <a:p xmlns:a="http://schemas.openxmlformats.org/drawingml/2006/main">
@@ -899,7 +1278,7 @@
   </p:cSld>
   <p:clrMap bg1="lt1" tx1="dk1" bg2="lt2" tx2="dk2" accent1="accent1" accent2="accent2" accent3="accent3" accent4="accent4" accent5="accent5" accent6="accent6" hlink="hlink" folHlink="folHlink"/>
   <p:sldLayoutIdLst>
-    <p:sldLayoutId xmlns:r="http://schemas.openxmlformats.org/officeDocument/2006/relationships" id="2147483649" r:id="R3d4703396da9494a"/>
+    <p:sldLayoutId xmlns:r="http://schemas.openxmlformats.org/officeDocument/2006/relationships" id="2147483649" r:id="Ra3fe796532ca4627"/>
   </p:sldLayoutIdLst>
   <p:txStyles>
     <p:titleStyle>
@@ -1618,6 +1997,7 @@
           <a:lstStyle xmlns:a="http://schemas.openxmlformats.org/drawingml/2006/main"/>
           <a:p xmlns:a="http://schemas.openxmlformats.org/drawingml/2006/main">
             <a:pPr>
+              <a:buNone/>
               <a:defRPr sz="4350" b="1">
                 <a:solidFill>
                   <a:srgbClr val="18223B"/>
@@ -1668,6 +2048,7 @@
           <a:lstStyle xmlns:a="http://schemas.openxmlformats.org/drawingml/2006/main"/>
           <a:p xmlns:a="http://schemas.openxmlformats.org/drawingml/2006/main">
             <a:pPr>
+              <a:buNone/>
               <a:defRPr sz="2100" b="1">
                 <a:solidFill>
                   <a:srgbClr val="18223B"/>
@@ -1718,6 +2099,7 @@
           <a:lstStyle xmlns:a="http://schemas.openxmlformats.org/drawingml/2006/main"/>
           <a:p xmlns:a="http://schemas.openxmlformats.org/drawingml/2006/main">
             <a:pPr>
+              <a:buNone/>
               <a:defRPr sz="1125" b="1">
                 <a:solidFill>
                   <a:srgbClr val="315BD9"/>
@@ -1768,6 +2150,7 @@
           <a:lstStyle xmlns:a="http://schemas.openxmlformats.org/drawingml/2006/main"/>
           <a:p xmlns:a="http://schemas.openxmlformats.org/drawingml/2006/main">
             <a:pPr>
+              <a:buNone/>
               <a:defRPr sz="5400" b="1">
                 <a:solidFill>
                   <a:srgbClr val="18223B"/>
@@ -1780,7 +2163,7 @@
                   <a:srgbClr val="18223B"/>
                 </a:solidFill>
               </a:rPr>
-              <a:t>Try This</a:t>
+              <a:t>Try This Fun</a:t>
             </a:r>
           </a:p>
         </p:txBody>
@@ -1818,6 +2201,7 @@
           <a:lstStyle xmlns:a="http://schemas.openxmlformats.org/drawingml/2006/main"/>
           <a:p xmlns:a="http://schemas.openxmlformats.org/drawingml/2006/main">
             <a:pPr>
+              <a:buNone/>
               <a:defRPr sz="2850" b="1">
                 <a:solidFill>
                   <a:srgbClr val="18223B"/>
@@ -1835,6 +2219,7 @@
           </a:p>
           <a:p xmlns:a="http://schemas.openxmlformats.org/drawingml/2006/main">
             <a:pPr>
+              <a:buNone/>
               <a:defRPr sz="2850" b="1">
                 <a:solidFill>
                   <a:srgbClr val="18223B"/>
@@ -1885,6 +2270,7 @@
           <a:lstStyle xmlns:a="http://schemas.openxmlformats.org/drawingml/2006/main"/>
           <a:p xmlns:a="http://schemas.openxmlformats.org/drawingml/2006/main">
             <a:pPr>
+              <a:buNone/>
               <a:defRPr sz="1350" b="1">
                 <a:solidFill>
                   <a:srgbClr val="18223B"/>
@@ -1935,6 +2321,7 @@
           <a:lstStyle xmlns:a="http://schemas.openxmlformats.org/drawingml/2006/main"/>
           <a:p xmlns:a="http://schemas.openxmlformats.org/drawingml/2006/main">
             <a:pPr>
+              <a:buNone/>
               <a:defRPr sz="1200" b="0">
                 <a:solidFill>
                   <a:srgbClr val="18223B"/>
@@ -2014,6 +2401,7 @@
           <a:lstStyle xmlns:a="http://schemas.openxmlformats.org/drawingml/2006/main"/>
           <a:p xmlns:a="http://schemas.openxmlformats.org/drawingml/2006/main">
             <a:pPr>
+              <a:buNone/>
               <a:defRPr sz="1125" b="1">
                 <a:solidFill>
                   <a:srgbClr val="315BD9"/>
@@ -2064,6 +2452,7 @@
           <a:lstStyle xmlns:a="http://schemas.openxmlformats.org/drawingml/2006/main"/>
           <a:p xmlns:a="http://schemas.openxmlformats.org/drawingml/2006/main">
             <a:pPr>
+              <a:buNone/>
               <a:defRPr sz="3750" b="1">
                 <a:solidFill>
                   <a:srgbClr val="18223B"/>
@@ -2081,6 +2470,7 @@
           </a:p>
           <a:p xmlns:a="http://schemas.openxmlformats.org/drawingml/2006/main">
             <a:pPr>
+              <a:buNone/>
               <a:defRPr sz="3750" b="1">
                 <a:solidFill>
                   <a:srgbClr val="18223B"/>
@@ -2131,6 +2521,7 @@
           <a:lstStyle xmlns:a="http://schemas.openxmlformats.org/drawingml/2006/main"/>
           <a:p xmlns:a="http://schemas.openxmlformats.org/drawingml/2006/main">
             <a:pPr>
+              <a:buNone/>
               <a:defRPr sz="1725" b="0">
                 <a:solidFill>
                   <a:srgbClr val="68738D"/>
@@ -2216,6 +2607,7 @@
           <a:lstStyle xmlns:a="http://schemas.openxmlformats.org/drawingml/2006/main"/>
           <a:p xmlns:a="http://schemas.openxmlformats.org/drawingml/2006/main">
             <a:pPr>
+              <a:buNone/>
               <a:defRPr sz="5400" b="1">
                 <a:solidFill>
                   <a:srgbClr val="315BD9"/>
@@ -2266,6 +2658,7 @@
           <a:lstStyle xmlns:a="http://schemas.openxmlformats.org/drawingml/2006/main"/>
           <a:p xmlns:a="http://schemas.openxmlformats.org/drawingml/2006/main">
             <a:pPr>
+              <a:buNone/>
               <a:defRPr sz="1350" b="1">
                 <a:solidFill>
                   <a:srgbClr val="18223B"/>
@@ -2316,6 +2709,7 @@
           <a:lstStyle xmlns:a="http://schemas.openxmlformats.org/drawingml/2006/main"/>
           <a:p xmlns:a="http://schemas.openxmlformats.org/drawingml/2006/main">
             <a:pPr>
+              <a:buNone/>
               <a:defRPr sz="3750" b="1">
                 <a:solidFill>
                   <a:srgbClr val="18223B"/>
@@ -2366,6 +2760,7 @@
           <a:lstStyle xmlns:a="http://schemas.openxmlformats.org/drawingml/2006/main"/>
           <a:p xmlns:a="http://schemas.openxmlformats.org/drawingml/2006/main">
             <a:pPr>
+              <a:buNone/>
               <a:defRPr sz="5400" b="1">
                 <a:solidFill>
                   <a:srgbClr val="FF6961"/>
@@ -2416,6 +2811,7 @@
           <a:lstStyle xmlns:a="http://schemas.openxmlformats.org/drawingml/2006/main"/>
           <a:p xmlns:a="http://schemas.openxmlformats.org/drawingml/2006/main">
             <a:pPr>
+              <a:buNone/>
               <a:defRPr sz="1350" b="1">
                 <a:solidFill>
                   <a:srgbClr val="18223B"/>
@@ -2501,6 +2897,7 @@
           <a:lstStyle xmlns:a="http://schemas.openxmlformats.org/drawingml/2006/main"/>
           <a:p xmlns:a="http://schemas.openxmlformats.org/drawingml/2006/main">
             <a:pPr>
+              <a:buNone/>
               <a:defRPr sz="2025" b="1">
                 <a:solidFill>
                   <a:srgbClr val="18223B"/>
@@ -2551,6 +2948,7 @@
           <a:lstStyle xmlns:a="http://schemas.openxmlformats.org/drawingml/2006/main"/>
           <a:p xmlns:a="http://schemas.openxmlformats.org/drawingml/2006/main">
             <a:pPr>
+              <a:buNone/>
               <a:defRPr sz="1275" b="0">
                 <a:solidFill>
                   <a:srgbClr val="18223B"/>
@@ -2568,6 +2966,7 @@
           </a:p>
           <a:p xmlns:a="http://schemas.openxmlformats.org/drawingml/2006/main">
             <a:pPr>
+              <a:buNone/>
               <a:defRPr sz="1275" b="0">
                 <a:solidFill>
                   <a:srgbClr val="18223B"/>
@@ -2750,6 +3149,7 @@
           <a:lstStyle xmlns:a="http://schemas.openxmlformats.org/drawingml/2006/main"/>
           <a:p xmlns:a="http://schemas.openxmlformats.org/drawingml/2006/main">
             <a:pPr>
+              <a:buNone/>
               <a:defRPr sz="2100" b="1">
                 <a:solidFill>
                   <a:srgbClr val="18223B"/>
@@ -2767,6 +3167,7 @@
           </a:p>
           <a:p xmlns:a="http://schemas.openxmlformats.org/drawingml/2006/main">
             <a:pPr>
+              <a:buNone/>
               <a:defRPr sz="2100" b="1">
                 <a:solidFill>
                   <a:srgbClr val="18223B"/>
@@ -2817,6 +3218,7 @@
           <a:lstStyle xmlns:a="http://schemas.openxmlformats.org/drawingml/2006/main"/>
           <a:p xmlns:a="http://schemas.openxmlformats.org/drawingml/2006/main">
             <a:pPr>
+              <a:buNone/>
               <a:defRPr sz="900" b="1">
                 <a:solidFill>
                   <a:srgbClr val="68738D"/>
@@ -2867,6 +3269,7 @@
           <a:lstStyle xmlns:a="http://schemas.openxmlformats.org/drawingml/2006/main"/>
           <a:p xmlns:a="http://schemas.openxmlformats.org/drawingml/2006/main">
             <a:pPr>
+              <a:buNone/>
               <a:defRPr sz="900" b="1">
                 <a:solidFill>
                   <a:srgbClr val="68738D"/>
@@ -2946,6 +3349,7 @@
           <a:lstStyle xmlns:a="http://schemas.openxmlformats.org/drawingml/2006/main"/>
           <a:p xmlns:a="http://schemas.openxmlformats.org/drawingml/2006/main">
             <a:pPr>
+              <a:buNone/>
               <a:defRPr sz="1125" b="1">
                 <a:solidFill>
                   <a:srgbClr val="315BD9"/>
@@ -2996,6 +3400,7 @@
           <a:lstStyle xmlns:a="http://schemas.openxmlformats.org/drawingml/2006/main"/>
           <a:p xmlns:a="http://schemas.openxmlformats.org/drawingml/2006/main">
             <a:pPr>
+              <a:buNone/>
               <a:defRPr sz="3450" b="1">
                 <a:solidFill>
                   <a:srgbClr val="18223B"/>
@@ -3013,6 +3418,7 @@
           </a:p>
           <a:p xmlns:a="http://schemas.openxmlformats.org/drawingml/2006/main">
             <a:pPr>
+              <a:buNone/>
               <a:defRPr sz="3450" b="1">
                 <a:solidFill>
                   <a:srgbClr val="18223B"/>
@@ -3063,6 +3469,7 @@
           <a:lstStyle xmlns:a="http://schemas.openxmlformats.org/drawingml/2006/main"/>
           <a:p xmlns:a="http://schemas.openxmlformats.org/drawingml/2006/main">
             <a:pPr>
+              <a:buNone/>
               <a:defRPr sz="1575" b="0">
                 <a:solidFill>
                   <a:srgbClr val="68738D"/>
@@ -3075,7 +3482,7 @@
                   <a:srgbClr val="68738D"/>
                 </a:solidFill>
               </a:rPr>
-              <a:t>Try This asks only what matters in this moment — the mood, setup, and number of players — then recommends one activity.</a:t>
+              <a:t>Try This asks only what matters in this moment — the mood, setup, and time available — then recommends one activity.</a:t>
             </a:r>
           </a:p>
         </p:txBody>
@@ -3146,6 +3553,7 @@
           <a:lstStyle xmlns:a="http://schemas.openxmlformats.org/drawingml/2006/main"/>
           <a:p xmlns:a="http://schemas.openxmlformats.org/drawingml/2006/main">
             <a:pPr>
+              <a:buNone/>
               <a:defRPr sz="1500" b="1">
                 <a:solidFill>
                   <a:srgbClr val="18223B"/>
@@ -3196,6 +3604,7 @@
           <a:lstStyle xmlns:a="http://schemas.openxmlformats.org/drawingml/2006/main"/>
           <a:p xmlns:a="http://schemas.openxmlformats.org/drawingml/2006/main">
             <a:pPr>
+              <a:buNone/>
               <a:defRPr sz="1725" b="1">
                 <a:solidFill>
                   <a:srgbClr val="18223B"/>
@@ -3279,6 +3688,7 @@
           <a:lstStyle xmlns:a="http://schemas.openxmlformats.org/drawingml/2006/main"/>
           <a:p xmlns:a="http://schemas.openxmlformats.org/drawingml/2006/main">
             <a:pPr>
+              <a:buNone/>
               <a:defRPr sz="1500" b="1">
                 <a:solidFill>
                   <a:srgbClr val="18223B"/>
@@ -3329,6 +3739,7 @@
           <a:lstStyle xmlns:a="http://schemas.openxmlformats.org/drawingml/2006/main"/>
           <a:p xmlns:a="http://schemas.openxmlformats.org/drawingml/2006/main">
             <a:pPr>
+              <a:buNone/>
               <a:defRPr sz="1725" b="1">
                 <a:solidFill>
                   <a:srgbClr val="18223B"/>
@@ -3412,6 +3823,7 @@
           <a:lstStyle xmlns:a="http://schemas.openxmlformats.org/drawingml/2006/main"/>
           <a:p xmlns:a="http://schemas.openxmlformats.org/drawingml/2006/main">
             <a:pPr>
+              <a:buNone/>
               <a:defRPr sz="1500" b="1">
                 <a:solidFill>
                   <a:srgbClr val="18223B"/>
@@ -3462,6 +3874,7 @@
           <a:lstStyle xmlns:a="http://schemas.openxmlformats.org/drawingml/2006/main"/>
           <a:p xmlns:a="http://schemas.openxmlformats.org/drawingml/2006/main">
             <a:pPr>
+              <a:buNone/>
               <a:defRPr sz="1725" b="1">
                 <a:solidFill>
                   <a:srgbClr val="18223B"/>
@@ -3516,14 +3929,14 @@
       </p:sp>
       <p:pic>
         <p:nvPicPr>
-          <p:cNvPr id="30" name=""/>
+          <p:cNvPr id="32" name=""/>
           <p:cNvPicPr>
             <a:picLocks xmlns:a="http://schemas.openxmlformats.org/drawingml/2006/main" noChangeAspect="1"/>
           </p:cNvPicPr>
           <p:nvPr/>
         </p:nvPicPr>
         <p:blipFill>
-          <a:blip xmlns:r="http://schemas.openxmlformats.org/officeDocument/2006/relationships" xmlns:a="http://schemas.openxmlformats.org/drawingml/2006/main" r:embed="R14c9aec595cd4836"/>
+          <a:blip xmlns:r="http://schemas.openxmlformats.org/officeDocument/2006/relationships" xmlns:a="http://schemas.openxmlformats.org/drawingml/2006/main" r:embed="R7b2216fc86f04dad"/>
           <a:stretch xmlns:a="http://schemas.openxmlformats.org/drawingml/2006/main"/>
         </p:blipFill>
         <p:spPr>
@@ -3569,6 +3982,7 @@
           <a:lstStyle xmlns:a="http://schemas.openxmlformats.org/drawingml/2006/main"/>
           <a:p xmlns:a="http://schemas.openxmlformats.org/drawingml/2006/main">
             <a:pPr>
+              <a:buNone/>
               <a:defRPr sz="900" b="1">
                 <a:solidFill>
                   <a:srgbClr val="68738D"/>
@@ -3619,6 +4033,7 @@
           <a:lstStyle xmlns:a="http://schemas.openxmlformats.org/drawingml/2006/main"/>
           <a:p xmlns:a="http://schemas.openxmlformats.org/drawingml/2006/main">
             <a:pPr>
+              <a:buNone/>
               <a:defRPr sz="900" b="1">
                 <a:solidFill>
                   <a:srgbClr val="68738D"/>
@@ -3702,15 +4117,18 @@
       </p:sp>
       <p:pic>
         <p:nvPicPr>
-          <p:cNvPr id="21" name=""/>
+          <p:cNvPr id="23" name=""/>
           <p:cNvPicPr>
             <a:picLocks xmlns:a="http://schemas.openxmlformats.org/drawingml/2006/main" noChangeAspect="1"/>
           </p:cNvPicPr>
           <p:nvPr/>
         </p:nvPicPr>
         <p:blipFill>
-          <a:blip xmlns:r="http://schemas.openxmlformats.org/officeDocument/2006/relationships" xmlns:a="http://schemas.openxmlformats.org/drawingml/2006/main" r:embed="Rc190f2f5c71b4980"/>
-          <a:stretch xmlns:a="http://schemas.openxmlformats.org/drawingml/2006/main"/>
+          <a:blip xmlns:r="http://schemas.openxmlformats.org/officeDocument/2006/relationships" xmlns:a="http://schemas.openxmlformats.org/drawingml/2006/main" r:embed="R88aa6f077c7641f4"/>
+          <a:srcRect xmlns:a="http://schemas.openxmlformats.org/drawingml/2006/main" l="0" t="2525" r="0" b="2525"/>
+          <a:stretch xmlns:a="http://schemas.openxmlformats.org/drawingml/2006/main">
+            <a:fillRect l="0" t="0" r="0" b="0"/>
+          </a:stretch>
         </p:blipFill>
         <p:spPr>
           <a:xfrm xmlns:a="http://schemas.openxmlformats.org/drawingml/2006/main">
@@ -3755,6 +4173,7 @@
           <a:lstStyle xmlns:a="http://schemas.openxmlformats.org/drawingml/2006/main"/>
           <a:p xmlns:a="http://schemas.openxmlformats.org/drawingml/2006/main">
             <a:pPr>
+              <a:buNone/>
               <a:defRPr sz="1125" b="1">
                 <a:solidFill>
                   <a:srgbClr val="FFD55A"/>
@@ -3767,7 +4186,7 @@
                   <a:srgbClr val="FFD55A"/>
                 </a:solidFill>
               </a:rPr>
-              <a:t>THE DIFFERENCE</a:t>
+              <a:t>HERITAGE, MADE PLAYABLE</a:t>
             </a:r>
           </a:p>
         </p:txBody>
@@ -3805,6 +4224,7 @@
           <a:lstStyle xmlns:a="http://schemas.openxmlformats.org/drawingml/2006/main"/>
           <a:p xmlns:a="http://schemas.openxmlformats.org/drawingml/2006/main">
             <a:pPr>
+              <a:buNone/>
               <a:defRPr sz="3300" b="1">
                 <a:solidFill>
                   <a:srgbClr val="FFFDF6"/>
@@ -3817,11 +4237,12 @@
                   <a:srgbClr val="FFFDF6"/>
                 </a:solidFill>
               </a:rPr>
-              <a:t>An idea is only useful</a:t>
-            </a:r>
-          </a:p>
-          <a:p xmlns:a="http://schemas.openxmlformats.org/drawingml/2006/main">
-            <a:pPr>
+              <a:t>Watch once.</a:t>
+            </a:r>
+          </a:p>
+          <a:p xmlns:a="http://schemas.openxmlformats.org/drawingml/2006/main">
+            <a:pPr>
+              <a:buNone/>
               <a:defRPr sz="3300" b="1">
                 <a:solidFill>
                   <a:srgbClr val="FFFDF6"/>
@@ -3834,7 +4255,7 @@
                   <a:srgbClr val="FFFDF6"/>
                 </a:solidFill>
               </a:rPr>
-              <a:t>if you can play it.</a:t>
+              <a:t>Play for years.</a:t>
             </a:r>
           </a:p>
         </p:txBody>
@@ -3872,6 +4293,7 @@
           <a:lstStyle xmlns:a="http://schemas.openxmlformats.org/drawingml/2006/main"/>
           <a:p xmlns:a="http://schemas.openxmlformats.org/drawingml/2006/main">
             <a:pPr>
+              <a:buNone/>
               <a:defRPr sz="1575" b="0">
                 <a:solidFill>
                   <a:srgbClr val="C9D2EA"/>
@@ -3884,7 +4306,7 @@
                   <a:srgbClr val="C9D2EA"/>
                 </a:solidFill>
               </a:rPr>
-              <a:t>Every activity is written to answer the questions a tired parent actually has:</a:t>
+              <a:t>Oral family games survive when a new parent is never expected to already know the missing details:</a:t>
             </a:r>
           </a:p>
         </p:txBody>
@@ -3955,6 +4377,7 @@
           <a:lstStyle xmlns:a="http://schemas.openxmlformats.org/drawingml/2006/main"/>
           <a:p xmlns:a="http://schemas.openxmlformats.org/drawingml/2006/main">
             <a:pPr>
+              <a:buNone/>
               <a:defRPr sz="1275" b="1">
                 <a:solidFill>
                   <a:srgbClr val="18223B"/>
@@ -4005,6 +4428,7 @@
           <a:lstStyle xmlns:a="http://schemas.openxmlformats.org/drawingml/2006/main"/>
           <a:p xmlns:a="http://schemas.openxmlformats.org/drawingml/2006/main">
             <a:pPr>
+              <a:buNone/>
               <a:defRPr sz="1650" b="1">
                 <a:solidFill>
                   <a:srgbClr val="FFFDF6"/>
@@ -4017,7 +4441,7 @@
                   <a:srgbClr val="FFFDF6"/>
                 </a:solidFill>
               </a:rPr>
-              <a:t>How do we start?</a:t>
+              <a:t>The original Kannada words</a:t>
             </a:r>
           </a:p>
         </p:txBody>
@@ -4055,6 +4479,7 @@
           <a:lstStyle xmlns:a="http://schemas.openxmlformats.org/drawingml/2006/main"/>
           <a:p xmlns:a="http://schemas.openxmlformats.org/drawingml/2006/main">
             <a:pPr>
+              <a:buNone/>
               <a:defRPr sz="1200" b="0">
                 <a:solidFill>
                   <a:srgbClr val="C9D2EA"/>
@@ -4067,7 +4492,7 @@
                   <a:srgbClr val="C9D2EA"/>
                 </a:solidFill>
               </a:rPr>
-              <a:t>A line you can say out loud.</a:t>
+              <a:t>Lyrics preserved in Kannada script.</a:t>
             </a:r>
           </a:p>
         </p:txBody>
@@ -4138,6 +4563,7 @@
           <a:lstStyle xmlns:a="http://schemas.openxmlformats.org/drawingml/2006/main"/>
           <a:p xmlns:a="http://schemas.openxmlformats.org/drawingml/2006/main">
             <a:pPr>
+              <a:buNone/>
               <a:defRPr sz="1275" b="1">
                 <a:solidFill>
                   <a:srgbClr val="18223B"/>
@@ -4188,6 +4614,7 @@
           <a:lstStyle xmlns:a="http://schemas.openxmlformats.org/drawingml/2006/main"/>
           <a:p xmlns:a="http://schemas.openxmlformats.org/drawingml/2006/main">
             <a:pPr>
+              <a:buNone/>
               <a:defRPr sz="1650" b="1">
                 <a:solidFill>
                   <a:srgbClr val="FFFDF6"/>
@@ -4200,7 +4627,7 @@
                   <a:srgbClr val="FFFDF6"/>
                 </a:solidFill>
               </a:rPr>
-              <a:t>What do we do next?</a:t>
+              <a:t>A practical reading guide</a:t>
             </a:r>
           </a:p>
         </p:txBody>
@@ -4238,6 +4665,7 @@
           <a:lstStyle xmlns:a="http://schemas.openxmlformats.org/drawingml/2006/main"/>
           <a:p xmlns:a="http://schemas.openxmlformats.org/drawingml/2006/main">
             <a:pPr>
+              <a:buNone/>
               <a:defRPr sz="1200" b="0">
                 <a:solidFill>
                   <a:srgbClr val="C9D2EA"/>
@@ -4250,7 +4678,7 @@
                   <a:srgbClr val="C9D2EA"/>
                 </a:solidFill>
               </a:rPr>
-              <a:t>Clear, specific play instructions.</a:t>
+              <a:t>Transliteration plus every movement.</a:t>
             </a:r>
           </a:p>
         </p:txBody>
@@ -4321,6 +4749,7 @@
           <a:lstStyle xmlns:a="http://schemas.openxmlformats.org/drawingml/2006/main"/>
           <a:p xmlns:a="http://schemas.openxmlformats.org/drawingml/2006/main">
             <a:pPr>
+              <a:buNone/>
               <a:defRPr sz="1275" b="1">
                 <a:solidFill>
                   <a:srgbClr val="18223B"/>
@@ -4371,6 +4800,7 @@
           <a:lstStyle xmlns:a="http://schemas.openxmlformats.org/drawingml/2006/main"/>
           <a:p xmlns:a="http://schemas.openxmlformats.org/drawingml/2006/main">
             <a:pPr>
+              <a:buNone/>
               <a:defRPr sz="1650" b="1">
                 <a:solidFill>
                   <a:srgbClr val="FFFDF6"/>
@@ -4383,7 +4813,7 @@
                   <a:srgbClr val="FFFDF6"/>
                 </a:solidFill>
               </a:rPr>
-              <a:t>How can it fit us?</a:t>
+              <a:t>A real family demonstration</a:t>
             </a:r>
           </a:p>
         </p:txBody>
@@ -4421,6 +4851,7 @@
           <a:lstStyle xmlns:a="http://schemas.openxmlformats.org/drawingml/2006/main"/>
           <a:p xmlns:a="http://schemas.openxmlformats.org/drawingml/2006/main">
             <a:pPr>
+              <a:buNone/>
               <a:defRPr sz="1200" b="0">
                 <a:solidFill>
                   <a:srgbClr val="C9D2EA"/>
@@ -4433,7 +4864,7 @@
                   <a:srgbClr val="C9D2EA"/>
                 </a:solidFill>
               </a:rPr>
-              <a:t>Easier and harder variations.</a:t>
+              <a:t>Video shows the rhythm and punchline.</a:t>
             </a:r>
           </a:p>
         </p:txBody>
@@ -4471,6 +4902,7 @@
           <a:lstStyle xmlns:a="http://schemas.openxmlformats.org/drawingml/2006/main"/>
           <a:p xmlns:a="http://schemas.openxmlformats.org/drawingml/2006/main">
             <a:pPr>
+              <a:buNone/>
               <a:defRPr sz="900" b="1">
                 <a:solidFill>
                   <a:srgbClr val="FFFDF6"/>
@@ -4521,6 +4953,7 @@
           <a:lstStyle xmlns:a="http://schemas.openxmlformats.org/drawingml/2006/main"/>
           <a:p xmlns:a="http://schemas.openxmlformats.org/drawingml/2006/main">
             <a:pPr>
+              <a:buNone/>
               <a:defRPr sz="900" b="1">
                 <a:solidFill>
                   <a:srgbClr val="FFFDF6"/>
@@ -4549,6 +4982,3368 @@
 </file>
 
 <file path=ppt/slides/slide5.xml><?xml version="1.0" encoding="utf-8"?>
+<p:sld xmlns:p="http://schemas.openxmlformats.org/presentationml/2006/main">
+  <p:cSld>
+    <p:bg>
+      <p:bgPr>
+        <a:solidFill xmlns:a="http://schemas.openxmlformats.org/drawingml/2006/main">
+          <a:srgbClr val="FFFDF6"/>
+        </a:solidFill>
+      </p:bgPr>
+    </p:bg>
+    <p:spTree>
+      <p:nvGrpSpPr>
+        <p:cNvPr id="1" name=""/>
+        <p:cNvGrpSpPr/>
+        <p:nvPr/>
+      </p:nvGrpSpPr>
+      <p:grpSpPr>
+        <a:xfrm xmlns:a="http://schemas.openxmlformats.org/drawingml/2006/main"/>
+      </p:grpSpPr>
+      <p:sp>
+        <p:nvSpPr>
+          <p:cNvPr id="17" name="">
+            <a:extLst xmlns:a="http://schemas.openxmlformats.org/drawingml/2006/main">
+              <a:ext uri="{FF2B5EF4-FFF2-40B4-BE49-F238E27FC236}">
+                <a16:creationId xmlns:a16="http://schemas.microsoft.com/office/drawing/2014/main" id="{96A218B2-0E34-4907-BB8B-1DA8148331D1}"/>
+              </a:ext>
+            </a:extLst>
+          </p:cNvPr>
+          <p:cNvSpPr>
+            <a:spLocks xmlns:a="http://schemas.openxmlformats.org/drawingml/2006/main" noGrp="1"/>
+          </p:cNvSpPr>
+          <p:nvPr/>
+        </p:nvSpPr>
+        <p:spPr>
+          <a:xfrm xmlns:a="http://schemas.openxmlformats.org/drawingml/2006/main">
+            <a:off x="666750" y="457200"/>
+            <a:ext cx="2667000" cy="266700"/>
+          </a:xfrm>
+          <a:prstGeom xmlns:a="http://schemas.openxmlformats.org/drawingml/2006/main" prst="rect">
+            <a:avLst/>
+          </a:prstGeom>
+          <a:noFill xmlns:a="http://schemas.openxmlformats.org/drawingml/2006/main"/>
+          <a:ln xmlns:a="http://schemas.openxmlformats.org/drawingml/2006/main" w="0">
+            <a:noFill/>
+            <a:prstDash val="solid"/>
+          </a:ln>
+        </p:spPr>
+        <p:txBody>
+          <a:bodyPr xmlns:a="http://schemas.openxmlformats.org/drawingml/2006/main" anchor="ctr"/>
+          <a:lstStyle xmlns:a="http://schemas.openxmlformats.org/drawingml/2006/main"/>
+          <a:p xmlns:a="http://schemas.openxmlformats.org/drawingml/2006/main">
+            <a:pPr>
+              <a:buNone/>
+              <a:defRPr sz="1125" b="1">
+                <a:solidFill>
+                  <a:srgbClr val="315BD9"/>
+                </a:solidFill>
+              </a:defRPr>
+            </a:pPr>
+            <a:r>
+              <a:rPr sz="1125" b="1">
+                <a:solidFill>
+                  <a:srgbClr val="315BD9"/>
+                </a:solidFill>
+              </a:rPr>
+              <a:t>SYSTEM ARCHITECTURE</a:t>
+            </a:r>
+          </a:p>
+        </p:txBody>
+      </p:sp>
+      <p:sp>
+        <p:nvSpPr>
+          <p:cNvPr id="2" name="">
+            <a:extLst xmlns:a="http://schemas.openxmlformats.org/drawingml/2006/main">
+              <a:ext uri="{FF2B5EF4-FFF2-40B4-BE49-F238E27FC236}">
+                <a16:creationId xmlns:a16="http://schemas.microsoft.com/office/drawing/2014/main" id="{92BCAA88-0D31-4F83-BDD4-AA5274367DBB}"/>
+              </a:ext>
+            </a:extLst>
+          </p:cNvPr>
+          <p:cNvSpPr>
+            <a:spLocks xmlns:a="http://schemas.openxmlformats.org/drawingml/2006/main" noGrp="1"/>
+          </p:cNvSpPr>
+          <p:nvPr/>
+        </p:nvSpPr>
+        <p:spPr>
+          <a:xfrm xmlns:a="http://schemas.openxmlformats.org/drawingml/2006/main">
+            <a:off x="647700" y="838200"/>
+            <a:ext cx="6286500" cy="1200150"/>
+          </a:xfrm>
+          <a:prstGeom xmlns:a="http://schemas.openxmlformats.org/drawingml/2006/main" prst="rect">
+            <a:avLst/>
+          </a:prstGeom>
+          <a:noFill xmlns:a="http://schemas.openxmlformats.org/drawingml/2006/main"/>
+          <a:ln xmlns:a="http://schemas.openxmlformats.org/drawingml/2006/main" w="0">
+            <a:noFill/>
+            <a:prstDash val="solid"/>
+          </a:ln>
+        </p:spPr>
+        <p:txBody>
+          <a:bodyPr xmlns:a="http://schemas.openxmlformats.org/drawingml/2006/main" anchor="ctr"/>
+          <a:lstStyle xmlns:a="http://schemas.openxmlformats.org/drawingml/2006/main"/>
+          <a:p xmlns:a="http://schemas.openxmlformats.org/drawingml/2006/main">
+            <a:pPr>
+              <a:buNone/>
+              <a:defRPr sz="3450" b="1">
+                <a:solidFill>
+                  <a:srgbClr val="18223B"/>
+                </a:solidFill>
+              </a:defRPr>
+            </a:pPr>
+            <a:r>
+              <a:rPr sz="3450" b="1">
+                <a:solidFill>
+                  <a:srgbClr val="18223B"/>
+                </a:solidFill>
+              </a:rPr>
+              <a:t>Simple at runtime.</a:t>
+            </a:r>
+          </a:p>
+          <a:p xmlns:a="http://schemas.openxmlformats.org/drawingml/2006/main">
+            <a:pPr>
+              <a:buNone/>
+              <a:defRPr sz="3450" b="1">
+                <a:solidFill>
+                  <a:srgbClr val="18223B"/>
+                </a:solidFill>
+              </a:defRPr>
+            </a:pPr>
+            <a:r>
+              <a:rPr sz="3450" b="1">
+                <a:solidFill>
+                  <a:srgbClr val="18223B"/>
+                </a:solidFill>
+              </a:rPr>
+              <a:t>Deep before it ships.</a:t>
+            </a:r>
+          </a:p>
+        </p:txBody>
+      </p:sp>
+      <p:sp>
+        <p:nvSpPr>
+          <p:cNvPr id="3" name="">
+            <a:extLst xmlns:a="http://schemas.openxmlformats.org/drawingml/2006/main">
+              <a:ext uri="{FF2B5EF4-FFF2-40B4-BE49-F238E27FC236}">
+                <a16:creationId xmlns:a16="http://schemas.microsoft.com/office/drawing/2014/main" id="{4D155491-0C99-4C3A-9600-9DFB756A6F79}"/>
+              </a:ext>
+            </a:extLst>
+          </p:cNvPr>
+          <p:cNvSpPr>
+            <a:spLocks xmlns:a="http://schemas.openxmlformats.org/drawingml/2006/main" noGrp="1"/>
+          </p:cNvSpPr>
+          <p:nvPr/>
+        </p:nvSpPr>
+        <p:spPr>
+          <a:xfrm xmlns:a="http://schemas.openxmlformats.org/drawingml/2006/main">
+            <a:off x="685800" y="2076450"/>
+            <a:ext cx="5505450" cy="1047750"/>
+          </a:xfrm>
+          <a:prstGeom xmlns:a="http://schemas.openxmlformats.org/drawingml/2006/main" prst="rect">
+            <a:avLst/>
+          </a:prstGeom>
+          <a:noFill xmlns:a="http://schemas.openxmlformats.org/drawingml/2006/main"/>
+          <a:ln xmlns:a="http://schemas.openxmlformats.org/drawingml/2006/main" w="0">
+            <a:noFill/>
+            <a:prstDash val="solid"/>
+          </a:ln>
+        </p:spPr>
+        <p:txBody>
+          <a:bodyPr xmlns:a="http://schemas.openxmlformats.org/drawingml/2006/main" anchor="ctr"/>
+          <a:lstStyle xmlns:a="http://schemas.openxmlformats.org/drawingml/2006/main"/>
+          <a:p xmlns:a="http://schemas.openxmlformats.org/drawingml/2006/main">
+            <a:pPr>
+              <a:buNone/>
+              <a:defRPr sz="1575" b="0">
+                <a:solidFill>
+                  <a:srgbClr val="68738D"/>
+                </a:solidFill>
+              </a:defRPr>
+            </a:pPr>
+            <a:r>
+              <a:rPr sz="1575" b="0">
+                <a:solidFill>
+                  <a:srgbClr val="68738D"/>
+                </a:solidFill>
+              </a:rPr>
+              <a:t>The MVP keeps family data on-device and turns a reviewed content pipeline into one fast, explainable recommendation.</a:t>
+            </a:r>
+          </a:p>
+        </p:txBody>
+      </p:sp>
+      <p:sp>
+        <p:nvSpPr>
+          <p:cNvPr id="4" name="">
+            <a:extLst xmlns:a="http://schemas.openxmlformats.org/drawingml/2006/main">
+              <a:ext uri="{FF2B5EF4-FFF2-40B4-BE49-F238E27FC236}">
+                <a16:creationId xmlns:a16="http://schemas.microsoft.com/office/drawing/2014/main" id="{84E2CA37-4AB3-4343-BC66-F932B71F5D8A}"/>
+              </a:ext>
+            </a:extLst>
+          </p:cNvPr>
+          <p:cNvSpPr>
+            <a:spLocks xmlns:a="http://schemas.openxmlformats.org/drawingml/2006/main" noGrp="1"/>
+          </p:cNvSpPr>
+          <p:nvPr/>
+        </p:nvSpPr>
+        <p:spPr>
+          <a:xfrm xmlns:a="http://schemas.openxmlformats.org/drawingml/2006/main">
+            <a:off x="704850" y="3390900"/>
+            <a:ext cx="514350" cy="514350"/>
+          </a:xfrm>
+          <a:prstGeom xmlns:a="http://schemas.openxmlformats.org/drawingml/2006/main" prst="ellipse">
+            <a:avLst/>
+          </a:prstGeom>
+          <a:solidFill xmlns:a="http://schemas.openxmlformats.org/drawingml/2006/main">
+            <a:srgbClr val="FFD55A"/>
+          </a:solidFill>
+          <a:ln xmlns:a="http://schemas.openxmlformats.org/drawingml/2006/main" w="19050">
+            <a:solidFill>
+              <a:srgbClr val="18223B"/>
+            </a:solidFill>
+            <a:prstDash val="solid"/>
+          </a:ln>
+        </p:spPr>
+      </p:sp>
+      <p:sp>
+        <p:nvSpPr>
+          <p:cNvPr id="5" name="">
+            <a:extLst xmlns:a="http://schemas.openxmlformats.org/drawingml/2006/main">
+              <a:ext uri="{FF2B5EF4-FFF2-40B4-BE49-F238E27FC236}">
+                <a16:creationId xmlns:a16="http://schemas.microsoft.com/office/drawing/2014/main" id="{6FC68DBD-1219-4CD7-AEB8-888FDDAB5BF6}"/>
+              </a:ext>
+            </a:extLst>
+          </p:cNvPr>
+          <p:cNvSpPr>
+            <a:spLocks xmlns:a="http://schemas.openxmlformats.org/drawingml/2006/main" noGrp="1"/>
+          </p:cNvSpPr>
+          <p:nvPr/>
+        </p:nvSpPr>
+        <p:spPr>
+          <a:xfrm xmlns:a="http://schemas.openxmlformats.org/drawingml/2006/main">
+            <a:off x="704850" y="3419475"/>
+            <a:ext cx="514350" cy="438150"/>
+          </a:xfrm>
+          <a:prstGeom xmlns:a="http://schemas.openxmlformats.org/drawingml/2006/main" prst="rect">
+            <a:avLst/>
+          </a:prstGeom>
+          <a:noFill xmlns:a="http://schemas.openxmlformats.org/drawingml/2006/main"/>
+          <a:ln xmlns:a="http://schemas.openxmlformats.org/drawingml/2006/main" w="0">
+            <a:noFill/>
+            <a:prstDash val="solid"/>
+          </a:ln>
+        </p:spPr>
+        <p:txBody>
+          <a:bodyPr xmlns:a="http://schemas.openxmlformats.org/drawingml/2006/main" anchor="ctr"/>
+          <a:lstStyle xmlns:a="http://schemas.openxmlformats.org/drawingml/2006/main"/>
+          <a:p xmlns:a="http://schemas.openxmlformats.org/drawingml/2006/main">
+            <a:pPr>
+              <a:buNone/>
+              <a:defRPr sz="1500" b="1">
+                <a:solidFill>
+                  <a:srgbClr val="18223B"/>
+                </a:solidFill>
+              </a:defRPr>
+            </a:pPr>
+            <a:r>
+              <a:rPr sz="1500" b="1">
+                <a:solidFill>
+                  <a:srgbClr val="18223B"/>
+                </a:solidFill>
+              </a:rPr>
+              <a:t>1</a:t>
+            </a:r>
+          </a:p>
+        </p:txBody>
+      </p:sp>
+      <p:sp>
+        <p:nvSpPr>
+          <p:cNvPr id="6" name="">
+            <a:extLst xmlns:a="http://schemas.openxmlformats.org/drawingml/2006/main">
+              <a:ext uri="{FF2B5EF4-FFF2-40B4-BE49-F238E27FC236}">
+                <a16:creationId xmlns:a16="http://schemas.microsoft.com/office/drawing/2014/main" id="{F2F9D9DA-4818-406D-B38C-BBA9CDA144F0}"/>
+              </a:ext>
+            </a:extLst>
+          </p:cNvPr>
+          <p:cNvSpPr>
+            <a:spLocks xmlns:a="http://schemas.openxmlformats.org/drawingml/2006/main" noGrp="1"/>
+          </p:cNvSpPr>
+          <p:nvPr/>
+        </p:nvSpPr>
+        <p:spPr>
+          <a:xfrm xmlns:a="http://schemas.openxmlformats.org/drawingml/2006/main">
+            <a:off x="1409700" y="3390900"/>
+            <a:ext cx="4248150" cy="514350"/>
+          </a:xfrm>
+          <a:prstGeom xmlns:a="http://schemas.openxmlformats.org/drawingml/2006/main" prst="rect">
+            <a:avLst/>
+          </a:prstGeom>
+          <a:noFill xmlns:a="http://schemas.openxmlformats.org/drawingml/2006/main"/>
+          <a:ln xmlns:a="http://schemas.openxmlformats.org/drawingml/2006/main" w="0">
+            <a:noFill/>
+            <a:prstDash val="solid"/>
+          </a:ln>
+        </p:spPr>
+        <p:txBody>
+          <a:bodyPr xmlns:a="http://schemas.openxmlformats.org/drawingml/2006/main" anchor="ctr"/>
+          <a:lstStyle xmlns:a="http://schemas.openxmlformats.org/drawingml/2006/main"/>
+          <a:p xmlns:a="http://schemas.openxmlformats.org/drawingml/2006/main">
+            <a:pPr>
+              <a:buNone/>
+              <a:defRPr sz="1725" b="1">
+                <a:solidFill>
+                  <a:srgbClr val="18223B"/>
+                </a:solidFill>
+              </a:defRPr>
+            </a:pPr>
+            <a:r>
+              <a:rPr sz="1725" b="1">
+                <a:solidFill>
+                  <a:srgbClr val="18223B"/>
+                </a:solidFill>
+              </a:rPr>
+              <a:t>Research → typed catalog</a:t>
+            </a:r>
+          </a:p>
+        </p:txBody>
+      </p:sp>
+      <p:sp>
+        <p:nvSpPr>
+          <p:cNvPr id="7" name="">
+            <a:extLst xmlns:a="http://schemas.openxmlformats.org/drawingml/2006/main">
+              <a:ext uri="{FF2B5EF4-FFF2-40B4-BE49-F238E27FC236}">
+                <a16:creationId xmlns:a16="http://schemas.microsoft.com/office/drawing/2014/main" id="{29AEAA16-D832-44D1-934F-2D3DF75B1F8D}"/>
+              </a:ext>
+            </a:extLst>
+          </p:cNvPr>
+          <p:cNvSpPr>
+            <a:spLocks xmlns:a="http://schemas.openxmlformats.org/drawingml/2006/main" noGrp="1"/>
+          </p:cNvSpPr>
+          <p:nvPr/>
+        </p:nvSpPr>
+        <p:spPr>
+          <a:xfrm xmlns:a="http://schemas.openxmlformats.org/drawingml/2006/main">
+            <a:off x="704850" y="4171950"/>
+            <a:ext cx="514350" cy="514350"/>
+          </a:xfrm>
+          <a:prstGeom xmlns:a="http://schemas.openxmlformats.org/drawingml/2006/main" prst="ellipse">
+            <a:avLst/>
+          </a:prstGeom>
+          <a:solidFill xmlns:a="http://schemas.openxmlformats.org/drawingml/2006/main">
+            <a:srgbClr val="68D6B1"/>
+          </a:solidFill>
+          <a:ln xmlns:a="http://schemas.openxmlformats.org/drawingml/2006/main" w="19050">
+            <a:solidFill>
+              <a:srgbClr val="18223B"/>
+            </a:solidFill>
+            <a:prstDash val="solid"/>
+          </a:ln>
+        </p:spPr>
+      </p:sp>
+      <p:sp>
+        <p:nvSpPr>
+          <p:cNvPr id="8" name="">
+            <a:extLst xmlns:a="http://schemas.openxmlformats.org/drawingml/2006/main">
+              <a:ext uri="{FF2B5EF4-FFF2-40B4-BE49-F238E27FC236}">
+                <a16:creationId xmlns:a16="http://schemas.microsoft.com/office/drawing/2014/main" id="{E0C48501-7D69-4358-964C-471A22B0F515}"/>
+              </a:ext>
+            </a:extLst>
+          </p:cNvPr>
+          <p:cNvSpPr>
+            <a:spLocks xmlns:a="http://schemas.openxmlformats.org/drawingml/2006/main" noGrp="1"/>
+          </p:cNvSpPr>
+          <p:nvPr/>
+        </p:nvSpPr>
+        <p:spPr>
+          <a:xfrm xmlns:a="http://schemas.openxmlformats.org/drawingml/2006/main">
+            <a:off x="704850" y="4200525"/>
+            <a:ext cx="514350" cy="438150"/>
+          </a:xfrm>
+          <a:prstGeom xmlns:a="http://schemas.openxmlformats.org/drawingml/2006/main" prst="rect">
+            <a:avLst/>
+          </a:prstGeom>
+          <a:noFill xmlns:a="http://schemas.openxmlformats.org/drawingml/2006/main"/>
+          <a:ln xmlns:a="http://schemas.openxmlformats.org/drawingml/2006/main" w="0">
+            <a:noFill/>
+            <a:prstDash val="solid"/>
+          </a:ln>
+        </p:spPr>
+        <p:txBody>
+          <a:bodyPr xmlns:a="http://schemas.openxmlformats.org/drawingml/2006/main" anchor="ctr"/>
+          <a:lstStyle xmlns:a="http://schemas.openxmlformats.org/drawingml/2006/main"/>
+          <a:p xmlns:a="http://schemas.openxmlformats.org/drawingml/2006/main">
+            <a:pPr>
+              <a:buNone/>
+              <a:defRPr sz="1500" b="1">
+                <a:solidFill>
+                  <a:srgbClr val="18223B"/>
+                </a:solidFill>
+              </a:defRPr>
+            </a:pPr>
+            <a:r>
+              <a:rPr sz="1500" b="1">
+                <a:solidFill>
+                  <a:srgbClr val="18223B"/>
+                </a:solidFill>
+              </a:rPr>
+              <a:t>2</a:t>
+            </a:r>
+          </a:p>
+        </p:txBody>
+      </p:sp>
+      <p:sp>
+        <p:nvSpPr>
+          <p:cNvPr id="9" name="">
+            <a:extLst xmlns:a="http://schemas.openxmlformats.org/drawingml/2006/main">
+              <a:ext uri="{FF2B5EF4-FFF2-40B4-BE49-F238E27FC236}">
+                <a16:creationId xmlns:a16="http://schemas.microsoft.com/office/drawing/2014/main" id="{01C4276C-27B8-4876-AE12-DB5BD85C5EDE}"/>
+              </a:ext>
+            </a:extLst>
+          </p:cNvPr>
+          <p:cNvSpPr>
+            <a:spLocks xmlns:a="http://schemas.openxmlformats.org/drawingml/2006/main" noGrp="1"/>
+          </p:cNvSpPr>
+          <p:nvPr/>
+        </p:nvSpPr>
+        <p:spPr>
+          <a:xfrm xmlns:a="http://schemas.openxmlformats.org/drawingml/2006/main">
+            <a:off x="1409700" y="4171950"/>
+            <a:ext cx="4248150" cy="514350"/>
+          </a:xfrm>
+          <a:prstGeom xmlns:a="http://schemas.openxmlformats.org/drawingml/2006/main" prst="rect">
+            <a:avLst/>
+          </a:prstGeom>
+          <a:noFill xmlns:a="http://schemas.openxmlformats.org/drawingml/2006/main"/>
+          <a:ln xmlns:a="http://schemas.openxmlformats.org/drawingml/2006/main" w="0">
+            <a:noFill/>
+            <a:prstDash val="solid"/>
+          </a:ln>
+        </p:spPr>
+        <p:txBody>
+          <a:bodyPr xmlns:a="http://schemas.openxmlformats.org/drawingml/2006/main" anchor="ctr"/>
+          <a:lstStyle xmlns:a="http://schemas.openxmlformats.org/drawingml/2006/main"/>
+          <a:p xmlns:a="http://schemas.openxmlformats.org/drawingml/2006/main">
+            <a:pPr>
+              <a:buNone/>
+              <a:defRPr sz="1725" b="1">
+                <a:solidFill>
+                  <a:srgbClr val="18223B"/>
+                </a:solidFill>
+              </a:defRPr>
+            </a:pPr>
+            <a:r>
+              <a:rPr sz="1725" b="1">
+                <a:solidFill>
+                  <a:srgbClr val="18223B"/>
+                </a:solidFill>
+              </a:rPr>
+              <a:t>Constraints → shuffled deck</a:t>
+            </a:r>
+          </a:p>
+        </p:txBody>
+      </p:sp>
+      <p:sp>
+        <p:nvSpPr>
+          <p:cNvPr id="10" name="">
+            <a:extLst xmlns:a="http://schemas.openxmlformats.org/drawingml/2006/main">
+              <a:ext uri="{FF2B5EF4-FFF2-40B4-BE49-F238E27FC236}">
+                <a16:creationId xmlns:a16="http://schemas.microsoft.com/office/drawing/2014/main" id="{DE484EEE-E418-43E5-922B-31B838A7AEF9}"/>
+              </a:ext>
+            </a:extLst>
+          </p:cNvPr>
+          <p:cNvSpPr>
+            <a:spLocks xmlns:a="http://schemas.openxmlformats.org/drawingml/2006/main" noGrp="1"/>
+          </p:cNvSpPr>
+          <p:nvPr/>
+        </p:nvSpPr>
+        <p:spPr>
+          <a:xfrm xmlns:a="http://schemas.openxmlformats.org/drawingml/2006/main">
+            <a:off x="704850" y="4953000"/>
+            <a:ext cx="514350" cy="514350"/>
+          </a:xfrm>
+          <a:prstGeom xmlns:a="http://schemas.openxmlformats.org/drawingml/2006/main" prst="ellipse">
+            <a:avLst/>
+          </a:prstGeom>
+          <a:solidFill xmlns:a="http://schemas.openxmlformats.org/drawingml/2006/main">
+            <a:srgbClr val="FF6961"/>
+          </a:solidFill>
+          <a:ln xmlns:a="http://schemas.openxmlformats.org/drawingml/2006/main" w="19050">
+            <a:solidFill>
+              <a:srgbClr val="18223B"/>
+            </a:solidFill>
+            <a:prstDash val="solid"/>
+          </a:ln>
+        </p:spPr>
+      </p:sp>
+      <p:sp>
+        <p:nvSpPr>
+          <p:cNvPr id="11" name="">
+            <a:extLst xmlns:a="http://schemas.openxmlformats.org/drawingml/2006/main">
+              <a:ext uri="{FF2B5EF4-FFF2-40B4-BE49-F238E27FC236}">
+                <a16:creationId xmlns:a16="http://schemas.microsoft.com/office/drawing/2014/main" id="{7C7D0D7A-DC75-40DA-95AF-F67C0C7E4FD9}"/>
+              </a:ext>
+            </a:extLst>
+          </p:cNvPr>
+          <p:cNvSpPr>
+            <a:spLocks xmlns:a="http://schemas.openxmlformats.org/drawingml/2006/main" noGrp="1"/>
+          </p:cNvSpPr>
+          <p:nvPr/>
+        </p:nvSpPr>
+        <p:spPr>
+          <a:xfrm xmlns:a="http://schemas.openxmlformats.org/drawingml/2006/main">
+            <a:off x="704850" y="4981575"/>
+            <a:ext cx="514350" cy="438150"/>
+          </a:xfrm>
+          <a:prstGeom xmlns:a="http://schemas.openxmlformats.org/drawingml/2006/main" prst="rect">
+            <a:avLst/>
+          </a:prstGeom>
+          <a:noFill xmlns:a="http://schemas.openxmlformats.org/drawingml/2006/main"/>
+          <a:ln xmlns:a="http://schemas.openxmlformats.org/drawingml/2006/main" w="0">
+            <a:noFill/>
+            <a:prstDash val="solid"/>
+          </a:ln>
+        </p:spPr>
+        <p:txBody>
+          <a:bodyPr xmlns:a="http://schemas.openxmlformats.org/drawingml/2006/main" anchor="ctr"/>
+          <a:lstStyle xmlns:a="http://schemas.openxmlformats.org/drawingml/2006/main"/>
+          <a:p xmlns:a="http://schemas.openxmlformats.org/drawingml/2006/main">
+            <a:pPr>
+              <a:buNone/>
+              <a:defRPr sz="1500" b="1">
+                <a:solidFill>
+                  <a:srgbClr val="18223B"/>
+                </a:solidFill>
+              </a:defRPr>
+            </a:pPr>
+            <a:r>
+              <a:rPr sz="1500" b="1">
+                <a:solidFill>
+                  <a:srgbClr val="18223B"/>
+                </a:solidFill>
+              </a:rPr>
+              <a:t>3</a:t>
+            </a:r>
+          </a:p>
+        </p:txBody>
+      </p:sp>
+      <p:sp>
+        <p:nvSpPr>
+          <p:cNvPr id="12" name="">
+            <a:extLst xmlns:a="http://schemas.openxmlformats.org/drawingml/2006/main">
+              <a:ext uri="{FF2B5EF4-FFF2-40B4-BE49-F238E27FC236}">
+                <a16:creationId xmlns:a16="http://schemas.microsoft.com/office/drawing/2014/main" id="{888C6082-3920-417B-8BAD-DAB6DB588F9C}"/>
+              </a:ext>
+            </a:extLst>
+          </p:cNvPr>
+          <p:cNvSpPr>
+            <a:spLocks xmlns:a="http://schemas.openxmlformats.org/drawingml/2006/main" noGrp="1"/>
+          </p:cNvSpPr>
+          <p:nvPr/>
+        </p:nvSpPr>
+        <p:spPr>
+          <a:xfrm xmlns:a="http://schemas.openxmlformats.org/drawingml/2006/main">
+            <a:off x="1409700" y="4953000"/>
+            <a:ext cx="4248150" cy="514350"/>
+          </a:xfrm>
+          <a:prstGeom xmlns:a="http://schemas.openxmlformats.org/drawingml/2006/main" prst="rect">
+            <a:avLst/>
+          </a:prstGeom>
+          <a:noFill xmlns:a="http://schemas.openxmlformats.org/drawingml/2006/main"/>
+          <a:ln xmlns:a="http://schemas.openxmlformats.org/drawingml/2006/main" w="0">
+            <a:noFill/>
+            <a:prstDash val="solid"/>
+          </a:ln>
+        </p:spPr>
+        <p:txBody>
+          <a:bodyPr xmlns:a="http://schemas.openxmlformats.org/drawingml/2006/main" anchor="ctr"/>
+          <a:lstStyle xmlns:a="http://schemas.openxmlformats.org/drawingml/2006/main"/>
+          <a:p xmlns:a="http://schemas.openxmlformats.org/drawingml/2006/main">
+            <a:pPr>
+              <a:buNone/>
+              <a:defRPr sz="1725" b="1">
+                <a:solidFill>
+                  <a:srgbClr val="18223B"/>
+                </a:solidFill>
+              </a:defRPr>
+            </a:pPr>
+            <a:r>
+              <a:rPr sz="1725" b="1">
+                <a:solidFill>
+                  <a:srgbClr val="18223B"/>
+                </a:solidFill>
+              </a:rPr>
+              <a:t>Web + iOS + Android</a:t>
+            </a:r>
+          </a:p>
+        </p:txBody>
+      </p:sp>
+      <p:sp>
+        <p:nvSpPr>
+          <p:cNvPr id="13" name="">
+            <a:extLst xmlns:a="http://schemas.openxmlformats.org/drawingml/2006/main">
+              <a:ext uri="{FF2B5EF4-FFF2-40B4-BE49-F238E27FC236}">
+                <a16:creationId xmlns:a16="http://schemas.microsoft.com/office/drawing/2014/main" id="{774F2CC4-39D5-4970-86EE-2A15514C80B2}"/>
+              </a:ext>
+            </a:extLst>
+          </p:cNvPr>
+          <p:cNvSpPr>
+            <a:spLocks xmlns:a="http://schemas.openxmlformats.org/drawingml/2006/main" noGrp="1"/>
+          </p:cNvSpPr>
+          <p:nvPr/>
+        </p:nvSpPr>
+        <p:spPr>
+          <a:xfrm xmlns:a="http://schemas.openxmlformats.org/drawingml/2006/main">
+            <a:off x="7048500" y="342900"/>
+            <a:ext cx="4000500" cy="6057900"/>
+          </a:xfrm>
+          <a:prstGeom xmlns:a="http://schemas.openxmlformats.org/drawingml/2006/main" prst="roundRect">
+            <a:avLst>
+              <a:gd name="adj" fmla="val 3810"/>
+            </a:avLst>
+          </a:prstGeom>
+          <a:solidFill xmlns:a="http://schemas.openxmlformats.org/drawingml/2006/main">
+            <a:srgbClr val="315BD9"/>
+          </a:solidFill>
+          <a:ln xmlns:a="http://schemas.openxmlformats.org/drawingml/2006/main" w="38100">
+            <a:solidFill>
+              <a:srgbClr val="18223B"/>
+            </a:solidFill>
+            <a:prstDash val="solid"/>
+          </a:ln>
+        </p:spPr>
+      </p:sp>
+      <p:pic>
+        <p:nvPicPr>
+          <p:cNvPr id="32" name=""/>
+          <p:cNvPicPr>
+            <a:picLocks xmlns:a="http://schemas.openxmlformats.org/drawingml/2006/main" noChangeAspect="1"/>
+          </p:cNvPicPr>
+          <p:nvPr/>
+        </p:nvPicPr>
+        <p:blipFill>
+          <a:blip xmlns:r="http://schemas.openxmlformats.org/officeDocument/2006/relationships" xmlns:a="http://schemas.openxmlformats.org/drawingml/2006/main" r:embed="Red853db36d34452f"/>
+          <a:stretch xmlns:a="http://schemas.openxmlformats.org/drawingml/2006/main"/>
+        </p:blipFill>
+        <p:spPr>
+          <a:xfrm xmlns:a="http://schemas.openxmlformats.org/drawingml/2006/main">
+            <a:off x="7723867" y="533400"/>
+            <a:ext cx="2649767" cy="5676900"/>
+          </a:xfrm>
+          <a:prstGeom xmlns:a="http://schemas.openxmlformats.org/drawingml/2006/main" prst="rect">
+            <a:avLst/>
+          </a:prstGeom>
+        </p:spPr>
+      </p:pic>
+      <p:sp>
+        <p:nvSpPr>
+          <p:cNvPr id="15" name="">
+            <a:extLst xmlns:a="http://schemas.openxmlformats.org/drawingml/2006/main">
+              <a:ext uri="{FF2B5EF4-FFF2-40B4-BE49-F238E27FC236}">
+                <a16:creationId xmlns:a16="http://schemas.microsoft.com/office/drawing/2014/main" id="{61B6006D-CA3D-42B1-8548-951AB842D860}"/>
+              </a:ext>
+            </a:extLst>
+          </p:cNvPr>
+          <p:cNvSpPr>
+            <a:spLocks xmlns:a="http://schemas.openxmlformats.org/drawingml/2006/main" noGrp="1"/>
+          </p:cNvSpPr>
+          <p:nvPr/>
+        </p:nvSpPr>
+        <p:spPr>
+          <a:xfrm xmlns:a="http://schemas.openxmlformats.org/drawingml/2006/main">
+            <a:off x="666750" y="6381750"/>
+            <a:ext cx="1905000" cy="209550"/>
+          </a:xfrm>
+          <a:prstGeom xmlns:a="http://schemas.openxmlformats.org/drawingml/2006/main" prst="rect">
+            <a:avLst/>
+          </a:prstGeom>
+          <a:noFill xmlns:a="http://schemas.openxmlformats.org/drawingml/2006/main"/>
+          <a:ln xmlns:a="http://schemas.openxmlformats.org/drawingml/2006/main" w="0">
+            <a:noFill/>
+            <a:prstDash val="solid"/>
+          </a:ln>
+        </p:spPr>
+        <p:txBody>
+          <a:bodyPr xmlns:a="http://schemas.openxmlformats.org/drawingml/2006/main" anchor="ctr"/>
+          <a:lstStyle xmlns:a="http://schemas.openxmlformats.org/drawingml/2006/main"/>
+          <a:p xmlns:a="http://schemas.openxmlformats.org/drawingml/2006/main">
+            <a:pPr>
+              <a:buNone/>
+              <a:defRPr sz="900" b="1">
+                <a:solidFill>
+                  <a:srgbClr val="68738D"/>
+                </a:solidFill>
+              </a:defRPr>
+            </a:pPr>
+            <a:r>
+              <a:rPr sz="900" b="1">
+                <a:solidFill>
+                  <a:srgbClr val="68738D"/>
+                </a:solidFill>
+              </a:rPr>
+              <a:t>TRYTHIS.FUN</a:t>
+            </a:r>
+          </a:p>
+        </p:txBody>
+      </p:sp>
+      <p:sp>
+        <p:nvSpPr>
+          <p:cNvPr id="16" name="">
+            <a:extLst xmlns:a="http://schemas.openxmlformats.org/drawingml/2006/main">
+              <a:ext uri="{FF2B5EF4-FFF2-40B4-BE49-F238E27FC236}">
+                <a16:creationId xmlns:a16="http://schemas.microsoft.com/office/drawing/2014/main" id="{E2BD911D-0681-44E1-BAB6-BFF12F856D1C}"/>
+              </a:ext>
+            </a:extLst>
+          </p:cNvPr>
+          <p:cNvSpPr>
+            <a:spLocks xmlns:a="http://schemas.openxmlformats.org/drawingml/2006/main" noGrp="1"/>
+          </p:cNvSpPr>
+          <p:nvPr/>
+        </p:nvSpPr>
+        <p:spPr>
+          <a:xfrm xmlns:a="http://schemas.openxmlformats.org/drawingml/2006/main">
+            <a:off x="11049000" y="6381750"/>
+            <a:ext cx="457200" cy="209550"/>
+          </a:xfrm>
+          <a:prstGeom xmlns:a="http://schemas.openxmlformats.org/drawingml/2006/main" prst="rect">
+            <a:avLst/>
+          </a:prstGeom>
+          <a:noFill xmlns:a="http://schemas.openxmlformats.org/drawingml/2006/main"/>
+          <a:ln xmlns:a="http://schemas.openxmlformats.org/drawingml/2006/main" w="0">
+            <a:noFill/>
+            <a:prstDash val="solid"/>
+          </a:ln>
+        </p:spPr>
+        <p:txBody>
+          <a:bodyPr xmlns:a="http://schemas.openxmlformats.org/drawingml/2006/main" anchor="ctr"/>
+          <a:lstStyle xmlns:a="http://schemas.openxmlformats.org/drawingml/2006/main"/>
+          <a:p xmlns:a="http://schemas.openxmlformats.org/drawingml/2006/main">
+            <a:pPr>
+              <a:buNone/>
+              <a:defRPr sz="900" b="1">
+                <a:solidFill>
+                  <a:srgbClr val="68738D"/>
+                </a:solidFill>
+              </a:defRPr>
+            </a:pPr>
+            <a:r>
+              <a:rPr sz="900" b="1">
+                <a:solidFill>
+                  <a:srgbClr val="68738D"/>
+                </a:solidFill>
+              </a:rPr>
+              <a:t>05</a:t>
+            </a:r>
+          </a:p>
+        </p:txBody>
+      </p:sp>
+    </p:spTree>
+    <p:extLst>
+      <p:ext uri="{BB962C8B-B14F-4D97-AF65-F5344CB8AC3E}">
+        <p14:creationId xmlns:p14="http://schemas.microsoft.com/office/powerpoint/2010/main" val="1189919713"/>
+      </p:ext>
+    </p:extLst>
+  </p:cSld>
+</p:sld>
+</file>
+
+<file path=ppt/slides/slide6.xml><?xml version="1.0" encoding="utf-8"?>
+<p:sld xmlns:p="http://schemas.openxmlformats.org/presentationml/2006/main">
+  <p:cSld>
+    <p:bg>
+      <p:bgPr>
+        <a:solidFill xmlns:a="http://schemas.openxmlformats.org/drawingml/2006/main">
+          <a:srgbClr val="18223B"/>
+        </a:solidFill>
+      </p:bgPr>
+    </p:bg>
+    <p:spTree>
+      <p:nvGrpSpPr>
+        <p:cNvPr id="1" name=""/>
+        <p:cNvGrpSpPr/>
+        <p:nvPr/>
+      </p:nvGrpSpPr>
+      <p:grpSpPr>
+        <a:xfrm xmlns:a="http://schemas.openxmlformats.org/drawingml/2006/main"/>
+      </p:grpSpPr>
+      <p:sp>
+        <p:nvSpPr>
+          <p:cNvPr id="20" name="">
+            <a:extLst xmlns:a="http://schemas.openxmlformats.org/drawingml/2006/main">
+              <a:ext uri="{FF2B5EF4-FFF2-40B4-BE49-F238E27FC236}">
+                <a16:creationId xmlns:a16="http://schemas.microsoft.com/office/drawing/2014/main" id="{E80225A7-3373-4FD5-ABA0-E592DBD5103C}"/>
+              </a:ext>
+            </a:extLst>
+          </p:cNvPr>
+          <p:cNvSpPr>
+            <a:spLocks xmlns:a="http://schemas.openxmlformats.org/drawingml/2006/main" noGrp="1"/>
+          </p:cNvSpPr>
+          <p:nvPr/>
+        </p:nvSpPr>
+        <p:spPr>
+          <a:xfrm xmlns:a="http://schemas.openxmlformats.org/drawingml/2006/main">
+            <a:off x="533400" y="400050"/>
+            <a:ext cx="3962400" cy="6076950"/>
+          </a:xfrm>
+          <a:prstGeom xmlns:a="http://schemas.openxmlformats.org/drawingml/2006/main" prst="roundRect">
+            <a:avLst>
+              <a:gd name="adj" fmla="val 3846"/>
+            </a:avLst>
+          </a:prstGeom>
+          <a:solidFill xmlns:a="http://schemas.openxmlformats.org/drawingml/2006/main">
+            <a:srgbClr val="FFFDF6"/>
+          </a:solidFill>
+          <a:ln xmlns:a="http://schemas.openxmlformats.org/drawingml/2006/main" w="0">
+            <a:solidFill>
+              <a:srgbClr val="FFFDF6"/>
+            </a:solidFill>
+            <a:prstDash val="solid"/>
+          </a:ln>
+        </p:spPr>
+      </p:sp>
+      <p:pic>
+        <p:nvPicPr>
+          <p:cNvPr id="23" name=""/>
+          <p:cNvPicPr>
+            <a:picLocks xmlns:a="http://schemas.openxmlformats.org/drawingml/2006/main" noChangeAspect="1"/>
+          </p:cNvPicPr>
+          <p:nvPr/>
+        </p:nvPicPr>
+        <p:blipFill>
+          <a:blip xmlns:r="http://schemas.openxmlformats.org/officeDocument/2006/relationships" xmlns:a="http://schemas.openxmlformats.org/drawingml/2006/main" r:embed="R8f4ff5e76d554a84"/>
+          <a:stretch xmlns:a="http://schemas.openxmlformats.org/drawingml/2006/main"/>
+        </p:blipFill>
+        <p:spPr>
+          <a:xfrm xmlns:a="http://schemas.openxmlformats.org/drawingml/2006/main">
+            <a:off x="1112211" y="552450"/>
+            <a:ext cx="2804777" cy="5772150"/>
+          </a:xfrm>
+          <a:prstGeom xmlns:a="http://schemas.openxmlformats.org/drawingml/2006/main" prst="rect">
+            <a:avLst/>
+          </a:prstGeom>
+        </p:spPr>
+      </p:pic>
+      <p:sp>
+        <p:nvSpPr>
+          <p:cNvPr id="3" name="">
+            <a:extLst xmlns:a="http://schemas.openxmlformats.org/drawingml/2006/main">
+              <a:ext uri="{FF2B5EF4-FFF2-40B4-BE49-F238E27FC236}">
+                <a16:creationId xmlns:a16="http://schemas.microsoft.com/office/drawing/2014/main" id="{EA7E3670-D82D-4DFC-9ED3-17F9B1DC5692}"/>
+              </a:ext>
+            </a:extLst>
+          </p:cNvPr>
+          <p:cNvSpPr>
+            <a:spLocks xmlns:a="http://schemas.openxmlformats.org/drawingml/2006/main" noGrp="1"/>
+          </p:cNvSpPr>
+          <p:nvPr/>
+        </p:nvSpPr>
+        <p:spPr>
+          <a:xfrm xmlns:a="http://schemas.openxmlformats.org/drawingml/2006/main">
+            <a:off x="5105400" y="685800"/>
+            <a:ext cx="3143250" cy="266700"/>
+          </a:xfrm>
+          <a:prstGeom xmlns:a="http://schemas.openxmlformats.org/drawingml/2006/main" prst="rect">
+            <a:avLst/>
+          </a:prstGeom>
+          <a:noFill xmlns:a="http://schemas.openxmlformats.org/drawingml/2006/main"/>
+          <a:ln xmlns:a="http://schemas.openxmlformats.org/drawingml/2006/main" w="0">
+            <a:noFill/>
+            <a:prstDash val="solid"/>
+          </a:ln>
+        </p:spPr>
+        <p:txBody>
+          <a:bodyPr xmlns:a="http://schemas.openxmlformats.org/drawingml/2006/main" anchor="ctr"/>
+          <a:lstStyle xmlns:a="http://schemas.openxmlformats.org/drawingml/2006/main"/>
+          <a:p xmlns:a="http://schemas.openxmlformats.org/drawingml/2006/main">
+            <a:pPr>
+              <a:buNone/>
+              <a:defRPr sz="1125" b="1">
+                <a:solidFill>
+                  <a:srgbClr val="FFD55A"/>
+                </a:solidFill>
+              </a:defRPr>
+            </a:pPr>
+            <a:r>
+              <a:rPr sz="1125" b="1">
+                <a:solidFill>
+                  <a:srgbClr val="FFD55A"/>
+                </a:solidFill>
+              </a:rPr>
+              <a:t>THE TECHNICAL MOAT</a:t>
+            </a:r>
+          </a:p>
+        </p:txBody>
+      </p:sp>
+      <p:sp>
+        <p:nvSpPr>
+          <p:cNvPr id="4" name="">
+            <a:extLst xmlns:a="http://schemas.openxmlformats.org/drawingml/2006/main">
+              <a:ext uri="{FF2B5EF4-FFF2-40B4-BE49-F238E27FC236}">
+                <a16:creationId xmlns:a16="http://schemas.microsoft.com/office/drawing/2014/main" id="{C789A1E6-7230-457D-84EB-2E27241CEBDB}"/>
+              </a:ext>
+            </a:extLst>
+          </p:cNvPr>
+          <p:cNvSpPr>
+            <a:spLocks xmlns:a="http://schemas.openxmlformats.org/drawingml/2006/main" noGrp="1"/>
+          </p:cNvSpPr>
+          <p:nvPr/>
+        </p:nvSpPr>
+        <p:spPr>
+          <a:xfrm xmlns:a="http://schemas.openxmlformats.org/drawingml/2006/main">
+            <a:off x="5067300" y="1066800"/>
+            <a:ext cx="6381750" cy="1200150"/>
+          </a:xfrm>
+          <a:prstGeom xmlns:a="http://schemas.openxmlformats.org/drawingml/2006/main" prst="rect">
+            <a:avLst/>
+          </a:prstGeom>
+          <a:noFill xmlns:a="http://schemas.openxmlformats.org/drawingml/2006/main"/>
+          <a:ln xmlns:a="http://schemas.openxmlformats.org/drawingml/2006/main" w="0">
+            <a:noFill/>
+            <a:prstDash val="solid"/>
+          </a:ln>
+        </p:spPr>
+        <p:txBody>
+          <a:bodyPr xmlns:a="http://schemas.openxmlformats.org/drawingml/2006/main" anchor="ctr"/>
+          <a:lstStyle xmlns:a="http://schemas.openxmlformats.org/drawingml/2006/main"/>
+          <a:p xmlns:a="http://schemas.openxmlformats.org/drawingml/2006/main">
+            <a:pPr>
+              <a:buNone/>
+              <a:defRPr sz="3300" b="1">
+                <a:solidFill>
+                  <a:srgbClr val="FFFDF6"/>
+                </a:solidFill>
+              </a:defRPr>
+            </a:pPr>
+            <a:r>
+              <a:rPr sz="3300" b="1">
+                <a:solidFill>
+                  <a:srgbClr val="FFFDF6"/>
+                </a:solidFill>
+              </a:rPr>
+              <a:t>The catalog is</a:t>
+            </a:r>
+          </a:p>
+          <a:p xmlns:a="http://schemas.openxmlformats.org/drawingml/2006/main">
+            <a:pPr>
+              <a:buNone/>
+              <a:defRPr sz="3300" b="1">
+                <a:solidFill>
+                  <a:srgbClr val="FFFDF6"/>
+                </a:solidFill>
+              </a:defRPr>
+            </a:pPr>
+            <a:r>
+              <a:rPr sz="3300" b="1">
+                <a:solidFill>
+                  <a:srgbClr val="FFFDF6"/>
+                </a:solidFill>
+              </a:rPr>
+              <a:t>the compounding asset.</a:t>
+            </a:r>
+          </a:p>
+        </p:txBody>
+      </p:sp>
+      <p:sp>
+        <p:nvSpPr>
+          <p:cNvPr id="5" name="">
+            <a:extLst xmlns:a="http://schemas.openxmlformats.org/drawingml/2006/main">
+              <a:ext uri="{FF2B5EF4-FFF2-40B4-BE49-F238E27FC236}">
+                <a16:creationId xmlns:a16="http://schemas.microsoft.com/office/drawing/2014/main" id="{FF734BFB-7848-4565-9EE4-5F9CE528F392}"/>
+              </a:ext>
+            </a:extLst>
+          </p:cNvPr>
+          <p:cNvSpPr>
+            <a:spLocks xmlns:a="http://schemas.openxmlformats.org/drawingml/2006/main" noGrp="1"/>
+          </p:cNvSpPr>
+          <p:nvPr/>
+        </p:nvSpPr>
+        <p:spPr>
+          <a:xfrm xmlns:a="http://schemas.openxmlformats.org/drawingml/2006/main">
+            <a:off x="5105400" y="2343150"/>
+            <a:ext cx="5905500" cy="723900"/>
+          </a:xfrm>
+          <a:prstGeom xmlns:a="http://schemas.openxmlformats.org/drawingml/2006/main" prst="rect">
+            <a:avLst/>
+          </a:prstGeom>
+          <a:noFill xmlns:a="http://schemas.openxmlformats.org/drawingml/2006/main"/>
+          <a:ln xmlns:a="http://schemas.openxmlformats.org/drawingml/2006/main" w="0">
+            <a:noFill/>
+            <a:prstDash val="solid"/>
+          </a:ln>
+        </p:spPr>
+        <p:txBody>
+          <a:bodyPr xmlns:a="http://schemas.openxmlformats.org/drawingml/2006/main" anchor="ctr"/>
+          <a:lstStyle xmlns:a="http://schemas.openxmlformats.org/drawingml/2006/main"/>
+          <a:p xmlns:a="http://schemas.openxmlformats.org/drawingml/2006/main">
+            <a:pPr>
+              <a:buNone/>
+              <a:defRPr sz="1575" b="0">
+                <a:solidFill>
+                  <a:srgbClr val="C9D2EA"/>
+                </a:solidFill>
+              </a:defRPr>
+            </a:pPr>
+            <a:r>
+              <a:rPr sz="1575" b="0">
+                <a:solidFill>
+                  <a:srgbClr val="C9D2EA"/>
+                </a:solidFill>
+              </a:rPr>
+              <a:t>The hard work happens before a card reaches a family:</a:t>
+            </a:r>
+          </a:p>
+        </p:txBody>
+      </p:sp>
+      <p:sp>
+        <p:nvSpPr>
+          <p:cNvPr id="6" name="">
+            <a:extLst xmlns:a="http://schemas.openxmlformats.org/drawingml/2006/main">
+              <a:ext uri="{FF2B5EF4-FFF2-40B4-BE49-F238E27FC236}">
+                <a16:creationId xmlns:a16="http://schemas.microsoft.com/office/drawing/2014/main" id="{B8C14E4D-4D23-4D7F-9C1A-FE1DB558F95A}"/>
+              </a:ext>
+            </a:extLst>
+          </p:cNvPr>
+          <p:cNvSpPr>
+            <a:spLocks xmlns:a="http://schemas.openxmlformats.org/drawingml/2006/main" noGrp="1"/>
+          </p:cNvSpPr>
+          <p:nvPr/>
+        </p:nvSpPr>
+        <p:spPr>
+          <a:xfrm xmlns:a="http://schemas.openxmlformats.org/drawingml/2006/main">
+            <a:off x="5105400" y="3305175"/>
+            <a:ext cx="400050" cy="400050"/>
+          </a:xfrm>
+          <a:prstGeom xmlns:a="http://schemas.openxmlformats.org/drawingml/2006/main" prst="ellipse">
+            <a:avLst/>
+          </a:prstGeom>
+          <a:solidFill xmlns:a="http://schemas.openxmlformats.org/drawingml/2006/main">
+            <a:srgbClr val="FFD55A"/>
+          </a:solidFill>
+          <a:ln xmlns:a="http://schemas.openxmlformats.org/drawingml/2006/main" w="19050">
+            <a:solidFill>
+              <a:srgbClr val="18223B"/>
+            </a:solidFill>
+            <a:prstDash val="solid"/>
+          </a:ln>
+        </p:spPr>
+      </p:sp>
+      <p:sp>
+        <p:nvSpPr>
+          <p:cNvPr id="7" name="">
+            <a:extLst xmlns:a="http://schemas.openxmlformats.org/drawingml/2006/main">
+              <a:ext uri="{FF2B5EF4-FFF2-40B4-BE49-F238E27FC236}">
+                <a16:creationId xmlns:a16="http://schemas.microsoft.com/office/drawing/2014/main" id="{D9A289F3-16E1-4D1C-92A2-C02C12300026}"/>
+              </a:ext>
+            </a:extLst>
+          </p:cNvPr>
+          <p:cNvSpPr>
+            <a:spLocks xmlns:a="http://schemas.openxmlformats.org/drawingml/2006/main" noGrp="1"/>
+          </p:cNvSpPr>
+          <p:nvPr/>
+        </p:nvSpPr>
+        <p:spPr>
+          <a:xfrm xmlns:a="http://schemas.openxmlformats.org/drawingml/2006/main">
+            <a:off x="5105400" y="3324225"/>
+            <a:ext cx="400050" cy="323850"/>
+          </a:xfrm>
+          <a:prstGeom xmlns:a="http://schemas.openxmlformats.org/drawingml/2006/main" prst="rect">
+            <a:avLst/>
+          </a:prstGeom>
+          <a:noFill xmlns:a="http://schemas.openxmlformats.org/drawingml/2006/main"/>
+          <a:ln xmlns:a="http://schemas.openxmlformats.org/drawingml/2006/main" w="0">
+            <a:noFill/>
+            <a:prstDash val="solid"/>
+          </a:ln>
+        </p:spPr>
+        <p:txBody>
+          <a:bodyPr xmlns:a="http://schemas.openxmlformats.org/drawingml/2006/main" anchor="ctr"/>
+          <a:lstStyle xmlns:a="http://schemas.openxmlformats.org/drawingml/2006/main"/>
+          <a:p xmlns:a="http://schemas.openxmlformats.org/drawingml/2006/main">
+            <a:pPr>
+              <a:buNone/>
+              <a:defRPr sz="1275" b="1">
+                <a:solidFill>
+                  <a:srgbClr val="18223B"/>
+                </a:solidFill>
+              </a:defRPr>
+            </a:pPr>
+            <a:r>
+              <a:rPr sz="1275" b="1">
+                <a:solidFill>
+                  <a:srgbClr val="18223B"/>
+                </a:solidFill>
+              </a:rPr>
+              <a:t>✓</a:t>
+            </a:r>
+          </a:p>
+        </p:txBody>
+      </p:sp>
+      <p:sp>
+        <p:nvSpPr>
+          <p:cNvPr id="8" name="">
+            <a:extLst xmlns:a="http://schemas.openxmlformats.org/drawingml/2006/main">
+              <a:ext uri="{FF2B5EF4-FFF2-40B4-BE49-F238E27FC236}">
+                <a16:creationId xmlns:a16="http://schemas.microsoft.com/office/drawing/2014/main" id="{14ED3BE8-CA97-4FA1-9E9D-3832306E41F8}"/>
+              </a:ext>
+            </a:extLst>
+          </p:cNvPr>
+          <p:cNvSpPr>
+            <a:spLocks xmlns:a="http://schemas.openxmlformats.org/drawingml/2006/main" noGrp="1"/>
+          </p:cNvSpPr>
+          <p:nvPr/>
+        </p:nvSpPr>
+        <p:spPr>
+          <a:xfrm xmlns:a="http://schemas.openxmlformats.org/drawingml/2006/main">
+            <a:off x="5695950" y="3257550"/>
+            <a:ext cx="5238750" cy="323850"/>
+          </a:xfrm>
+          <a:prstGeom xmlns:a="http://schemas.openxmlformats.org/drawingml/2006/main" prst="rect">
+            <a:avLst/>
+          </a:prstGeom>
+          <a:noFill xmlns:a="http://schemas.openxmlformats.org/drawingml/2006/main"/>
+          <a:ln xmlns:a="http://schemas.openxmlformats.org/drawingml/2006/main" w="0">
+            <a:noFill/>
+            <a:prstDash val="solid"/>
+          </a:ln>
+        </p:spPr>
+        <p:txBody>
+          <a:bodyPr xmlns:a="http://schemas.openxmlformats.org/drawingml/2006/main" anchor="ctr"/>
+          <a:lstStyle xmlns:a="http://schemas.openxmlformats.org/drawingml/2006/main"/>
+          <a:p xmlns:a="http://schemas.openxmlformats.org/drawingml/2006/main">
+            <a:pPr>
+              <a:buNone/>
+              <a:defRPr sz="1650" b="1">
+                <a:solidFill>
+                  <a:srgbClr val="FFFDF6"/>
+                </a:solidFill>
+              </a:defRPr>
+            </a:pPr>
+            <a:r>
+              <a:rPr sz="1650" b="1">
+                <a:solidFill>
+                  <a:srgbClr val="FFFDF6"/>
+                </a:solidFill>
+              </a:rPr>
+              <a:t>A shared typed schema</a:t>
+            </a:r>
+          </a:p>
+        </p:txBody>
+      </p:sp>
+      <p:sp>
+        <p:nvSpPr>
+          <p:cNvPr id="9" name="">
+            <a:extLst xmlns:a="http://schemas.openxmlformats.org/drawingml/2006/main">
+              <a:ext uri="{FF2B5EF4-FFF2-40B4-BE49-F238E27FC236}">
+                <a16:creationId xmlns:a16="http://schemas.microsoft.com/office/drawing/2014/main" id="{3CC433F9-F986-4F24-9A1F-95BE266566E9}"/>
+              </a:ext>
+            </a:extLst>
+          </p:cNvPr>
+          <p:cNvSpPr>
+            <a:spLocks xmlns:a="http://schemas.openxmlformats.org/drawingml/2006/main" noGrp="1"/>
+          </p:cNvSpPr>
+          <p:nvPr/>
+        </p:nvSpPr>
+        <p:spPr>
+          <a:xfrm xmlns:a="http://schemas.openxmlformats.org/drawingml/2006/main">
+            <a:off x="5695950" y="3581400"/>
+            <a:ext cx="5238750" cy="304800"/>
+          </a:xfrm>
+          <a:prstGeom xmlns:a="http://schemas.openxmlformats.org/drawingml/2006/main" prst="rect">
+            <a:avLst/>
+          </a:prstGeom>
+          <a:noFill xmlns:a="http://schemas.openxmlformats.org/drawingml/2006/main"/>
+          <a:ln xmlns:a="http://schemas.openxmlformats.org/drawingml/2006/main" w="0">
+            <a:noFill/>
+            <a:prstDash val="solid"/>
+          </a:ln>
+        </p:spPr>
+        <p:txBody>
+          <a:bodyPr xmlns:a="http://schemas.openxmlformats.org/drawingml/2006/main" anchor="ctr"/>
+          <a:lstStyle xmlns:a="http://schemas.openxmlformats.org/drawingml/2006/main"/>
+          <a:p xmlns:a="http://schemas.openxmlformats.org/drawingml/2006/main">
+            <a:pPr>
+              <a:buNone/>
+              <a:defRPr sz="1200" b="0">
+                <a:solidFill>
+                  <a:srgbClr val="C9D2EA"/>
+                </a:solidFill>
+              </a:defRPr>
+            </a:pPr>
+            <a:r>
+              <a:rPr sz="1200" b="0">
+                <a:solidFill>
+                  <a:srgbClr val="C9D2EA"/>
+                </a:solidFill>
+              </a:rPr>
+              <a:t>One reviewed catalog across every platform.</a:t>
+            </a:r>
+          </a:p>
+        </p:txBody>
+      </p:sp>
+      <p:sp>
+        <p:nvSpPr>
+          <p:cNvPr id="10" name="">
+            <a:extLst xmlns:a="http://schemas.openxmlformats.org/drawingml/2006/main">
+              <a:ext uri="{FF2B5EF4-FFF2-40B4-BE49-F238E27FC236}">
+                <a16:creationId xmlns:a16="http://schemas.microsoft.com/office/drawing/2014/main" id="{BA9F958E-8B37-4BB9-83C1-6EEFC56C7E96}"/>
+              </a:ext>
+            </a:extLst>
+          </p:cNvPr>
+          <p:cNvSpPr>
+            <a:spLocks xmlns:a="http://schemas.openxmlformats.org/drawingml/2006/main" noGrp="1"/>
+          </p:cNvSpPr>
+          <p:nvPr/>
+        </p:nvSpPr>
+        <p:spPr>
+          <a:xfrm xmlns:a="http://schemas.openxmlformats.org/drawingml/2006/main">
+            <a:off x="5105400" y="4181475"/>
+            <a:ext cx="400050" cy="400050"/>
+          </a:xfrm>
+          <a:prstGeom xmlns:a="http://schemas.openxmlformats.org/drawingml/2006/main" prst="ellipse">
+            <a:avLst/>
+          </a:prstGeom>
+          <a:solidFill xmlns:a="http://schemas.openxmlformats.org/drawingml/2006/main">
+            <a:srgbClr val="68D6B1"/>
+          </a:solidFill>
+          <a:ln xmlns:a="http://schemas.openxmlformats.org/drawingml/2006/main" w="19050">
+            <a:solidFill>
+              <a:srgbClr val="18223B"/>
+            </a:solidFill>
+            <a:prstDash val="solid"/>
+          </a:ln>
+        </p:spPr>
+      </p:sp>
+      <p:sp>
+        <p:nvSpPr>
+          <p:cNvPr id="11" name="">
+            <a:extLst xmlns:a="http://schemas.openxmlformats.org/drawingml/2006/main">
+              <a:ext uri="{FF2B5EF4-FFF2-40B4-BE49-F238E27FC236}">
+                <a16:creationId xmlns:a16="http://schemas.microsoft.com/office/drawing/2014/main" id="{82EE2B12-16F9-4FD1-ABE9-B09BF87DCD7E}"/>
+              </a:ext>
+            </a:extLst>
+          </p:cNvPr>
+          <p:cNvSpPr>
+            <a:spLocks xmlns:a="http://schemas.openxmlformats.org/drawingml/2006/main" noGrp="1"/>
+          </p:cNvSpPr>
+          <p:nvPr/>
+        </p:nvSpPr>
+        <p:spPr>
+          <a:xfrm xmlns:a="http://schemas.openxmlformats.org/drawingml/2006/main">
+            <a:off x="5105400" y="4200525"/>
+            <a:ext cx="400050" cy="323850"/>
+          </a:xfrm>
+          <a:prstGeom xmlns:a="http://schemas.openxmlformats.org/drawingml/2006/main" prst="rect">
+            <a:avLst/>
+          </a:prstGeom>
+          <a:noFill xmlns:a="http://schemas.openxmlformats.org/drawingml/2006/main"/>
+          <a:ln xmlns:a="http://schemas.openxmlformats.org/drawingml/2006/main" w="0">
+            <a:noFill/>
+            <a:prstDash val="solid"/>
+          </a:ln>
+        </p:spPr>
+        <p:txBody>
+          <a:bodyPr xmlns:a="http://schemas.openxmlformats.org/drawingml/2006/main" anchor="ctr"/>
+          <a:lstStyle xmlns:a="http://schemas.openxmlformats.org/drawingml/2006/main"/>
+          <a:p xmlns:a="http://schemas.openxmlformats.org/drawingml/2006/main">
+            <a:pPr>
+              <a:buNone/>
+              <a:defRPr sz="1275" b="1">
+                <a:solidFill>
+                  <a:srgbClr val="18223B"/>
+                </a:solidFill>
+              </a:defRPr>
+            </a:pPr>
+            <a:r>
+              <a:rPr sz="1275" b="1">
+                <a:solidFill>
+                  <a:srgbClr val="18223B"/>
+                </a:solidFill>
+              </a:rPr>
+              <a:t>✓</a:t>
+            </a:r>
+          </a:p>
+        </p:txBody>
+      </p:sp>
+      <p:sp>
+        <p:nvSpPr>
+          <p:cNvPr id="12" name="">
+            <a:extLst xmlns:a="http://schemas.openxmlformats.org/drawingml/2006/main">
+              <a:ext uri="{FF2B5EF4-FFF2-40B4-BE49-F238E27FC236}">
+                <a16:creationId xmlns:a16="http://schemas.microsoft.com/office/drawing/2014/main" id="{8B7D8118-8BAD-4F24-8D9B-34ABD1C88A69}"/>
+              </a:ext>
+            </a:extLst>
+          </p:cNvPr>
+          <p:cNvSpPr>
+            <a:spLocks xmlns:a="http://schemas.openxmlformats.org/drawingml/2006/main" noGrp="1"/>
+          </p:cNvSpPr>
+          <p:nvPr/>
+        </p:nvSpPr>
+        <p:spPr>
+          <a:xfrm xmlns:a="http://schemas.openxmlformats.org/drawingml/2006/main">
+            <a:off x="5695950" y="4133850"/>
+            <a:ext cx="5238750" cy="323850"/>
+          </a:xfrm>
+          <a:prstGeom xmlns:a="http://schemas.openxmlformats.org/drawingml/2006/main" prst="rect">
+            <a:avLst/>
+          </a:prstGeom>
+          <a:noFill xmlns:a="http://schemas.openxmlformats.org/drawingml/2006/main"/>
+          <a:ln xmlns:a="http://schemas.openxmlformats.org/drawingml/2006/main" w="0">
+            <a:noFill/>
+            <a:prstDash val="solid"/>
+          </a:ln>
+        </p:spPr>
+        <p:txBody>
+          <a:bodyPr xmlns:a="http://schemas.openxmlformats.org/drawingml/2006/main" anchor="ctr"/>
+          <a:lstStyle xmlns:a="http://schemas.openxmlformats.org/drawingml/2006/main"/>
+          <a:p xmlns:a="http://schemas.openxmlformats.org/drawingml/2006/main">
+            <a:pPr>
+              <a:buNone/>
+              <a:defRPr sz="1650" b="1">
+                <a:solidFill>
+                  <a:srgbClr val="FFFDF6"/>
+                </a:solidFill>
+              </a:defRPr>
+            </a:pPr>
+            <a:r>
+              <a:rPr sz="1650" b="1">
+                <a:solidFill>
+                  <a:srgbClr val="FFFDF6"/>
+                </a:solidFill>
+              </a:rPr>
+              <a:t>Explainable matching</a:t>
+            </a:r>
+          </a:p>
+        </p:txBody>
+      </p:sp>
+      <p:sp>
+        <p:nvSpPr>
+          <p:cNvPr id="13" name="">
+            <a:extLst xmlns:a="http://schemas.openxmlformats.org/drawingml/2006/main">
+              <a:ext uri="{FF2B5EF4-FFF2-40B4-BE49-F238E27FC236}">
+                <a16:creationId xmlns:a16="http://schemas.microsoft.com/office/drawing/2014/main" id="{0073711F-075D-4FF4-841B-F6FDC487497A}"/>
+              </a:ext>
+            </a:extLst>
+          </p:cNvPr>
+          <p:cNvSpPr>
+            <a:spLocks xmlns:a="http://schemas.openxmlformats.org/drawingml/2006/main" noGrp="1"/>
+          </p:cNvSpPr>
+          <p:nvPr/>
+        </p:nvSpPr>
+        <p:spPr>
+          <a:xfrm xmlns:a="http://schemas.openxmlformats.org/drawingml/2006/main">
+            <a:off x="5695950" y="4457700"/>
+            <a:ext cx="5238750" cy="304800"/>
+          </a:xfrm>
+          <a:prstGeom xmlns:a="http://schemas.openxmlformats.org/drawingml/2006/main" prst="rect">
+            <a:avLst/>
+          </a:prstGeom>
+          <a:noFill xmlns:a="http://schemas.openxmlformats.org/drawingml/2006/main"/>
+          <a:ln xmlns:a="http://schemas.openxmlformats.org/drawingml/2006/main" w="0">
+            <a:noFill/>
+            <a:prstDash val="solid"/>
+          </a:ln>
+        </p:spPr>
+        <p:txBody>
+          <a:bodyPr xmlns:a="http://schemas.openxmlformats.org/drawingml/2006/main" anchor="ctr"/>
+          <a:lstStyle xmlns:a="http://schemas.openxmlformats.org/drawingml/2006/main"/>
+          <a:p xmlns:a="http://schemas.openxmlformats.org/drawingml/2006/main">
+            <a:pPr>
+              <a:buNone/>
+              <a:defRPr sz="1200" b="0">
+                <a:solidFill>
+                  <a:srgbClr val="C9D2EA"/>
+                </a:solidFill>
+              </a:defRPr>
+            </a:pPr>
+            <a:r>
+              <a:rPr sz="1200" b="0">
+                <a:solidFill>
+                  <a:srgbClr val="C9D2EA"/>
+                </a:solidFill>
+              </a:rPr>
+              <a:t>Hard constraints, safe fallback, fresh shuffle.</a:t>
+            </a:r>
+          </a:p>
+        </p:txBody>
+      </p:sp>
+      <p:sp>
+        <p:nvSpPr>
+          <p:cNvPr id="14" name="">
+            <a:extLst xmlns:a="http://schemas.openxmlformats.org/drawingml/2006/main">
+              <a:ext uri="{FF2B5EF4-FFF2-40B4-BE49-F238E27FC236}">
+                <a16:creationId xmlns:a16="http://schemas.microsoft.com/office/drawing/2014/main" id="{A4D08C4E-3DE5-4A03-95A3-E75CAA91FD3D}"/>
+              </a:ext>
+            </a:extLst>
+          </p:cNvPr>
+          <p:cNvSpPr>
+            <a:spLocks xmlns:a="http://schemas.openxmlformats.org/drawingml/2006/main" noGrp="1"/>
+          </p:cNvSpPr>
+          <p:nvPr/>
+        </p:nvSpPr>
+        <p:spPr>
+          <a:xfrm xmlns:a="http://schemas.openxmlformats.org/drawingml/2006/main">
+            <a:off x="5105400" y="5057775"/>
+            <a:ext cx="400050" cy="400050"/>
+          </a:xfrm>
+          <a:prstGeom xmlns:a="http://schemas.openxmlformats.org/drawingml/2006/main" prst="ellipse">
+            <a:avLst/>
+          </a:prstGeom>
+          <a:solidFill xmlns:a="http://schemas.openxmlformats.org/drawingml/2006/main">
+            <a:srgbClr val="A98BEA"/>
+          </a:solidFill>
+          <a:ln xmlns:a="http://schemas.openxmlformats.org/drawingml/2006/main" w="19050">
+            <a:solidFill>
+              <a:srgbClr val="18223B"/>
+            </a:solidFill>
+            <a:prstDash val="solid"/>
+          </a:ln>
+        </p:spPr>
+      </p:sp>
+      <p:sp>
+        <p:nvSpPr>
+          <p:cNvPr id="15" name="">
+            <a:extLst xmlns:a="http://schemas.openxmlformats.org/drawingml/2006/main">
+              <a:ext uri="{FF2B5EF4-FFF2-40B4-BE49-F238E27FC236}">
+                <a16:creationId xmlns:a16="http://schemas.microsoft.com/office/drawing/2014/main" id="{D8D27936-1A0A-41EA-A755-BA43AF16C11B}"/>
+              </a:ext>
+            </a:extLst>
+          </p:cNvPr>
+          <p:cNvSpPr>
+            <a:spLocks xmlns:a="http://schemas.openxmlformats.org/drawingml/2006/main" noGrp="1"/>
+          </p:cNvSpPr>
+          <p:nvPr/>
+        </p:nvSpPr>
+        <p:spPr>
+          <a:xfrm xmlns:a="http://schemas.openxmlformats.org/drawingml/2006/main">
+            <a:off x="5105400" y="5076825"/>
+            <a:ext cx="400050" cy="323850"/>
+          </a:xfrm>
+          <a:prstGeom xmlns:a="http://schemas.openxmlformats.org/drawingml/2006/main" prst="rect">
+            <a:avLst/>
+          </a:prstGeom>
+          <a:noFill xmlns:a="http://schemas.openxmlformats.org/drawingml/2006/main"/>
+          <a:ln xmlns:a="http://schemas.openxmlformats.org/drawingml/2006/main" w="0">
+            <a:noFill/>
+            <a:prstDash val="solid"/>
+          </a:ln>
+        </p:spPr>
+        <p:txBody>
+          <a:bodyPr xmlns:a="http://schemas.openxmlformats.org/drawingml/2006/main" anchor="ctr"/>
+          <a:lstStyle xmlns:a="http://schemas.openxmlformats.org/drawingml/2006/main"/>
+          <a:p xmlns:a="http://schemas.openxmlformats.org/drawingml/2006/main">
+            <a:pPr>
+              <a:buNone/>
+              <a:defRPr sz="1275" b="1">
+                <a:solidFill>
+                  <a:srgbClr val="18223B"/>
+                </a:solidFill>
+              </a:defRPr>
+            </a:pPr>
+            <a:r>
+              <a:rPr sz="1275" b="1">
+                <a:solidFill>
+                  <a:srgbClr val="18223B"/>
+                </a:solidFill>
+              </a:rPr>
+              <a:t>✓</a:t>
+            </a:r>
+          </a:p>
+        </p:txBody>
+      </p:sp>
+      <p:sp>
+        <p:nvSpPr>
+          <p:cNvPr id="16" name="">
+            <a:extLst xmlns:a="http://schemas.openxmlformats.org/drawingml/2006/main">
+              <a:ext uri="{FF2B5EF4-FFF2-40B4-BE49-F238E27FC236}">
+                <a16:creationId xmlns:a16="http://schemas.microsoft.com/office/drawing/2014/main" id="{0ACA57C2-83E5-44A3-9B39-B0C08C4954BD}"/>
+              </a:ext>
+            </a:extLst>
+          </p:cNvPr>
+          <p:cNvSpPr>
+            <a:spLocks xmlns:a="http://schemas.openxmlformats.org/drawingml/2006/main" noGrp="1"/>
+          </p:cNvSpPr>
+          <p:nvPr/>
+        </p:nvSpPr>
+        <p:spPr>
+          <a:xfrm xmlns:a="http://schemas.openxmlformats.org/drawingml/2006/main">
+            <a:off x="5695950" y="5010150"/>
+            <a:ext cx="5238750" cy="323850"/>
+          </a:xfrm>
+          <a:prstGeom xmlns:a="http://schemas.openxmlformats.org/drawingml/2006/main" prst="rect">
+            <a:avLst/>
+          </a:prstGeom>
+          <a:noFill xmlns:a="http://schemas.openxmlformats.org/drawingml/2006/main"/>
+          <a:ln xmlns:a="http://schemas.openxmlformats.org/drawingml/2006/main" w="0">
+            <a:noFill/>
+            <a:prstDash val="solid"/>
+          </a:ln>
+        </p:spPr>
+        <p:txBody>
+          <a:bodyPr xmlns:a="http://schemas.openxmlformats.org/drawingml/2006/main" anchor="ctr"/>
+          <a:lstStyle xmlns:a="http://schemas.openxmlformats.org/drawingml/2006/main"/>
+          <a:p xmlns:a="http://schemas.openxmlformats.org/drawingml/2006/main">
+            <a:pPr>
+              <a:buNone/>
+              <a:defRPr sz="1650" b="1">
+                <a:solidFill>
+                  <a:srgbClr val="FFFDF6"/>
+                </a:solidFill>
+              </a:defRPr>
+            </a:pPr>
+            <a:r>
+              <a:rPr sz="1650" b="1">
+                <a:solidFill>
+                  <a:srgbClr val="FFFDF6"/>
+                </a:solidFill>
+              </a:rPr>
+              <a:t>Complete editorial playbooks</a:t>
+            </a:r>
+          </a:p>
+        </p:txBody>
+      </p:sp>
+      <p:sp>
+        <p:nvSpPr>
+          <p:cNvPr id="17" name="">
+            <a:extLst xmlns:a="http://schemas.openxmlformats.org/drawingml/2006/main">
+              <a:ext uri="{FF2B5EF4-FFF2-40B4-BE49-F238E27FC236}">
+                <a16:creationId xmlns:a16="http://schemas.microsoft.com/office/drawing/2014/main" id="{58EEDBAD-8943-417A-9C9B-AA100B143181}"/>
+              </a:ext>
+            </a:extLst>
+          </p:cNvPr>
+          <p:cNvSpPr>
+            <a:spLocks xmlns:a="http://schemas.openxmlformats.org/drawingml/2006/main" noGrp="1"/>
+          </p:cNvSpPr>
+          <p:nvPr/>
+        </p:nvSpPr>
+        <p:spPr>
+          <a:xfrm xmlns:a="http://schemas.openxmlformats.org/drawingml/2006/main">
+            <a:off x="5695950" y="5334000"/>
+            <a:ext cx="5238750" cy="304800"/>
+          </a:xfrm>
+          <a:prstGeom xmlns:a="http://schemas.openxmlformats.org/drawingml/2006/main" prst="rect">
+            <a:avLst/>
+          </a:prstGeom>
+          <a:noFill xmlns:a="http://schemas.openxmlformats.org/drawingml/2006/main"/>
+          <a:ln xmlns:a="http://schemas.openxmlformats.org/drawingml/2006/main" w="0">
+            <a:noFill/>
+            <a:prstDash val="solid"/>
+          </a:ln>
+        </p:spPr>
+        <p:txBody>
+          <a:bodyPr xmlns:a="http://schemas.openxmlformats.org/drawingml/2006/main" anchor="ctr"/>
+          <a:lstStyle xmlns:a="http://schemas.openxmlformats.org/drawingml/2006/main"/>
+          <a:p xmlns:a="http://schemas.openxmlformats.org/drawingml/2006/main">
+            <a:pPr>
+              <a:buNone/>
+              <a:defRPr sz="1200" b="0">
+                <a:solidFill>
+                  <a:srgbClr val="C9D2EA"/>
+                </a:solidFill>
+              </a:defRPr>
+            </a:pPr>
+            <a:r>
+              <a:rPr sz="1200" b="0">
+                <a:solidFill>
+                  <a:srgbClr val="C9D2EA"/>
+                </a:solidFill>
+              </a:rPr>
+              <a:t>Starts, steps, remixes, media, and provenance.</a:t>
+            </a:r>
+          </a:p>
+        </p:txBody>
+      </p:sp>
+      <p:sp>
+        <p:nvSpPr>
+          <p:cNvPr id="18" name="">
+            <a:extLst xmlns:a="http://schemas.openxmlformats.org/drawingml/2006/main">
+              <a:ext uri="{FF2B5EF4-FFF2-40B4-BE49-F238E27FC236}">
+                <a16:creationId xmlns:a16="http://schemas.microsoft.com/office/drawing/2014/main" id="{36C3DE06-48B4-4471-BC0C-C776C7483B24}"/>
+              </a:ext>
+            </a:extLst>
+          </p:cNvPr>
+          <p:cNvSpPr>
+            <a:spLocks xmlns:a="http://schemas.openxmlformats.org/drawingml/2006/main" noGrp="1"/>
+          </p:cNvSpPr>
+          <p:nvPr/>
+        </p:nvSpPr>
+        <p:spPr>
+          <a:xfrm xmlns:a="http://schemas.openxmlformats.org/drawingml/2006/main">
+            <a:off x="5105400" y="6381750"/>
+            <a:ext cx="1905000" cy="209550"/>
+          </a:xfrm>
+          <a:prstGeom xmlns:a="http://schemas.openxmlformats.org/drawingml/2006/main" prst="rect">
+            <a:avLst/>
+          </a:prstGeom>
+          <a:noFill xmlns:a="http://schemas.openxmlformats.org/drawingml/2006/main"/>
+          <a:ln xmlns:a="http://schemas.openxmlformats.org/drawingml/2006/main" w="0">
+            <a:noFill/>
+            <a:prstDash val="solid"/>
+          </a:ln>
+        </p:spPr>
+        <p:txBody>
+          <a:bodyPr xmlns:a="http://schemas.openxmlformats.org/drawingml/2006/main" anchor="ctr"/>
+          <a:lstStyle xmlns:a="http://schemas.openxmlformats.org/drawingml/2006/main"/>
+          <a:p xmlns:a="http://schemas.openxmlformats.org/drawingml/2006/main">
+            <a:pPr>
+              <a:buNone/>
+              <a:defRPr sz="900" b="1">
+                <a:solidFill>
+                  <a:srgbClr val="FFFDF6"/>
+                </a:solidFill>
+              </a:defRPr>
+            </a:pPr>
+            <a:r>
+              <a:rPr sz="900" b="1">
+                <a:solidFill>
+                  <a:srgbClr val="FFFDF6"/>
+                </a:solidFill>
+              </a:rPr>
+              <a:t>TRYTHIS.FUN</a:t>
+            </a:r>
+          </a:p>
+        </p:txBody>
+      </p:sp>
+      <p:sp>
+        <p:nvSpPr>
+          <p:cNvPr id="19" name="">
+            <a:extLst xmlns:a="http://schemas.openxmlformats.org/drawingml/2006/main">
+              <a:ext uri="{FF2B5EF4-FFF2-40B4-BE49-F238E27FC236}">
+                <a16:creationId xmlns:a16="http://schemas.microsoft.com/office/drawing/2014/main" id="{A82555FF-A304-41CC-A07F-AF66BB16ECE8}"/>
+              </a:ext>
+            </a:extLst>
+          </p:cNvPr>
+          <p:cNvSpPr>
+            <a:spLocks xmlns:a="http://schemas.openxmlformats.org/drawingml/2006/main" noGrp="1"/>
+          </p:cNvSpPr>
+          <p:nvPr/>
+        </p:nvSpPr>
+        <p:spPr>
+          <a:xfrm xmlns:a="http://schemas.openxmlformats.org/drawingml/2006/main">
+            <a:off x="11049000" y="6381750"/>
+            <a:ext cx="457200" cy="209550"/>
+          </a:xfrm>
+          <a:prstGeom xmlns:a="http://schemas.openxmlformats.org/drawingml/2006/main" prst="rect">
+            <a:avLst/>
+          </a:prstGeom>
+          <a:noFill xmlns:a="http://schemas.openxmlformats.org/drawingml/2006/main"/>
+          <a:ln xmlns:a="http://schemas.openxmlformats.org/drawingml/2006/main" w="0">
+            <a:noFill/>
+            <a:prstDash val="solid"/>
+          </a:ln>
+        </p:spPr>
+        <p:txBody>
+          <a:bodyPr xmlns:a="http://schemas.openxmlformats.org/drawingml/2006/main" anchor="ctr"/>
+          <a:lstStyle xmlns:a="http://schemas.openxmlformats.org/drawingml/2006/main"/>
+          <a:p xmlns:a="http://schemas.openxmlformats.org/drawingml/2006/main">
+            <a:pPr>
+              <a:buNone/>
+              <a:defRPr sz="900" b="1">
+                <a:solidFill>
+                  <a:srgbClr val="FFFDF6"/>
+                </a:solidFill>
+              </a:defRPr>
+            </a:pPr>
+            <a:r>
+              <a:rPr sz="900" b="1">
+                <a:solidFill>
+                  <a:srgbClr val="FFFDF6"/>
+                </a:solidFill>
+              </a:rPr>
+              <a:t>06</a:t>
+            </a:r>
+          </a:p>
+        </p:txBody>
+      </p:sp>
+    </p:spTree>
+    <p:extLst>
+      <p:ext uri="{BB962C8B-B14F-4D97-AF65-F5344CB8AC3E}">
+        <p14:creationId xmlns:p14="http://schemas.microsoft.com/office/powerpoint/2010/main" val="264232321"/>
+      </p:ext>
+    </p:extLst>
+  </p:cSld>
+</p:sld>
+</file>
+
+<file path=ppt/slides/slide7.xml><?xml version="1.0" encoding="utf-8"?>
+<p:sld xmlns:p="http://schemas.openxmlformats.org/presentationml/2006/main">
+  <p:cSld>
+    <p:bg>
+      <p:bgPr>
+        <a:solidFill xmlns:a="http://schemas.openxmlformats.org/drawingml/2006/main">
+          <a:srgbClr val="18223B"/>
+        </a:solidFill>
+      </p:bgPr>
+    </p:bg>
+    <p:spTree>
+      <p:nvGrpSpPr>
+        <p:cNvPr id="1" name=""/>
+        <p:cNvGrpSpPr/>
+        <p:nvPr/>
+      </p:nvGrpSpPr>
+      <p:grpSpPr>
+        <a:xfrm xmlns:a="http://schemas.openxmlformats.org/drawingml/2006/main"/>
+      </p:grpSpPr>
+      <p:sp>
+        <p:nvSpPr>
+          <p:cNvPr id="20" name="">
+            <a:extLst xmlns:a="http://schemas.openxmlformats.org/drawingml/2006/main">
+              <a:ext uri="{FF2B5EF4-FFF2-40B4-BE49-F238E27FC236}">
+                <a16:creationId xmlns:a16="http://schemas.microsoft.com/office/drawing/2014/main" id="{E80225A7-3373-4FD5-ABA0-E592DBD5103C}"/>
+              </a:ext>
+            </a:extLst>
+          </p:cNvPr>
+          <p:cNvSpPr>
+            <a:spLocks xmlns:a="http://schemas.openxmlformats.org/drawingml/2006/main" noGrp="1"/>
+          </p:cNvSpPr>
+          <p:nvPr/>
+        </p:nvSpPr>
+        <p:spPr>
+          <a:xfrm xmlns:a="http://schemas.openxmlformats.org/drawingml/2006/main">
+            <a:off x="533400" y="400050"/>
+            <a:ext cx="3962400" cy="6076950"/>
+          </a:xfrm>
+          <a:prstGeom xmlns:a="http://schemas.openxmlformats.org/drawingml/2006/main" prst="roundRect">
+            <a:avLst>
+              <a:gd name="adj" fmla="val 3846"/>
+            </a:avLst>
+          </a:prstGeom>
+          <a:solidFill xmlns:a="http://schemas.openxmlformats.org/drawingml/2006/main">
+            <a:srgbClr val="FFFDF6"/>
+          </a:solidFill>
+          <a:ln xmlns:a="http://schemas.openxmlformats.org/drawingml/2006/main" w="0">
+            <a:solidFill>
+              <a:srgbClr val="FFFDF6"/>
+            </a:solidFill>
+            <a:prstDash val="solid"/>
+          </a:ln>
+        </p:spPr>
+      </p:sp>
+      <p:pic>
+        <p:nvPicPr>
+          <p:cNvPr id="23" name=""/>
+          <p:cNvPicPr>
+            <a:picLocks xmlns:a="http://schemas.openxmlformats.org/drawingml/2006/main" noChangeAspect="1"/>
+          </p:cNvPicPr>
+          <p:nvPr/>
+        </p:nvPicPr>
+        <p:blipFill>
+          <a:blip xmlns:r="http://schemas.openxmlformats.org/officeDocument/2006/relationships" xmlns:a="http://schemas.openxmlformats.org/drawingml/2006/main" r:embed="R601778f048304601"/>
+          <a:stretch xmlns:a="http://schemas.openxmlformats.org/drawingml/2006/main"/>
+        </p:blipFill>
+        <p:spPr>
+          <a:xfrm xmlns:a="http://schemas.openxmlformats.org/drawingml/2006/main">
+            <a:off x="1112211" y="552450"/>
+            <a:ext cx="2804777" cy="5772150"/>
+          </a:xfrm>
+          <a:prstGeom xmlns:a="http://schemas.openxmlformats.org/drawingml/2006/main" prst="rect">
+            <a:avLst/>
+          </a:prstGeom>
+        </p:spPr>
+      </p:pic>
+      <p:sp>
+        <p:nvSpPr>
+          <p:cNvPr id="3" name="">
+            <a:extLst xmlns:a="http://schemas.openxmlformats.org/drawingml/2006/main">
+              <a:ext uri="{FF2B5EF4-FFF2-40B4-BE49-F238E27FC236}">
+                <a16:creationId xmlns:a16="http://schemas.microsoft.com/office/drawing/2014/main" id="{EA7E3670-D82D-4DFC-9ED3-17F9B1DC5692}"/>
+              </a:ext>
+            </a:extLst>
+          </p:cNvPr>
+          <p:cNvSpPr>
+            <a:spLocks xmlns:a="http://schemas.openxmlformats.org/drawingml/2006/main" noGrp="1"/>
+          </p:cNvSpPr>
+          <p:nvPr/>
+        </p:nvSpPr>
+        <p:spPr>
+          <a:xfrm xmlns:a="http://schemas.openxmlformats.org/drawingml/2006/main">
+            <a:off x="5105400" y="685800"/>
+            <a:ext cx="3143250" cy="266700"/>
+          </a:xfrm>
+          <a:prstGeom xmlns:a="http://schemas.openxmlformats.org/drawingml/2006/main" prst="rect">
+            <a:avLst/>
+          </a:prstGeom>
+          <a:noFill xmlns:a="http://schemas.openxmlformats.org/drawingml/2006/main"/>
+          <a:ln xmlns:a="http://schemas.openxmlformats.org/drawingml/2006/main" w="0">
+            <a:noFill/>
+            <a:prstDash val="solid"/>
+          </a:ln>
+        </p:spPr>
+        <p:txBody>
+          <a:bodyPr xmlns:a="http://schemas.openxmlformats.org/drawingml/2006/main" anchor="ctr"/>
+          <a:lstStyle xmlns:a="http://schemas.openxmlformats.org/drawingml/2006/main"/>
+          <a:p xmlns:a="http://schemas.openxmlformats.org/drawingml/2006/main">
+            <a:pPr>
+              <a:buNone/>
+              <a:defRPr sz="1125" b="1">
+                <a:solidFill>
+                  <a:srgbClr val="FFD55A"/>
+                </a:solidFill>
+              </a:defRPr>
+            </a:pPr>
+            <a:r>
+              <a:rPr sz="1125" b="1">
+                <a:solidFill>
+                  <a:srgbClr val="FFD55A"/>
+                </a:solidFill>
+              </a:rPr>
+              <a:t>BUSINESS VIABILITY</a:t>
+            </a:r>
+          </a:p>
+        </p:txBody>
+      </p:sp>
+      <p:sp>
+        <p:nvSpPr>
+          <p:cNvPr id="4" name="">
+            <a:extLst xmlns:a="http://schemas.openxmlformats.org/drawingml/2006/main">
+              <a:ext uri="{FF2B5EF4-FFF2-40B4-BE49-F238E27FC236}">
+                <a16:creationId xmlns:a16="http://schemas.microsoft.com/office/drawing/2014/main" id="{C789A1E6-7230-457D-84EB-2E27241CEBDB}"/>
+              </a:ext>
+            </a:extLst>
+          </p:cNvPr>
+          <p:cNvSpPr>
+            <a:spLocks xmlns:a="http://schemas.openxmlformats.org/drawingml/2006/main" noGrp="1"/>
+          </p:cNvSpPr>
+          <p:nvPr/>
+        </p:nvSpPr>
+        <p:spPr>
+          <a:xfrm xmlns:a="http://schemas.openxmlformats.org/drawingml/2006/main">
+            <a:off x="5067300" y="1066800"/>
+            <a:ext cx="6381750" cy="1200150"/>
+          </a:xfrm>
+          <a:prstGeom xmlns:a="http://schemas.openxmlformats.org/drawingml/2006/main" prst="rect">
+            <a:avLst/>
+          </a:prstGeom>
+          <a:noFill xmlns:a="http://schemas.openxmlformats.org/drawingml/2006/main"/>
+          <a:ln xmlns:a="http://schemas.openxmlformats.org/drawingml/2006/main" w="0">
+            <a:noFill/>
+            <a:prstDash val="solid"/>
+          </a:ln>
+        </p:spPr>
+        <p:txBody>
+          <a:bodyPr xmlns:a="http://schemas.openxmlformats.org/drawingml/2006/main" anchor="ctr"/>
+          <a:lstStyle xmlns:a="http://schemas.openxmlformats.org/drawingml/2006/main"/>
+          <a:p xmlns:a="http://schemas.openxmlformats.org/drawingml/2006/main">
+            <a:pPr>
+              <a:buNone/>
+              <a:defRPr sz="3300" b="1">
+                <a:solidFill>
+                  <a:srgbClr val="FFFDF6"/>
+                </a:solidFill>
+              </a:defRPr>
+            </a:pPr>
+            <a:r>
+              <a:rPr sz="3300" b="1">
+                <a:solidFill>
+                  <a:srgbClr val="FFFDF6"/>
+                </a:solidFill>
+              </a:rPr>
+              <a:t>Low infrastructure.</a:t>
+            </a:r>
+          </a:p>
+          <a:p xmlns:a="http://schemas.openxmlformats.org/drawingml/2006/main">
+            <a:pPr>
+              <a:buNone/>
+              <a:defRPr sz="3300" b="1">
+                <a:solidFill>
+                  <a:srgbClr val="FFFDF6"/>
+                </a:solidFill>
+              </a:defRPr>
+            </a:pPr>
+            <a:r>
+              <a:rPr sz="3300" b="1">
+                <a:solidFill>
+                  <a:srgbClr val="FFFDF6"/>
+                </a:solidFill>
+              </a:rPr>
+              <a:t>Growing content value.</a:t>
+            </a:r>
+          </a:p>
+        </p:txBody>
+      </p:sp>
+      <p:sp>
+        <p:nvSpPr>
+          <p:cNvPr id="5" name="">
+            <a:extLst xmlns:a="http://schemas.openxmlformats.org/drawingml/2006/main">
+              <a:ext uri="{FF2B5EF4-FFF2-40B4-BE49-F238E27FC236}">
+                <a16:creationId xmlns:a16="http://schemas.microsoft.com/office/drawing/2014/main" id="{FF734BFB-7848-4565-9EE4-5F9CE528F392}"/>
+              </a:ext>
+            </a:extLst>
+          </p:cNvPr>
+          <p:cNvSpPr>
+            <a:spLocks xmlns:a="http://schemas.openxmlformats.org/drawingml/2006/main" noGrp="1"/>
+          </p:cNvSpPr>
+          <p:nvPr/>
+        </p:nvSpPr>
+        <p:spPr>
+          <a:xfrm xmlns:a="http://schemas.openxmlformats.org/drawingml/2006/main">
+            <a:off x="5105400" y="2343150"/>
+            <a:ext cx="5905500" cy="723900"/>
+          </a:xfrm>
+          <a:prstGeom xmlns:a="http://schemas.openxmlformats.org/drawingml/2006/main" prst="rect">
+            <a:avLst/>
+          </a:prstGeom>
+          <a:noFill xmlns:a="http://schemas.openxmlformats.org/drawingml/2006/main"/>
+          <a:ln xmlns:a="http://schemas.openxmlformats.org/drawingml/2006/main" w="0">
+            <a:noFill/>
+            <a:prstDash val="solid"/>
+          </a:ln>
+        </p:spPr>
+        <p:txBody>
+          <a:bodyPr xmlns:a="http://schemas.openxmlformats.org/drawingml/2006/main" anchor="ctr"/>
+          <a:lstStyle xmlns:a="http://schemas.openxmlformats.org/drawingml/2006/main"/>
+          <a:p xmlns:a="http://schemas.openxmlformats.org/drawingml/2006/main">
+            <a:pPr>
+              <a:buNone/>
+              <a:defRPr sz="1575" b="0">
+                <a:solidFill>
+                  <a:srgbClr val="C9D2EA"/>
+                </a:solidFill>
+              </a:defRPr>
+            </a:pPr>
+            <a:r>
+              <a:rPr sz="1575" b="0">
+                <a:solidFill>
+                  <a:srgbClr val="C9D2EA"/>
+                </a:solidFill>
+              </a:rPr>
+              <a:t>We can validate willingness to pay before adding payment complexity:</a:t>
+            </a:r>
+          </a:p>
+        </p:txBody>
+      </p:sp>
+      <p:sp>
+        <p:nvSpPr>
+          <p:cNvPr id="6" name="">
+            <a:extLst xmlns:a="http://schemas.openxmlformats.org/drawingml/2006/main">
+              <a:ext uri="{FF2B5EF4-FFF2-40B4-BE49-F238E27FC236}">
+                <a16:creationId xmlns:a16="http://schemas.microsoft.com/office/drawing/2014/main" id="{B8C14E4D-4D23-4D7F-9C1A-FE1DB558F95A}"/>
+              </a:ext>
+            </a:extLst>
+          </p:cNvPr>
+          <p:cNvSpPr>
+            <a:spLocks xmlns:a="http://schemas.openxmlformats.org/drawingml/2006/main" noGrp="1"/>
+          </p:cNvSpPr>
+          <p:nvPr/>
+        </p:nvSpPr>
+        <p:spPr>
+          <a:xfrm xmlns:a="http://schemas.openxmlformats.org/drawingml/2006/main">
+            <a:off x="5105400" y="3305175"/>
+            <a:ext cx="400050" cy="400050"/>
+          </a:xfrm>
+          <a:prstGeom xmlns:a="http://schemas.openxmlformats.org/drawingml/2006/main" prst="ellipse">
+            <a:avLst/>
+          </a:prstGeom>
+          <a:solidFill xmlns:a="http://schemas.openxmlformats.org/drawingml/2006/main">
+            <a:srgbClr val="FFD55A"/>
+          </a:solidFill>
+          <a:ln xmlns:a="http://schemas.openxmlformats.org/drawingml/2006/main" w="19050">
+            <a:solidFill>
+              <a:srgbClr val="18223B"/>
+            </a:solidFill>
+            <a:prstDash val="solid"/>
+          </a:ln>
+        </p:spPr>
+      </p:sp>
+      <p:sp>
+        <p:nvSpPr>
+          <p:cNvPr id="7" name="">
+            <a:extLst xmlns:a="http://schemas.openxmlformats.org/drawingml/2006/main">
+              <a:ext uri="{FF2B5EF4-FFF2-40B4-BE49-F238E27FC236}">
+                <a16:creationId xmlns:a16="http://schemas.microsoft.com/office/drawing/2014/main" id="{D9A289F3-16E1-4D1C-92A2-C02C12300026}"/>
+              </a:ext>
+            </a:extLst>
+          </p:cNvPr>
+          <p:cNvSpPr>
+            <a:spLocks xmlns:a="http://schemas.openxmlformats.org/drawingml/2006/main" noGrp="1"/>
+          </p:cNvSpPr>
+          <p:nvPr/>
+        </p:nvSpPr>
+        <p:spPr>
+          <a:xfrm xmlns:a="http://schemas.openxmlformats.org/drawingml/2006/main">
+            <a:off x="5105400" y="3324225"/>
+            <a:ext cx="400050" cy="323850"/>
+          </a:xfrm>
+          <a:prstGeom xmlns:a="http://schemas.openxmlformats.org/drawingml/2006/main" prst="rect">
+            <a:avLst/>
+          </a:prstGeom>
+          <a:noFill xmlns:a="http://schemas.openxmlformats.org/drawingml/2006/main"/>
+          <a:ln xmlns:a="http://schemas.openxmlformats.org/drawingml/2006/main" w="0">
+            <a:noFill/>
+            <a:prstDash val="solid"/>
+          </a:ln>
+        </p:spPr>
+        <p:txBody>
+          <a:bodyPr xmlns:a="http://schemas.openxmlformats.org/drawingml/2006/main" anchor="ctr"/>
+          <a:lstStyle xmlns:a="http://schemas.openxmlformats.org/drawingml/2006/main"/>
+          <a:p xmlns:a="http://schemas.openxmlformats.org/drawingml/2006/main">
+            <a:pPr>
+              <a:buNone/>
+              <a:defRPr sz="1275" b="1">
+                <a:solidFill>
+                  <a:srgbClr val="18223B"/>
+                </a:solidFill>
+              </a:defRPr>
+            </a:pPr>
+            <a:r>
+              <a:rPr sz="1275" b="1">
+                <a:solidFill>
+                  <a:srgbClr val="18223B"/>
+                </a:solidFill>
+              </a:rPr>
+              <a:t>✓</a:t>
+            </a:r>
+          </a:p>
+        </p:txBody>
+      </p:sp>
+      <p:sp>
+        <p:nvSpPr>
+          <p:cNvPr id="8" name="">
+            <a:extLst xmlns:a="http://schemas.openxmlformats.org/drawingml/2006/main">
+              <a:ext uri="{FF2B5EF4-FFF2-40B4-BE49-F238E27FC236}">
+                <a16:creationId xmlns:a16="http://schemas.microsoft.com/office/drawing/2014/main" id="{14ED3BE8-CA97-4FA1-9E9D-3832306E41F8}"/>
+              </a:ext>
+            </a:extLst>
+          </p:cNvPr>
+          <p:cNvSpPr>
+            <a:spLocks xmlns:a="http://schemas.openxmlformats.org/drawingml/2006/main" noGrp="1"/>
+          </p:cNvSpPr>
+          <p:nvPr/>
+        </p:nvSpPr>
+        <p:spPr>
+          <a:xfrm xmlns:a="http://schemas.openxmlformats.org/drawingml/2006/main">
+            <a:off x="5695950" y="3257550"/>
+            <a:ext cx="5238750" cy="323850"/>
+          </a:xfrm>
+          <a:prstGeom xmlns:a="http://schemas.openxmlformats.org/drawingml/2006/main" prst="rect">
+            <a:avLst/>
+          </a:prstGeom>
+          <a:noFill xmlns:a="http://schemas.openxmlformats.org/drawingml/2006/main"/>
+          <a:ln xmlns:a="http://schemas.openxmlformats.org/drawingml/2006/main" w="0">
+            <a:noFill/>
+            <a:prstDash val="solid"/>
+          </a:ln>
+        </p:spPr>
+        <p:txBody>
+          <a:bodyPr xmlns:a="http://schemas.openxmlformats.org/drawingml/2006/main" anchor="ctr"/>
+          <a:lstStyle xmlns:a="http://schemas.openxmlformats.org/drawingml/2006/main"/>
+          <a:p xmlns:a="http://schemas.openxmlformats.org/drawingml/2006/main">
+            <a:pPr>
+              <a:buNone/>
+              <a:defRPr sz="1650" b="1">
+                <a:solidFill>
+                  <a:srgbClr val="FFFDF6"/>
+                </a:solidFill>
+              </a:defRPr>
+            </a:pPr>
+            <a:r>
+              <a:rPr sz="1650" b="1">
+                <a:solidFill>
+                  <a:srgbClr val="FFFDF6"/>
+                </a:solidFill>
+              </a:rPr>
+              <a:t>Free starter collection</a:t>
+            </a:r>
+          </a:p>
+        </p:txBody>
+      </p:sp>
+      <p:sp>
+        <p:nvSpPr>
+          <p:cNvPr id="9" name="">
+            <a:extLst xmlns:a="http://schemas.openxmlformats.org/drawingml/2006/main">
+              <a:ext uri="{FF2B5EF4-FFF2-40B4-BE49-F238E27FC236}">
+                <a16:creationId xmlns:a16="http://schemas.microsoft.com/office/drawing/2014/main" id="{3CC433F9-F986-4F24-9A1F-95BE266566E9}"/>
+              </a:ext>
+            </a:extLst>
+          </p:cNvPr>
+          <p:cNvSpPr>
+            <a:spLocks xmlns:a="http://schemas.openxmlformats.org/drawingml/2006/main" noGrp="1"/>
+          </p:cNvSpPr>
+          <p:nvPr/>
+        </p:nvSpPr>
+        <p:spPr>
+          <a:xfrm xmlns:a="http://schemas.openxmlformats.org/drawingml/2006/main">
+            <a:off x="5695950" y="3581400"/>
+            <a:ext cx="5238750" cy="304800"/>
+          </a:xfrm>
+          <a:prstGeom xmlns:a="http://schemas.openxmlformats.org/drawingml/2006/main" prst="rect">
+            <a:avLst/>
+          </a:prstGeom>
+          <a:noFill xmlns:a="http://schemas.openxmlformats.org/drawingml/2006/main"/>
+          <a:ln xmlns:a="http://schemas.openxmlformats.org/drawingml/2006/main" w="0">
+            <a:noFill/>
+            <a:prstDash val="solid"/>
+          </a:ln>
+        </p:spPr>
+        <p:txBody>
+          <a:bodyPr xmlns:a="http://schemas.openxmlformats.org/drawingml/2006/main" anchor="ctr"/>
+          <a:lstStyle xmlns:a="http://schemas.openxmlformats.org/drawingml/2006/main"/>
+          <a:p xmlns:a="http://schemas.openxmlformats.org/drawingml/2006/main">
+            <a:pPr>
+              <a:buNone/>
+              <a:defRPr sz="1200" b="0">
+                <a:solidFill>
+                  <a:srgbClr val="C9D2EA"/>
+                </a:solidFill>
+              </a:defRPr>
+            </a:pPr>
+            <a:r>
+              <a:rPr sz="1200" b="0">
+                <a:solidFill>
+                  <a:srgbClr val="C9D2EA"/>
+                </a:solidFill>
+              </a:rPr>
+              <a:t>Prove repeat use through the account-free product.</a:t>
+            </a:r>
+          </a:p>
+        </p:txBody>
+      </p:sp>
+      <p:sp>
+        <p:nvSpPr>
+          <p:cNvPr id="10" name="">
+            <a:extLst xmlns:a="http://schemas.openxmlformats.org/drawingml/2006/main">
+              <a:ext uri="{FF2B5EF4-FFF2-40B4-BE49-F238E27FC236}">
+                <a16:creationId xmlns:a16="http://schemas.microsoft.com/office/drawing/2014/main" id="{BA9F958E-8B37-4BB9-83C1-6EEFC56C7E96}"/>
+              </a:ext>
+            </a:extLst>
+          </p:cNvPr>
+          <p:cNvSpPr>
+            <a:spLocks xmlns:a="http://schemas.openxmlformats.org/drawingml/2006/main" noGrp="1"/>
+          </p:cNvSpPr>
+          <p:nvPr/>
+        </p:nvSpPr>
+        <p:spPr>
+          <a:xfrm xmlns:a="http://schemas.openxmlformats.org/drawingml/2006/main">
+            <a:off x="5105400" y="4181475"/>
+            <a:ext cx="400050" cy="400050"/>
+          </a:xfrm>
+          <a:prstGeom xmlns:a="http://schemas.openxmlformats.org/drawingml/2006/main" prst="ellipse">
+            <a:avLst/>
+          </a:prstGeom>
+          <a:solidFill xmlns:a="http://schemas.openxmlformats.org/drawingml/2006/main">
+            <a:srgbClr val="68D6B1"/>
+          </a:solidFill>
+          <a:ln xmlns:a="http://schemas.openxmlformats.org/drawingml/2006/main" w="19050">
+            <a:solidFill>
+              <a:srgbClr val="18223B"/>
+            </a:solidFill>
+            <a:prstDash val="solid"/>
+          </a:ln>
+        </p:spPr>
+      </p:sp>
+      <p:sp>
+        <p:nvSpPr>
+          <p:cNvPr id="11" name="">
+            <a:extLst xmlns:a="http://schemas.openxmlformats.org/drawingml/2006/main">
+              <a:ext uri="{FF2B5EF4-FFF2-40B4-BE49-F238E27FC236}">
+                <a16:creationId xmlns:a16="http://schemas.microsoft.com/office/drawing/2014/main" id="{82EE2B12-16F9-4FD1-ABE9-B09BF87DCD7E}"/>
+              </a:ext>
+            </a:extLst>
+          </p:cNvPr>
+          <p:cNvSpPr>
+            <a:spLocks xmlns:a="http://schemas.openxmlformats.org/drawingml/2006/main" noGrp="1"/>
+          </p:cNvSpPr>
+          <p:nvPr/>
+        </p:nvSpPr>
+        <p:spPr>
+          <a:xfrm xmlns:a="http://schemas.openxmlformats.org/drawingml/2006/main">
+            <a:off x="5105400" y="4200525"/>
+            <a:ext cx="400050" cy="323850"/>
+          </a:xfrm>
+          <a:prstGeom xmlns:a="http://schemas.openxmlformats.org/drawingml/2006/main" prst="rect">
+            <a:avLst/>
+          </a:prstGeom>
+          <a:noFill xmlns:a="http://schemas.openxmlformats.org/drawingml/2006/main"/>
+          <a:ln xmlns:a="http://schemas.openxmlformats.org/drawingml/2006/main" w="0">
+            <a:noFill/>
+            <a:prstDash val="solid"/>
+          </a:ln>
+        </p:spPr>
+        <p:txBody>
+          <a:bodyPr xmlns:a="http://schemas.openxmlformats.org/drawingml/2006/main" anchor="ctr"/>
+          <a:lstStyle xmlns:a="http://schemas.openxmlformats.org/drawingml/2006/main"/>
+          <a:p xmlns:a="http://schemas.openxmlformats.org/drawingml/2006/main">
+            <a:pPr>
+              <a:buNone/>
+              <a:defRPr sz="1275" b="1">
+                <a:solidFill>
+                  <a:srgbClr val="18223B"/>
+                </a:solidFill>
+              </a:defRPr>
+            </a:pPr>
+            <a:r>
+              <a:rPr sz="1275" b="1">
+                <a:solidFill>
+                  <a:srgbClr val="18223B"/>
+                </a:solidFill>
+              </a:rPr>
+              <a:t>✓</a:t>
+            </a:r>
+          </a:p>
+        </p:txBody>
+      </p:sp>
+      <p:sp>
+        <p:nvSpPr>
+          <p:cNvPr id="12" name="">
+            <a:extLst xmlns:a="http://schemas.openxmlformats.org/drawingml/2006/main">
+              <a:ext uri="{FF2B5EF4-FFF2-40B4-BE49-F238E27FC236}">
+                <a16:creationId xmlns:a16="http://schemas.microsoft.com/office/drawing/2014/main" id="{8B7D8118-8BAD-4F24-8D9B-34ABD1C88A69}"/>
+              </a:ext>
+            </a:extLst>
+          </p:cNvPr>
+          <p:cNvSpPr>
+            <a:spLocks xmlns:a="http://schemas.openxmlformats.org/drawingml/2006/main" noGrp="1"/>
+          </p:cNvSpPr>
+          <p:nvPr/>
+        </p:nvSpPr>
+        <p:spPr>
+          <a:xfrm xmlns:a="http://schemas.openxmlformats.org/drawingml/2006/main">
+            <a:off x="5695950" y="4133850"/>
+            <a:ext cx="5238750" cy="323850"/>
+          </a:xfrm>
+          <a:prstGeom xmlns:a="http://schemas.openxmlformats.org/drawingml/2006/main" prst="rect">
+            <a:avLst/>
+          </a:prstGeom>
+          <a:noFill xmlns:a="http://schemas.openxmlformats.org/drawingml/2006/main"/>
+          <a:ln xmlns:a="http://schemas.openxmlformats.org/drawingml/2006/main" w="0">
+            <a:noFill/>
+            <a:prstDash val="solid"/>
+          </a:ln>
+        </p:spPr>
+        <p:txBody>
+          <a:bodyPr xmlns:a="http://schemas.openxmlformats.org/drawingml/2006/main" anchor="ctr"/>
+          <a:lstStyle xmlns:a="http://schemas.openxmlformats.org/drawingml/2006/main"/>
+          <a:p xmlns:a="http://schemas.openxmlformats.org/drawingml/2006/main">
+            <a:pPr>
+              <a:buNone/>
+              <a:defRPr sz="1650" b="1">
+                <a:solidFill>
+                  <a:srgbClr val="FFFDF6"/>
+                </a:solidFill>
+              </a:defRPr>
+            </a:pPr>
+            <a:r>
+              <a:rPr sz="1650" b="1">
+                <a:solidFill>
+                  <a:srgbClr val="FFFDF6"/>
+                </a:solidFill>
+              </a:rPr>
+              <a:t>One-time family unlock</a:t>
+            </a:r>
+          </a:p>
+        </p:txBody>
+      </p:sp>
+      <p:sp>
+        <p:nvSpPr>
+          <p:cNvPr id="13" name="">
+            <a:extLst xmlns:a="http://schemas.openxmlformats.org/drawingml/2006/main">
+              <a:ext uri="{FF2B5EF4-FFF2-40B4-BE49-F238E27FC236}">
+                <a16:creationId xmlns:a16="http://schemas.microsoft.com/office/drawing/2014/main" id="{0073711F-075D-4FF4-841B-F6FDC487497A}"/>
+              </a:ext>
+            </a:extLst>
+          </p:cNvPr>
+          <p:cNvSpPr>
+            <a:spLocks xmlns:a="http://schemas.openxmlformats.org/drawingml/2006/main" noGrp="1"/>
+          </p:cNvSpPr>
+          <p:nvPr/>
+        </p:nvSpPr>
+        <p:spPr>
+          <a:xfrm xmlns:a="http://schemas.openxmlformats.org/drawingml/2006/main">
+            <a:off x="5695950" y="4457700"/>
+            <a:ext cx="5238750" cy="304800"/>
+          </a:xfrm>
+          <a:prstGeom xmlns:a="http://schemas.openxmlformats.org/drawingml/2006/main" prst="rect">
+            <a:avLst/>
+          </a:prstGeom>
+          <a:noFill xmlns:a="http://schemas.openxmlformats.org/drawingml/2006/main"/>
+          <a:ln xmlns:a="http://schemas.openxmlformats.org/drawingml/2006/main" w="0">
+            <a:noFill/>
+            <a:prstDash val="solid"/>
+          </a:ln>
+        </p:spPr>
+        <p:txBody>
+          <a:bodyPr xmlns:a="http://schemas.openxmlformats.org/drawingml/2006/main" anchor="ctr"/>
+          <a:lstStyle xmlns:a="http://schemas.openxmlformats.org/drawingml/2006/main"/>
+          <a:p xmlns:a="http://schemas.openxmlformats.org/drawingml/2006/main">
+            <a:pPr>
+              <a:buNone/>
+              <a:defRPr sz="1200" b="0">
+                <a:solidFill>
+                  <a:srgbClr val="C9D2EA"/>
+                </a:solidFill>
+              </a:defRPr>
+            </a:pPr>
+            <a:r>
+              <a:rPr sz="1200" b="0">
+                <a:solidFill>
+                  <a:srgbClr val="C9D2EA"/>
+                </a:solidFill>
+              </a:rPr>
+              <a:t>Complete library and offline media—no subscription.</a:t>
+            </a:r>
+          </a:p>
+        </p:txBody>
+      </p:sp>
+      <p:sp>
+        <p:nvSpPr>
+          <p:cNvPr id="14" name="">
+            <a:extLst xmlns:a="http://schemas.openxmlformats.org/drawingml/2006/main">
+              <a:ext uri="{FF2B5EF4-FFF2-40B4-BE49-F238E27FC236}">
+                <a16:creationId xmlns:a16="http://schemas.microsoft.com/office/drawing/2014/main" id="{A4D08C4E-3DE5-4A03-95A3-E75CAA91FD3D}"/>
+              </a:ext>
+            </a:extLst>
+          </p:cNvPr>
+          <p:cNvSpPr>
+            <a:spLocks xmlns:a="http://schemas.openxmlformats.org/drawingml/2006/main" noGrp="1"/>
+          </p:cNvSpPr>
+          <p:nvPr/>
+        </p:nvSpPr>
+        <p:spPr>
+          <a:xfrm xmlns:a="http://schemas.openxmlformats.org/drawingml/2006/main">
+            <a:off x="5105400" y="5057775"/>
+            <a:ext cx="400050" cy="400050"/>
+          </a:xfrm>
+          <a:prstGeom xmlns:a="http://schemas.openxmlformats.org/drawingml/2006/main" prst="ellipse">
+            <a:avLst/>
+          </a:prstGeom>
+          <a:solidFill xmlns:a="http://schemas.openxmlformats.org/drawingml/2006/main">
+            <a:srgbClr val="A98BEA"/>
+          </a:solidFill>
+          <a:ln xmlns:a="http://schemas.openxmlformats.org/drawingml/2006/main" w="19050">
+            <a:solidFill>
+              <a:srgbClr val="18223B"/>
+            </a:solidFill>
+            <a:prstDash val="solid"/>
+          </a:ln>
+        </p:spPr>
+      </p:sp>
+      <p:sp>
+        <p:nvSpPr>
+          <p:cNvPr id="15" name="">
+            <a:extLst xmlns:a="http://schemas.openxmlformats.org/drawingml/2006/main">
+              <a:ext uri="{FF2B5EF4-FFF2-40B4-BE49-F238E27FC236}">
+                <a16:creationId xmlns:a16="http://schemas.microsoft.com/office/drawing/2014/main" id="{D8D27936-1A0A-41EA-A755-BA43AF16C11B}"/>
+              </a:ext>
+            </a:extLst>
+          </p:cNvPr>
+          <p:cNvSpPr>
+            <a:spLocks xmlns:a="http://schemas.openxmlformats.org/drawingml/2006/main" noGrp="1"/>
+          </p:cNvSpPr>
+          <p:nvPr/>
+        </p:nvSpPr>
+        <p:spPr>
+          <a:xfrm xmlns:a="http://schemas.openxmlformats.org/drawingml/2006/main">
+            <a:off x="5105400" y="5076825"/>
+            <a:ext cx="400050" cy="323850"/>
+          </a:xfrm>
+          <a:prstGeom xmlns:a="http://schemas.openxmlformats.org/drawingml/2006/main" prst="rect">
+            <a:avLst/>
+          </a:prstGeom>
+          <a:noFill xmlns:a="http://schemas.openxmlformats.org/drawingml/2006/main"/>
+          <a:ln xmlns:a="http://schemas.openxmlformats.org/drawingml/2006/main" w="0">
+            <a:noFill/>
+            <a:prstDash val="solid"/>
+          </a:ln>
+        </p:spPr>
+        <p:txBody>
+          <a:bodyPr xmlns:a="http://schemas.openxmlformats.org/drawingml/2006/main" anchor="ctr"/>
+          <a:lstStyle xmlns:a="http://schemas.openxmlformats.org/drawingml/2006/main"/>
+          <a:p xmlns:a="http://schemas.openxmlformats.org/drawingml/2006/main">
+            <a:pPr>
+              <a:buNone/>
+              <a:defRPr sz="1275" b="1">
+                <a:solidFill>
+                  <a:srgbClr val="18223B"/>
+                </a:solidFill>
+              </a:defRPr>
+            </a:pPr>
+            <a:r>
+              <a:rPr sz="1275" b="1">
+                <a:solidFill>
+                  <a:srgbClr val="18223B"/>
+                </a:solidFill>
+              </a:rPr>
+              <a:t>✓</a:t>
+            </a:r>
+          </a:p>
+        </p:txBody>
+      </p:sp>
+      <p:sp>
+        <p:nvSpPr>
+          <p:cNvPr id="16" name="">
+            <a:extLst xmlns:a="http://schemas.openxmlformats.org/drawingml/2006/main">
+              <a:ext uri="{FF2B5EF4-FFF2-40B4-BE49-F238E27FC236}">
+                <a16:creationId xmlns:a16="http://schemas.microsoft.com/office/drawing/2014/main" id="{0ACA57C2-83E5-44A3-9B39-B0C08C4954BD}"/>
+              </a:ext>
+            </a:extLst>
+          </p:cNvPr>
+          <p:cNvSpPr>
+            <a:spLocks xmlns:a="http://schemas.openxmlformats.org/drawingml/2006/main" noGrp="1"/>
+          </p:cNvSpPr>
+          <p:nvPr/>
+        </p:nvSpPr>
+        <p:spPr>
+          <a:xfrm xmlns:a="http://schemas.openxmlformats.org/drawingml/2006/main">
+            <a:off x="5695950" y="5010150"/>
+            <a:ext cx="5238750" cy="323850"/>
+          </a:xfrm>
+          <a:prstGeom xmlns:a="http://schemas.openxmlformats.org/drawingml/2006/main" prst="rect">
+            <a:avLst/>
+          </a:prstGeom>
+          <a:noFill xmlns:a="http://schemas.openxmlformats.org/drawingml/2006/main"/>
+          <a:ln xmlns:a="http://schemas.openxmlformats.org/drawingml/2006/main" w="0">
+            <a:noFill/>
+            <a:prstDash val="solid"/>
+          </a:ln>
+        </p:spPr>
+        <p:txBody>
+          <a:bodyPr xmlns:a="http://schemas.openxmlformats.org/drawingml/2006/main" anchor="ctr"/>
+          <a:lstStyle xmlns:a="http://schemas.openxmlformats.org/drawingml/2006/main"/>
+          <a:p xmlns:a="http://schemas.openxmlformats.org/drawingml/2006/main">
+            <a:pPr>
+              <a:buNone/>
+              <a:defRPr sz="1650" b="1">
+                <a:solidFill>
+                  <a:srgbClr val="FFFDF6"/>
+                </a:solidFill>
+              </a:defRPr>
+            </a:pPr>
+            <a:r>
+              <a:rPr sz="1650" b="1">
+                <a:solidFill>
+                  <a:srgbClr val="FFFDF6"/>
+                </a:solidFill>
+              </a:rPr>
+              <a:t>Collection partnerships</a:t>
+            </a:r>
+          </a:p>
+        </p:txBody>
+      </p:sp>
+      <p:sp>
+        <p:nvSpPr>
+          <p:cNvPr id="17" name="">
+            <a:extLst xmlns:a="http://schemas.openxmlformats.org/drawingml/2006/main">
+              <a:ext uri="{FF2B5EF4-FFF2-40B4-BE49-F238E27FC236}">
+                <a16:creationId xmlns:a16="http://schemas.microsoft.com/office/drawing/2014/main" id="{58EEDBAD-8943-417A-9C9B-AA100B143181}"/>
+              </a:ext>
+            </a:extLst>
+          </p:cNvPr>
+          <p:cNvSpPr>
+            <a:spLocks xmlns:a="http://schemas.openxmlformats.org/drawingml/2006/main" noGrp="1"/>
+          </p:cNvSpPr>
+          <p:nvPr/>
+        </p:nvSpPr>
+        <p:spPr>
+          <a:xfrm xmlns:a="http://schemas.openxmlformats.org/drawingml/2006/main">
+            <a:off x="5695950" y="5334000"/>
+            <a:ext cx="5238750" cy="304800"/>
+          </a:xfrm>
+          <a:prstGeom xmlns:a="http://schemas.openxmlformats.org/drawingml/2006/main" prst="rect">
+            <a:avLst/>
+          </a:prstGeom>
+          <a:noFill xmlns:a="http://schemas.openxmlformats.org/drawingml/2006/main"/>
+          <a:ln xmlns:a="http://schemas.openxmlformats.org/drawingml/2006/main" w="0">
+            <a:noFill/>
+            <a:prstDash val="solid"/>
+          </a:ln>
+        </p:spPr>
+        <p:txBody>
+          <a:bodyPr xmlns:a="http://schemas.openxmlformats.org/drawingml/2006/main" anchor="ctr"/>
+          <a:lstStyle xmlns:a="http://schemas.openxmlformats.org/drawingml/2006/main"/>
+          <a:p xmlns:a="http://schemas.openxmlformats.org/drawingml/2006/main">
+            <a:pPr>
+              <a:buNone/>
+              <a:defRPr sz="1200" b="0">
+                <a:solidFill>
+                  <a:srgbClr val="C9D2EA"/>
+                </a:solidFill>
+              </a:defRPr>
+            </a:pPr>
+            <a:r>
+              <a:rPr sz="1200" b="0">
+                <a:solidFill>
+                  <a:srgbClr val="C9D2EA"/>
+                </a:solidFill>
+              </a:rPr>
+              <a:t>Libraries, schools, and cultural organizations.</a:t>
+            </a:r>
+          </a:p>
+        </p:txBody>
+      </p:sp>
+      <p:sp>
+        <p:nvSpPr>
+          <p:cNvPr id="18" name="">
+            <a:extLst xmlns:a="http://schemas.openxmlformats.org/drawingml/2006/main">
+              <a:ext uri="{FF2B5EF4-FFF2-40B4-BE49-F238E27FC236}">
+                <a16:creationId xmlns:a16="http://schemas.microsoft.com/office/drawing/2014/main" id="{36C3DE06-48B4-4471-BC0C-C776C7483B24}"/>
+              </a:ext>
+            </a:extLst>
+          </p:cNvPr>
+          <p:cNvSpPr>
+            <a:spLocks xmlns:a="http://schemas.openxmlformats.org/drawingml/2006/main" noGrp="1"/>
+          </p:cNvSpPr>
+          <p:nvPr/>
+        </p:nvSpPr>
+        <p:spPr>
+          <a:xfrm xmlns:a="http://schemas.openxmlformats.org/drawingml/2006/main">
+            <a:off x="5105400" y="6381750"/>
+            <a:ext cx="1905000" cy="209550"/>
+          </a:xfrm>
+          <a:prstGeom xmlns:a="http://schemas.openxmlformats.org/drawingml/2006/main" prst="rect">
+            <a:avLst/>
+          </a:prstGeom>
+          <a:noFill xmlns:a="http://schemas.openxmlformats.org/drawingml/2006/main"/>
+          <a:ln xmlns:a="http://schemas.openxmlformats.org/drawingml/2006/main" w="0">
+            <a:noFill/>
+            <a:prstDash val="solid"/>
+          </a:ln>
+        </p:spPr>
+        <p:txBody>
+          <a:bodyPr xmlns:a="http://schemas.openxmlformats.org/drawingml/2006/main" anchor="ctr"/>
+          <a:lstStyle xmlns:a="http://schemas.openxmlformats.org/drawingml/2006/main"/>
+          <a:p xmlns:a="http://schemas.openxmlformats.org/drawingml/2006/main">
+            <a:pPr>
+              <a:buNone/>
+              <a:defRPr sz="900" b="1">
+                <a:solidFill>
+                  <a:srgbClr val="FFFDF6"/>
+                </a:solidFill>
+              </a:defRPr>
+            </a:pPr>
+            <a:r>
+              <a:rPr sz="900" b="1">
+                <a:solidFill>
+                  <a:srgbClr val="FFFDF6"/>
+                </a:solidFill>
+              </a:rPr>
+              <a:t>TRYTHIS.FUN</a:t>
+            </a:r>
+          </a:p>
+        </p:txBody>
+      </p:sp>
+      <p:sp>
+        <p:nvSpPr>
+          <p:cNvPr id="19" name="">
+            <a:extLst xmlns:a="http://schemas.openxmlformats.org/drawingml/2006/main">
+              <a:ext uri="{FF2B5EF4-FFF2-40B4-BE49-F238E27FC236}">
+                <a16:creationId xmlns:a16="http://schemas.microsoft.com/office/drawing/2014/main" id="{A82555FF-A304-41CC-A07F-AF66BB16ECE8}"/>
+              </a:ext>
+            </a:extLst>
+          </p:cNvPr>
+          <p:cNvSpPr>
+            <a:spLocks xmlns:a="http://schemas.openxmlformats.org/drawingml/2006/main" noGrp="1"/>
+          </p:cNvSpPr>
+          <p:nvPr/>
+        </p:nvSpPr>
+        <p:spPr>
+          <a:xfrm xmlns:a="http://schemas.openxmlformats.org/drawingml/2006/main">
+            <a:off x="11049000" y="6381750"/>
+            <a:ext cx="457200" cy="209550"/>
+          </a:xfrm>
+          <a:prstGeom xmlns:a="http://schemas.openxmlformats.org/drawingml/2006/main" prst="rect">
+            <a:avLst/>
+          </a:prstGeom>
+          <a:noFill xmlns:a="http://schemas.openxmlformats.org/drawingml/2006/main"/>
+          <a:ln xmlns:a="http://schemas.openxmlformats.org/drawingml/2006/main" w="0">
+            <a:noFill/>
+            <a:prstDash val="solid"/>
+          </a:ln>
+        </p:spPr>
+        <p:txBody>
+          <a:bodyPr xmlns:a="http://schemas.openxmlformats.org/drawingml/2006/main" anchor="ctr"/>
+          <a:lstStyle xmlns:a="http://schemas.openxmlformats.org/drawingml/2006/main"/>
+          <a:p xmlns:a="http://schemas.openxmlformats.org/drawingml/2006/main">
+            <a:pPr>
+              <a:buNone/>
+              <a:defRPr sz="900" b="1">
+                <a:solidFill>
+                  <a:srgbClr val="FFFDF6"/>
+                </a:solidFill>
+              </a:defRPr>
+            </a:pPr>
+            <a:r>
+              <a:rPr sz="900" b="1">
+                <a:solidFill>
+                  <a:srgbClr val="FFFDF6"/>
+                </a:solidFill>
+              </a:rPr>
+              <a:t>07</a:t>
+            </a:r>
+          </a:p>
+        </p:txBody>
+      </p:sp>
+    </p:spTree>
+    <p:extLst>
+      <p:ext uri="{BB962C8B-B14F-4D97-AF65-F5344CB8AC3E}">
+        <p14:creationId xmlns:p14="http://schemas.microsoft.com/office/powerpoint/2010/main" val="264232321"/>
+      </p:ext>
+    </p:extLst>
+  </p:cSld>
+</p:sld>
+</file>
+
+<file path=ppt/slides/slide8.xml><?xml version="1.0" encoding="utf-8"?>
+<p:sld xmlns:p="http://schemas.openxmlformats.org/presentationml/2006/main">
+  <p:cSld>
+    <p:bg>
+      <p:bgPr>
+        <a:solidFill xmlns:a="http://schemas.openxmlformats.org/drawingml/2006/main">
+          <a:srgbClr val="FFFDF6"/>
+        </a:solidFill>
+      </p:bgPr>
+    </p:bg>
+    <p:spTree>
+      <p:nvGrpSpPr>
+        <p:cNvPr id="1" name=""/>
+        <p:cNvGrpSpPr/>
+        <p:nvPr/>
+      </p:nvGrpSpPr>
+      <p:grpSpPr>
+        <a:xfrm xmlns:a="http://schemas.openxmlformats.org/drawingml/2006/main"/>
+      </p:grpSpPr>
+      <p:sp>
+        <p:nvSpPr>
+          <p:cNvPr id="17" name="">
+            <a:extLst xmlns:a="http://schemas.openxmlformats.org/drawingml/2006/main">
+              <a:ext uri="{FF2B5EF4-FFF2-40B4-BE49-F238E27FC236}">
+                <a16:creationId xmlns:a16="http://schemas.microsoft.com/office/drawing/2014/main" id="{96A218B2-0E34-4907-BB8B-1DA8148331D1}"/>
+              </a:ext>
+            </a:extLst>
+          </p:cNvPr>
+          <p:cNvSpPr>
+            <a:spLocks xmlns:a="http://schemas.openxmlformats.org/drawingml/2006/main" noGrp="1"/>
+          </p:cNvSpPr>
+          <p:nvPr/>
+        </p:nvSpPr>
+        <p:spPr>
+          <a:xfrm xmlns:a="http://schemas.openxmlformats.org/drawingml/2006/main">
+            <a:off x="666750" y="457200"/>
+            <a:ext cx="2667000" cy="266700"/>
+          </a:xfrm>
+          <a:prstGeom xmlns:a="http://schemas.openxmlformats.org/drawingml/2006/main" prst="rect">
+            <a:avLst/>
+          </a:prstGeom>
+          <a:noFill xmlns:a="http://schemas.openxmlformats.org/drawingml/2006/main"/>
+          <a:ln xmlns:a="http://schemas.openxmlformats.org/drawingml/2006/main" w="0">
+            <a:noFill/>
+            <a:prstDash val="solid"/>
+          </a:ln>
+        </p:spPr>
+        <p:txBody>
+          <a:bodyPr xmlns:a="http://schemas.openxmlformats.org/drawingml/2006/main" anchor="ctr"/>
+          <a:lstStyle xmlns:a="http://schemas.openxmlformats.org/drawingml/2006/main"/>
+          <a:p xmlns:a="http://schemas.openxmlformats.org/drawingml/2006/main">
+            <a:pPr>
+              <a:buNone/>
+              <a:defRPr sz="1125" b="1">
+                <a:solidFill>
+                  <a:srgbClr val="315BD9"/>
+                </a:solidFill>
+              </a:defRPr>
+            </a:pPr>
+            <a:r>
+              <a:rPr sz="1125" b="1">
+                <a:solidFill>
+                  <a:srgbClr val="315BD9"/>
+                </a:solidFill>
+              </a:rPr>
+              <a:t>SIX-MONTH ROADMAP</a:t>
+            </a:r>
+          </a:p>
+        </p:txBody>
+      </p:sp>
+      <p:sp>
+        <p:nvSpPr>
+          <p:cNvPr id="2" name="">
+            <a:extLst xmlns:a="http://schemas.openxmlformats.org/drawingml/2006/main">
+              <a:ext uri="{FF2B5EF4-FFF2-40B4-BE49-F238E27FC236}">
+                <a16:creationId xmlns:a16="http://schemas.microsoft.com/office/drawing/2014/main" id="{92BCAA88-0D31-4F83-BDD4-AA5274367DBB}"/>
+              </a:ext>
+            </a:extLst>
+          </p:cNvPr>
+          <p:cNvSpPr>
+            <a:spLocks xmlns:a="http://schemas.openxmlformats.org/drawingml/2006/main" noGrp="1"/>
+          </p:cNvSpPr>
+          <p:nvPr/>
+        </p:nvSpPr>
+        <p:spPr>
+          <a:xfrm xmlns:a="http://schemas.openxmlformats.org/drawingml/2006/main">
+            <a:off x="647700" y="838200"/>
+            <a:ext cx="6286500" cy="1200150"/>
+          </a:xfrm>
+          <a:prstGeom xmlns:a="http://schemas.openxmlformats.org/drawingml/2006/main" prst="rect">
+            <a:avLst/>
+          </a:prstGeom>
+          <a:noFill xmlns:a="http://schemas.openxmlformats.org/drawingml/2006/main"/>
+          <a:ln xmlns:a="http://schemas.openxmlformats.org/drawingml/2006/main" w="0">
+            <a:noFill/>
+            <a:prstDash val="solid"/>
+          </a:ln>
+        </p:spPr>
+        <p:txBody>
+          <a:bodyPr xmlns:a="http://schemas.openxmlformats.org/drawingml/2006/main" anchor="ctr"/>
+          <a:lstStyle xmlns:a="http://schemas.openxmlformats.org/drawingml/2006/main"/>
+          <a:p xmlns:a="http://schemas.openxmlformats.org/drawingml/2006/main">
+            <a:pPr>
+              <a:buNone/>
+              <a:defRPr sz="3450" b="1">
+                <a:solidFill>
+                  <a:srgbClr val="18223B"/>
+                </a:solidFill>
+              </a:defRPr>
+            </a:pPr>
+            <a:r>
+              <a:rPr sz="3450" b="1">
+                <a:solidFill>
+                  <a:srgbClr val="18223B"/>
+                </a:solidFill>
+              </a:rPr>
+              <a:t>Prove repetition.</a:t>
+            </a:r>
+          </a:p>
+          <a:p xmlns:a="http://schemas.openxmlformats.org/drawingml/2006/main">
+            <a:pPr>
+              <a:buNone/>
+              <a:defRPr sz="3450" b="1">
+                <a:solidFill>
+                  <a:srgbClr val="18223B"/>
+                </a:solidFill>
+              </a:defRPr>
+            </a:pPr>
+            <a:r>
+              <a:rPr sz="3450" b="1">
+                <a:solidFill>
+                  <a:srgbClr val="18223B"/>
+                </a:solidFill>
+              </a:rPr>
+              <a:t>Then expand the library.</a:t>
+            </a:r>
+          </a:p>
+        </p:txBody>
+      </p:sp>
+      <p:sp>
+        <p:nvSpPr>
+          <p:cNvPr id="3" name="">
+            <a:extLst xmlns:a="http://schemas.openxmlformats.org/drawingml/2006/main">
+              <a:ext uri="{FF2B5EF4-FFF2-40B4-BE49-F238E27FC236}">
+                <a16:creationId xmlns:a16="http://schemas.microsoft.com/office/drawing/2014/main" id="{4D155491-0C99-4C3A-9600-9DFB756A6F79}"/>
+              </a:ext>
+            </a:extLst>
+          </p:cNvPr>
+          <p:cNvSpPr>
+            <a:spLocks xmlns:a="http://schemas.openxmlformats.org/drawingml/2006/main" noGrp="1"/>
+          </p:cNvSpPr>
+          <p:nvPr/>
+        </p:nvSpPr>
+        <p:spPr>
+          <a:xfrm xmlns:a="http://schemas.openxmlformats.org/drawingml/2006/main">
+            <a:off x="685800" y="2076450"/>
+            <a:ext cx="5505450" cy="1047750"/>
+          </a:xfrm>
+          <a:prstGeom xmlns:a="http://schemas.openxmlformats.org/drawingml/2006/main" prst="rect">
+            <a:avLst/>
+          </a:prstGeom>
+          <a:noFill xmlns:a="http://schemas.openxmlformats.org/drawingml/2006/main"/>
+          <a:ln xmlns:a="http://schemas.openxmlformats.org/drawingml/2006/main" w="0">
+            <a:noFill/>
+            <a:prstDash val="solid"/>
+          </a:ln>
+        </p:spPr>
+        <p:txBody>
+          <a:bodyPr xmlns:a="http://schemas.openxmlformats.org/drawingml/2006/main" anchor="ctr"/>
+          <a:lstStyle xmlns:a="http://schemas.openxmlformats.org/drawingml/2006/main"/>
+          <a:p xmlns:a="http://schemas.openxmlformats.org/drawingml/2006/main">
+            <a:pPr>
+              <a:buNone/>
+              <a:defRPr sz="1575" b="0">
+                <a:solidFill>
+                  <a:srgbClr val="68738D"/>
+                </a:solidFill>
+              </a:defRPr>
+            </a:pPr>
+            <a:r>
+              <a:rPr sz="1575" b="0">
+                <a:solidFill>
+                  <a:srgbClr val="68738D"/>
+                </a:solidFill>
+              </a:rPr>
+              <a:t>The next phase turns the working prototype into a measurable, cross-platform family product.</a:t>
+            </a:r>
+          </a:p>
+        </p:txBody>
+      </p:sp>
+      <p:sp>
+        <p:nvSpPr>
+          <p:cNvPr id="4" name="">
+            <a:extLst xmlns:a="http://schemas.openxmlformats.org/drawingml/2006/main">
+              <a:ext uri="{FF2B5EF4-FFF2-40B4-BE49-F238E27FC236}">
+                <a16:creationId xmlns:a16="http://schemas.microsoft.com/office/drawing/2014/main" id="{84E2CA37-4AB3-4343-BC66-F932B71F5D8A}"/>
+              </a:ext>
+            </a:extLst>
+          </p:cNvPr>
+          <p:cNvSpPr>
+            <a:spLocks xmlns:a="http://schemas.openxmlformats.org/drawingml/2006/main" noGrp="1"/>
+          </p:cNvSpPr>
+          <p:nvPr/>
+        </p:nvSpPr>
+        <p:spPr>
+          <a:xfrm xmlns:a="http://schemas.openxmlformats.org/drawingml/2006/main">
+            <a:off x="704850" y="3390900"/>
+            <a:ext cx="514350" cy="514350"/>
+          </a:xfrm>
+          <a:prstGeom xmlns:a="http://schemas.openxmlformats.org/drawingml/2006/main" prst="ellipse">
+            <a:avLst/>
+          </a:prstGeom>
+          <a:solidFill xmlns:a="http://schemas.openxmlformats.org/drawingml/2006/main">
+            <a:srgbClr val="FFD55A"/>
+          </a:solidFill>
+          <a:ln xmlns:a="http://schemas.openxmlformats.org/drawingml/2006/main" w="19050">
+            <a:solidFill>
+              <a:srgbClr val="18223B"/>
+            </a:solidFill>
+            <a:prstDash val="solid"/>
+          </a:ln>
+        </p:spPr>
+      </p:sp>
+      <p:sp>
+        <p:nvSpPr>
+          <p:cNvPr id="5" name="">
+            <a:extLst xmlns:a="http://schemas.openxmlformats.org/drawingml/2006/main">
+              <a:ext uri="{FF2B5EF4-FFF2-40B4-BE49-F238E27FC236}">
+                <a16:creationId xmlns:a16="http://schemas.microsoft.com/office/drawing/2014/main" id="{6FC68DBD-1219-4CD7-AEB8-888FDDAB5BF6}"/>
+              </a:ext>
+            </a:extLst>
+          </p:cNvPr>
+          <p:cNvSpPr>
+            <a:spLocks xmlns:a="http://schemas.openxmlformats.org/drawingml/2006/main" noGrp="1"/>
+          </p:cNvSpPr>
+          <p:nvPr/>
+        </p:nvSpPr>
+        <p:spPr>
+          <a:xfrm xmlns:a="http://schemas.openxmlformats.org/drawingml/2006/main">
+            <a:off x="704850" y="3419475"/>
+            <a:ext cx="514350" cy="438150"/>
+          </a:xfrm>
+          <a:prstGeom xmlns:a="http://schemas.openxmlformats.org/drawingml/2006/main" prst="rect">
+            <a:avLst/>
+          </a:prstGeom>
+          <a:noFill xmlns:a="http://schemas.openxmlformats.org/drawingml/2006/main"/>
+          <a:ln xmlns:a="http://schemas.openxmlformats.org/drawingml/2006/main" w="0">
+            <a:noFill/>
+            <a:prstDash val="solid"/>
+          </a:ln>
+        </p:spPr>
+        <p:txBody>
+          <a:bodyPr xmlns:a="http://schemas.openxmlformats.org/drawingml/2006/main" anchor="ctr"/>
+          <a:lstStyle xmlns:a="http://schemas.openxmlformats.org/drawingml/2006/main"/>
+          <a:p xmlns:a="http://schemas.openxmlformats.org/drawingml/2006/main">
+            <a:pPr>
+              <a:buNone/>
+              <a:defRPr sz="1500" b="1">
+                <a:solidFill>
+                  <a:srgbClr val="18223B"/>
+                </a:solidFill>
+              </a:defRPr>
+            </a:pPr>
+            <a:r>
+              <a:rPr sz="1500" b="1">
+                <a:solidFill>
+                  <a:srgbClr val="18223B"/>
+                </a:solidFill>
+              </a:rPr>
+              <a:t>1</a:t>
+            </a:r>
+          </a:p>
+        </p:txBody>
+      </p:sp>
+      <p:sp>
+        <p:nvSpPr>
+          <p:cNvPr id="6" name="">
+            <a:extLst xmlns:a="http://schemas.openxmlformats.org/drawingml/2006/main">
+              <a:ext uri="{FF2B5EF4-FFF2-40B4-BE49-F238E27FC236}">
+                <a16:creationId xmlns:a16="http://schemas.microsoft.com/office/drawing/2014/main" id="{F2F9D9DA-4818-406D-B38C-BBA9CDA144F0}"/>
+              </a:ext>
+            </a:extLst>
+          </p:cNvPr>
+          <p:cNvSpPr>
+            <a:spLocks xmlns:a="http://schemas.openxmlformats.org/drawingml/2006/main" noGrp="1"/>
+          </p:cNvSpPr>
+          <p:nvPr/>
+        </p:nvSpPr>
+        <p:spPr>
+          <a:xfrm xmlns:a="http://schemas.openxmlformats.org/drawingml/2006/main">
+            <a:off x="1409700" y="3390900"/>
+            <a:ext cx="4248150" cy="514350"/>
+          </a:xfrm>
+          <a:prstGeom xmlns:a="http://schemas.openxmlformats.org/drawingml/2006/main" prst="rect">
+            <a:avLst/>
+          </a:prstGeom>
+          <a:noFill xmlns:a="http://schemas.openxmlformats.org/drawingml/2006/main"/>
+          <a:ln xmlns:a="http://schemas.openxmlformats.org/drawingml/2006/main" w="0">
+            <a:noFill/>
+            <a:prstDash val="solid"/>
+          </a:ln>
+        </p:spPr>
+        <p:txBody>
+          <a:bodyPr xmlns:a="http://schemas.openxmlformats.org/drawingml/2006/main" anchor="ctr"/>
+          <a:lstStyle xmlns:a="http://schemas.openxmlformats.org/drawingml/2006/main"/>
+          <a:p xmlns:a="http://schemas.openxmlformats.org/drawingml/2006/main">
+            <a:pPr>
+              <a:buNone/>
+              <a:defRPr sz="1725" b="1">
+                <a:solidFill>
+                  <a:srgbClr val="18223B"/>
+                </a:solidFill>
+              </a:defRPr>
+            </a:pPr>
+            <a:r>
+              <a:rPr sz="1725" b="1">
+                <a:solidFill>
+                  <a:srgbClr val="18223B"/>
+                </a:solidFill>
+              </a:rPr>
+              <a:t>Measure tried, saved &amp; repeated</a:t>
+            </a:r>
+          </a:p>
+        </p:txBody>
+      </p:sp>
+      <p:sp>
+        <p:nvSpPr>
+          <p:cNvPr id="7" name="">
+            <a:extLst xmlns:a="http://schemas.openxmlformats.org/drawingml/2006/main">
+              <a:ext uri="{FF2B5EF4-FFF2-40B4-BE49-F238E27FC236}">
+                <a16:creationId xmlns:a16="http://schemas.microsoft.com/office/drawing/2014/main" id="{29AEAA16-D832-44D1-934F-2D3DF75B1F8D}"/>
+              </a:ext>
+            </a:extLst>
+          </p:cNvPr>
+          <p:cNvSpPr>
+            <a:spLocks xmlns:a="http://schemas.openxmlformats.org/drawingml/2006/main" noGrp="1"/>
+          </p:cNvSpPr>
+          <p:nvPr/>
+        </p:nvSpPr>
+        <p:spPr>
+          <a:xfrm xmlns:a="http://schemas.openxmlformats.org/drawingml/2006/main">
+            <a:off x="704850" y="4171950"/>
+            <a:ext cx="514350" cy="514350"/>
+          </a:xfrm>
+          <a:prstGeom xmlns:a="http://schemas.openxmlformats.org/drawingml/2006/main" prst="ellipse">
+            <a:avLst/>
+          </a:prstGeom>
+          <a:solidFill xmlns:a="http://schemas.openxmlformats.org/drawingml/2006/main">
+            <a:srgbClr val="68D6B1"/>
+          </a:solidFill>
+          <a:ln xmlns:a="http://schemas.openxmlformats.org/drawingml/2006/main" w="19050">
+            <a:solidFill>
+              <a:srgbClr val="18223B"/>
+            </a:solidFill>
+            <a:prstDash val="solid"/>
+          </a:ln>
+        </p:spPr>
+      </p:sp>
+      <p:sp>
+        <p:nvSpPr>
+          <p:cNvPr id="8" name="">
+            <a:extLst xmlns:a="http://schemas.openxmlformats.org/drawingml/2006/main">
+              <a:ext uri="{FF2B5EF4-FFF2-40B4-BE49-F238E27FC236}">
+                <a16:creationId xmlns:a16="http://schemas.microsoft.com/office/drawing/2014/main" id="{E0C48501-7D69-4358-964C-471A22B0F515}"/>
+              </a:ext>
+            </a:extLst>
+          </p:cNvPr>
+          <p:cNvSpPr>
+            <a:spLocks xmlns:a="http://schemas.openxmlformats.org/drawingml/2006/main" noGrp="1"/>
+          </p:cNvSpPr>
+          <p:nvPr/>
+        </p:nvSpPr>
+        <p:spPr>
+          <a:xfrm xmlns:a="http://schemas.openxmlformats.org/drawingml/2006/main">
+            <a:off x="704850" y="4200525"/>
+            <a:ext cx="514350" cy="438150"/>
+          </a:xfrm>
+          <a:prstGeom xmlns:a="http://schemas.openxmlformats.org/drawingml/2006/main" prst="rect">
+            <a:avLst/>
+          </a:prstGeom>
+          <a:noFill xmlns:a="http://schemas.openxmlformats.org/drawingml/2006/main"/>
+          <a:ln xmlns:a="http://schemas.openxmlformats.org/drawingml/2006/main" w="0">
+            <a:noFill/>
+            <a:prstDash val="solid"/>
+          </a:ln>
+        </p:spPr>
+        <p:txBody>
+          <a:bodyPr xmlns:a="http://schemas.openxmlformats.org/drawingml/2006/main" anchor="ctr"/>
+          <a:lstStyle xmlns:a="http://schemas.openxmlformats.org/drawingml/2006/main"/>
+          <a:p xmlns:a="http://schemas.openxmlformats.org/drawingml/2006/main">
+            <a:pPr>
+              <a:buNone/>
+              <a:defRPr sz="1500" b="1">
+                <a:solidFill>
+                  <a:srgbClr val="18223B"/>
+                </a:solidFill>
+              </a:defRPr>
+            </a:pPr>
+            <a:r>
+              <a:rPr sz="1500" b="1">
+                <a:solidFill>
+                  <a:srgbClr val="18223B"/>
+                </a:solidFill>
+              </a:rPr>
+              <a:t>2</a:t>
+            </a:r>
+          </a:p>
+        </p:txBody>
+      </p:sp>
+      <p:sp>
+        <p:nvSpPr>
+          <p:cNvPr id="9" name="">
+            <a:extLst xmlns:a="http://schemas.openxmlformats.org/drawingml/2006/main">
+              <a:ext uri="{FF2B5EF4-FFF2-40B4-BE49-F238E27FC236}">
+                <a16:creationId xmlns:a16="http://schemas.microsoft.com/office/drawing/2014/main" id="{01C4276C-27B8-4876-AE12-DB5BD85C5EDE}"/>
+              </a:ext>
+            </a:extLst>
+          </p:cNvPr>
+          <p:cNvSpPr>
+            <a:spLocks xmlns:a="http://schemas.openxmlformats.org/drawingml/2006/main" noGrp="1"/>
+          </p:cNvSpPr>
+          <p:nvPr/>
+        </p:nvSpPr>
+        <p:spPr>
+          <a:xfrm xmlns:a="http://schemas.openxmlformats.org/drawingml/2006/main">
+            <a:off x="1409700" y="4171950"/>
+            <a:ext cx="4248150" cy="514350"/>
+          </a:xfrm>
+          <a:prstGeom xmlns:a="http://schemas.openxmlformats.org/drawingml/2006/main" prst="rect">
+            <a:avLst/>
+          </a:prstGeom>
+          <a:noFill xmlns:a="http://schemas.openxmlformats.org/drawingml/2006/main"/>
+          <a:ln xmlns:a="http://schemas.openxmlformats.org/drawingml/2006/main" w="0">
+            <a:noFill/>
+            <a:prstDash val="solid"/>
+          </a:ln>
+        </p:spPr>
+        <p:txBody>
+          <a:bodyPr xmlns:a="http://schemas.openxmlformats.org/drawingml/2006/main" anchor="ctr"/>
+          <a:lstStyle xmlns:a="http://schemas.openxmlformats.org/drawingml/2006/main"/>
+          <a:p xmlns:a="http://schemas.openxmlformats.org/drawingml/2006/main">
+            <a:pPr>
+              <a:buNone/>
+              <a:defRPr sz="1725" b="1">
+                <a:solidFill>
+                  <a:srgbClr val="18223B"/>
+                </a:solidFill>
+              </a:defRPr>
+            </a:pPr>
+            <a:r>
+              <a:rPr sz="1725" b="1">
+                <a:solidFill>
+                  <a:srgbClr val="18223B"/>
+                </a:solidFill>
+              </a:rPr>
+              <a:t>Add reviewed heritage packs</a:t>
+            </a:r>
+          </a:p>
+        </p:txBody>
+      </p:sp>
+      <p:sp>
+        <p:nvSpPr>
+          <p:cNvPr id="10" name="">
+            <a:extLst xmlns:a="http://schemas.openxmlformats.org/drawingml/2006/main">
+              <a:ext uri="{FF2B5EF4-FFF2-40B4-BE49-F238E27FC236}">
+                <a16:creationId xmlns:a16="http://schemas.microsoft.com/office/drawing/2014/main" id="{DE484EEE-E418-43E5-922B-31B838A7AEF9}"/>
+              </a:ext>
+            </a:extLst>
+          </p:cNvPr>
+          <p:cNvSpPr>
+            <a:spLocks xmlns:a="http://schemas.openxmlformats.org/drawingml/2006/main" noGrp="1"/>
+          </p:cNvSpPr>
+          <p:nvPr/>
+        </p:nvSpPr>
+        <p:spPr>
+          <a:xfrm xmlns:a="http://schemas.openxmlformats.org/drawingml/2006/main">
+            <a:off x="704850" y="4953000"/>
+            <a:ext cx="514350" cy="514350"/>
+          </a:xfrm>
+          <a:prstGeom xmlns:a="http://schemas.openxmlformats.org/drawingml/2006/main" prst="ellipse">
+            <a:avLst/>
+          </a:prstGeom>
+          <a:solidFill xmlns:a="http://schemas.openxmlformats.org/drawingml/2006/main">
+            <a:srgbClr val="FF6961"/>
+          </a:solidFill>
+          <a:ln xmlns:a="http://schemas.openxmlformats.org/drawingml/2006/main" w="19050">
+            <a:solidFill>
+              <a:srgbClr val="18223B"/>
+            </a:solidFill>
+            <a:prstDash val="solid"/>
+          </a:ln>
+        </p:spPr>
+      </p:sp>
+      <p:sp>
+        <p:nvSpPr>
+          <p:cNvPr id="11" name="">
+            <a:extLst xmlns:a="http://schemas.openxmlformats.org/drawingml/2006/main">
+              <a:ext uri="{FF2B5EF4-FFF2-40B4-BE49-F238E27FC236}">
+                <a16:creationId xmlns:a16="http://schemas.microsoft.com/office/drawing/2014/main" id="{7C7D0D7A-DC75-40DA-95AF-F67C0C7E4FD9}"/>
+              </a:ext>
+            </a:extLst>
+          </p:cNvPr>
+          <p:cNvSpPr>
+            <a:spLocks xmlns:a="http://schemas.openxmlformats.org/drawingml/2006/main" noGrp="1"/>
+          </p:cNvSpPr>
+          <p:nvPr/>
+        </p:nvSpPr>
+        <p:spPr>
+          <a:xfrm xmlns:a="http://schemas.openxmlformats.org/drawingml/2006/main">
+            <a:off x="704850" y="4981575"/>
+            <a:ext cx="514350" cy="438150"/>
+          </a:xfrm>
+          <a:prstGeom xmlns:a="http://schemas.openxmlformats.org/drawingml/2006/main" prst="rect">
+            <a:avLst/>
+          </a:prstGeom>
+          <a:noFill xmlns:a="http://schemas.openxmlformats.org/drawingml/2006/main"/>
+          <a:ln xmlns:a="http://schemas.openxmlformats.org/drawingml/2006/main" w="0">
+            <a:noFill/>
+            <a:prstDash val="solid"/>
+          </a:ln>
+        </p:spPr>
+        <p:txBody>
+          <a:bodyPr xmlns:a="http://schemas.openxmlformats.org/drawingml/2006/main" anchor="ctr"/>
+          <a:lstStyle xmlns:a="http://schemas.openxmlformats.org/drawingml/2006/main"/>
+          <a:p xmlns:a="http://schemas.openxmlformats.org/drawingml/2006/main">
+            <a:pPr>
+              <a:buNone/>
+              <a:defRPr sz="1500" b="1">
+                <a:solidFill>
+                  <a:srgbClr val="18223B"/>
+                </a:solidFill>
+              </a:defRPr>
+            </a:pPr>
+            <a:r>
+              <a:rPr sz="1500" b="1">
+                <a:solidFill>
+                  <a:srgbClr val="18223B"/>
+                </a:solidFill>
+              </a:rPr>
+              <a:t>3</a:t>
+            </a:r>
+          </a:p>
+        </p:txBody>
+      </p:sp>
+      <p:sp>
+        <p:nvSpPr>
+          <p:cNvPr id="12" name="">
+            <a:extLst xmlns:a="http://schemas.openxmlformats.org/drawingml/2006/main">
+              <a:ext uri="{FF2B5EF4-FFF2-40B4-BE49-F238E27FC236}">
+                <a16:creationId xmlns:a16="http://schemas.microsoft.com/office/drawing/2014/main" id="{888C6082-3920-417B-8BAD-DAB6DB588F9C}"/>
+              </a:ext>
+            </a:extLst>
+          </p:cNvPr>
+          <p:cNvSpPr>
+            <a:spLocks xmlns:a="http://schemas.openxmlformats.org/drawingml/2006/main" noGrp="1"/>
+          </p:cNvSpPr>
+          <p:nvPr/>
+        </p:nvSpPr>
+        <p:spPr>
+          <a:xfrm xmlns:a="http://schemas.openxmlformats.org/drawingml/2006/main">
+            <a:off x="1409700" y="4953000"/>
+            <a:ext cx="4248150" cy="514350"/>
+          </a:xfrm>
+          <a:prstGeom xmlns:a="http://schemas.openxmlformats.org/drawingml/2006/main" prst="rect">
+            <a:avLst/>
+          </a:prstGeom>
+          <a:noFill xmlns:a="http://schemas.openxmlformats.org/drawingml/2006/main"/>
+          <a:ln xmlns:a="http://schemas.openxmlformats.org/drawingml/2006/main" w="0">
+            <a:noFill/>
+            <a:prstDash val="solid"/>
+          </a:ln>
+        </p:spPr>
+        <p:txBody>
+          <a:bodyPr xmlns:a="http://schemas.openxmlformats.org/drawingml/2006/main" anchor="ctr"/>
+          <a:lstStyle xmlns:a="http://schemas.openxmlformats.org/drawingml/2006/main"/>
+          <a:p xmlns:a="http://schemas.openxmlformats.org/drawingml/2006/main">
+            <a:pPr>
+              <a:buNone/>
+              <a:defRPr sz="1725" b="1">
+                <a:solidFill>
+                  <a:srgbClr val="18223B"/>
+                </a:solidFill>
+              </a:defRPr>
+            </a:pPr>
+            <a:r>
+              <a:rPr sz="1725" b="1">
+                <a:solidFill>
+                  <a:srgbClr val="18223B"/>
+                </a:solidFill>
+              </a:rPr>
+              <a:t>Launch iOS + Android stores</a:t>
+            </a:r>
+          </a:p>
+        </p:txBody>
+      </p:sp>
+      <p:sp>
+        <p:nvSpPr>
+          <p:cNvPr id="13" name="">
+            <a:extLst xmlns:a="http://schemas.openxmlformats.org/drawingml/2006/main">
+              <a:ext uri="{FF2B5EF4-FFF2-40B4-BE49-F238E27FC236}">
+                <a16:creationId xmlns:a16="http://schemas.microsoft.com/office/drawing/2014/main" id="{774F2CC4-39D5-4970-86EE-2A15514C80B2}"/>
+              </a:ext>
+            </a:extLst>
+          </p:cNvPr>
+          <p:cNvSpPr>
+            <a:spLocks xmlns:a="http://schemas.openxmlformats.org/drawingml/2006/main" noGrp="1"/>
+          </p:cNvSpPr>
+          <p:nvPr/>
+        </p:nvSpPr>
+        <p:spPr>
+          <a:xfrm xmlns:a="http://schemas.openxmlformats.org/drawingml/2006/main">
+            <a:off x="7048500" y="342900"/>
+            <a:ext cx="4000500" cy="6057900"/>
+          </a:xfrm>
+          <a:prstGeom xmlns:a="http://schemas.openxmlformats.org/drawingml/2006/main" prst="roundRect">
+            <a:avLst>
+              <a:gd name="adj" fmla="val 3810"/>
+            </a:avLst>
+          </a:prstGeom>
+          <a:solidFill xmlns:a="http://schemas.openxmlformats.org/drawingml/2006/main">
+            <a:srgbClr val="315BD9"/>
+          </a:solidFill>
+          <a:ln xmlns:a="http://schemas.openxmlformats.org/drawingml/2006/main" w="38100">
+            <a:solidFill>
+              <a:srgbClr val="18223B"/>
+            </a:solidFill>
+            <a:prstDash val="solid"/>
+          </a:ln>
+        </p:spPr>
+      </p:sp>
+      <p:pic>
+        <p:nvPicPr>
+          <p:cNvPr id="32" name=""/>
+          <p:cNvPicPr>
+            <a:picLocks xmlns:a="http://schemas.openxmlformats.org/drawingml/2006/main" noChangeAspect="1"/>
+          </p:cNvPicPr>
+          <p:nvPr/>
+        </p:nvPicPr>
+        <p:blipFill>
+          <a:blip xmlns:r="http://schemas.openxmlformats.org/officeDocument/2006/relationships" xmlns:a="http://schemas.openxmlformats.org/drawingml/2006/main" r:embed="R09860d301b0b4d6c"/>
+          <a:stretch xmlns:a="http://schemas.openxmlformats.org/drawingml/2006/main"/>
+        </p:blipFill>
+        <p:spPr>
+          <a:xfrm xmlns:a="http://schemas.openxmlformats.org/drawingml/2006/main">
+            <a:off x="7723867" y="533400"/>
+            <a:ext cx="2649767" cy="5676900"/>
+          </a:xfrm>
+          <a:prstGeom xmlns:a="http://schemas.openxmlformats.org/drawingml/2006/main" prst="rect">
+            <a:avLst/>
+          </a:prstGeom>
+        </p:spPr>
+      </p:pic>
+      <p:sp>
+        <p:nvSpPr>
+          <p:cNvPr id="15" name="">
+            <a:extLst xmlns:a="http://schemas.openxmlformats.org/drawingml/2006/main">
+              <a:ext uri="{FF2B5EF4-FFF2-40B4-BE49-F238E27FC236}">
+                <a16:creationId xmlns:a16="http://schemas.microsoft.com/office/drawing/2014/main" id="{61B6006D-CA3D-42B1-8548-951AB842D860}"/>
+              </a:ext>
+            </a:extLst>
+          </p:cNvPr>
+          <p:cNvSpPr>
+            <a:spLocks xmlns:a="http://schemas.openxmlformats.org/drawingml/2006/main" noGrp="1"/>
+          </p:cNvSpPr>
+          <p:nvPr/>
+        </p:nvSpPr>
+        <p:spPr>
+          <a:xfrm xmlns:a="http://schemas.openxmlformats.org/drawingml/2006/main">
+            <a:off x="666750" y="6381750"/>
+            <a:ext cx="1905000" cy="209550"/>
+          </a:xfrm>
+          <a:prstGeom xmlns:a="http://schemas.openxmlformats.org/drawingml/2006/main" prst="rect">
+            <a:avLst/>
+          </a:prstGeom>
+          <a:noFill xmlns:a="http://schemas.openxmlformats.org/drawingml/2006/main"/>
+          <a:ln xmlns:a="http://schemas.openxmlformats.org/drawingml/2006/main" w="0">
+            <a:noFill/>
+            <a:prstDash val="solid"/>
+          </a:ln>
+        </p:spPr>
+        <p:txBody>
+          <a:bodyPr xmlns:a="http://schemas.openxmlformats.org/drawingml/2006/main" anchor="ctr"/>
+          <a:lstStyle xmlns:a="http://schemas.openxmlformats.org/drawingml/2006/main"/>
+          <a:p xmlns:a="http://schemas.openxmlformats.org/drawingml/2006/main">
+            <a:pPr>
+              <a:buNone/>
+              <a:defRPr sz="900" b="1">
+                <a:solidFill>
+                  <a:srgbClr val="68738D"/>
+                </a:solidFill>
+              </a:defRPr>
+            </a:pPr>
+            <a:r>
+              <a:rPr sz="900" b="1">
+                <a:solidFill>
+                  <a:srgbClr val="68738D"/>
+                </a:solidFill>
+              </a:rPr>
+              <a:t>TRYTHIS.FUN</a:t>
+            </a:r>
+          </a:p>
+        </p:txBody>
+      </p:sp>
+      <p:sp>
+        <p:nvSpPr>
+          <p:cNvPr id="16" name="">
+            <a:extLst xmlns:a="http://schemas.openxmlformats.org/drawingml/2006/main">
+              <a:ext uri="{FF2B5EF4-FFF2-40B4-BE49-F238E27FC236}">
+                <a16:creationId xmlns:a16="http://schemas.microsoft.com/office/drawing/2014/main" id="{E2BD911D-0681-44E1-BAB6-BFF12F856D1C}"/>
+              </a:ext>
+            </a:extLst>
+          </p:cNvPr>
+          <p:cNvSpPr>
+            <a:spLocks xmlns:a="http://schemas.openxmlformats.org/drawingml/2006/main" noGrp="1"/>
+          </p:cNvSpPr>
+          <p:nvPr/>
+        </p:nvSpPr>
+        <p:spPr>
+          <a:xfrm xmlns:a="http://schemas.openxmlformats.org/drawingml/2006/main">
+            <a:off x="11049000" y="6381750"/>
+            <a:ext cx="457200" cy="209550"/>
+          </a:xfrm>
+          <a:prstGeom xmlns:a="http://schemas.openxmlformats.org/drawingml/2006/main" prst="rect">
+            <a:avLst/>
+          </a:prstGeom>
+          <a:noFill xmlns:a="http://schemas.openxmlformats.org/drawingml/2006/main"/>
+          <a:ln xmlns:a="http://schemas.openxmlformats.org/drawingml/2006/main" w="0">
+            <a:noFill/>
+            <a:prstDash val="solid"/>
+          </a:ln>
+        </p:spPr>
+        <p:txBody>
+          <a:bodyPr xmlns:a="http://schemas.openxmlformats.org/drawingml/2006/main" anchor="ctr"/>
+          <a:lstStyle xmlns:a="http://schemas.openxmlformats.org/drawingml/2006/main"/>
+          <a:p xmlns:a="http://schemas.openxmlformats.org/drawingml/2006/main">
+            <a:pPr>
+              <a:buNone/>
+              <a:defRPr sz="900" b="1">
+                <a:solidFill>
+                  <a:srgbClr val="68738D"/>
+                </a:solidFill>
+              </a:defRPr>
+            </a:pPr>
+            <a:r>
+              <a:rPr sz="900" b="1">
+                <a:solidFill>
+                  <a:srgbClr val="68738D"/>
+                </a:solidFill>
+              </a:rPr>
+              <a:t>08</a:t>
+            </a:r>
+          </a:p>
+        </p:txBody>
+      </p:sp>
+    </p:spTree>
+    <p:extLst>
+      <p:ext uri="{BB962C8B-B14F-4D97-AF65-F5344CB8AC3E}">
+        <p14:creationId xmlns:p14="http://schemas.microsoft.com/office/powerpoint/2010/main" val="1189919713"/>
+      </p:ext>
+    </p:extLst>
+  </p:cSld>
+</p:sld>
+</file>
+
+<file path=ppt/slides/slide9.xml><?xml version="1.0" encoding="utf-8"?>
 <p:sld xmlns:p="http://schemas.openxmlformats.org/presentationml/2006/main">
   <p:cSld>
     <p:bg>
@@ -4635,6 +8430,7 @@
           <a:lstStyle xmlns:a="http://schemas.openxmlformats.org/drawingml/2006/main"/>
           <a:p xmlns:a="http://schemas.openxmlformats.org/drawingml/2006/main">
             <a:pPr>
+              <a:buNone/>
               <a:defRPr sz="1125" b="1">
                 <a:solidFill>
                   <a:srgbClr val="315BD9"/>
@@ -4647,7 +8443,7 @@
                   <a:srgbClr val="315BD9"/>
                 </a:solidFill>
               </a:rPr>
-              <a:t>OUR GOAL</a:t>
+              <a:t>THE OUTCOME</a:t>
             </a:r>
           </a:p>
         </p:txBody>
@@ -4685,6 +8481,7 @@
           <a:lstStyle xmlns:a="http://schemas.openxmlformats.org/drawingml/2006/main"/>
           <a:p xmlns:a="http://schemas.openxmlformats.org/drawingml/2006/main">
             <a:pPr>
+              <a:buNone/>
               <a:defRPr sz="3900" b="1">
                 <a:solidFill>
                   <a:srgbClr val="18223B"/>
@@ -4697,11 +8494,12 @@
                   <a:srgbClr val="18223B"/>
                 </a:solidFill>
               </a:rPr>
-              <a:t>Turn five spare minutes</a:t>
-            </a:r>
-          </a:p>
-          <a:p xmlns:a="http://schemas.openxmlformats.org/drawingml/2006/main">
-            <a:pPr>
+              <a:t>Preserve what families know.</a:t>
+            </a:r>
+          </a:p>
+          <a:p xmlns:a="http://schemas.openxmlformats.org/drawingml/2006/main">
+            <a:pPr>
+              <a:buNone/>
               <a:defRPr sz="3900" b="1">
                 <a:solidFill>
                   <a:srgbClr val="18223B"/>
@@ -4714,7 +8512,7 @@
                   <a:srgbClr val="18223B"/>
                 </a:solidFill>
               </a:rPr>
-              <a:t>into a shared memory.</a:t>
+              <a:t>Make the next laugh easier.</a:t>
             </a:r>
           </a:p>
         </p:txBody>
@@ -4752,6 +8550,7 @@
           <a:lstStyle xmlns:a="http://schemas.openxmlformats.org/drawingml/2006/main"/>
           <a:p xmlns:a="http://schemas.openxmlformats.org/drawingml/2006/main">
             <a:pPr>
+              <a:buNone/>
               <a:defRPr sz="1650" b="0">
                 <a:solidFill>
                   <a:srgbClr val="68738D"/>
@@ -4764,7 +8563,7 @@
                   <a:srgbClr val="68738D"/>
                 </a:solidFill>
               </a:rPr>
-              <a:t>Try This helps families spend less time choosing — and more time laughing, making, moving, talking, and being together.</a:t>
+              <a:t>Try This Fun turns scattered ideas and fading family traditions into clear, playable moments—on the web today, and across iOS and Android next.</a:t>
             </a:r>
           </a:p>
         </p:txBody>
@@ -4837,6 +8636,7 @@
           <a:lstStyle xmlns:a="http://schemas.openxmlformats.org/drawingml/2006/main"/>
           <a:p xmlns:a="http://schemas.openxmlformats.org/drawingml/2006/main">
             <a:pPr>
+              <a:buNone/>
               <a:defRPr sz="2025" b="1">
                 <a:solidFill>
                   <a:srgbClr val="18223B"/>
@@ -4957,6 +8757,7 @@
           <a:lstStyle xmlns:a="http://schemas.openxmlformats.org/drawingml/2006/main"/>
           <a:p xmlns:a="http://schemas.openxmlformats.org/drawingml/2006/main">
             <a:pPr>
+              <a:buNone/>
               <a:defRPr sz="4050" b="1">
                 <a:solidFill>
                   <a:srgbClr val="18223B"/>
@@ -5007,6 +8808,7 @@
           <a:lstStyle xmlns:a="http://schemas.openxmlformats.org/drawingml/2006/main"/>
           <a:p xmlns:a="http://schemas.openxmlformats.org/drawingml/2006/main">
             <a:pPr>
+              <a:buNone/>
               <a:defRPr sz="2025" b="1">
                 <a:solidFill>
                   <a:srgbClr val="18223B"/>
@@ -5057,6 +8859,7 @@
           <a:lstStyle xmlns:a="http://schemas.openxmlformats.org/drawingml/2006/main"/>
           <a:p xmlns:a="http://schemas.openxmlformats.org/drawingml/2006/main">
             <a:pPr>
+              <a:buNone/>
               <a:defRPr sz="1125" b="1">
                 <a:solidFill>
                   <a:srgbClr val="18223B"/>
@@ -5107,6 +8910,7 @@
           <a:lstStyle xmlns:a="http://schemas.openxmlformats.org/drawingml/2006/main"/>
           <a:p xmlns:a="http://schemas.openxmlformats.org/drawingml/2006/main">
             <a:pPr>
+              <a:buNone/>
               <a:defRPr sz="1050" b="0">
                 <a:solidFill>
                   <a:srgbClr val="68738D"/>
@@ -5119,7 +8923,7 @@
                   <a:srgbClr val="68738D"/>
                 </a:solidFill>
               </a:rPr>
-              <a:t>Thank you</a:t>
+              <a:t>Play it now</a:t>
             </a:r>
           </a:p>
         </p:txBody>

</xml_diff>